<commit_message>
Align slide ablation wording with script
</commit_message>
<xml_diff>
--- a/deliverables/proposal_2026_06_03/PromoMind_proposal_slides_en.pptx
+++ b/deliverables/proposal_2026_06_03/PromoMind_proposal_slides_en.pptx
@@ -2,22 +2,22 @@
 <file path=ppt/presentation.xml><?xml version="1.0" encoding="utf-8"?>
 <p:presentation xmlns:p="http://schemas.openxmlformats.org/presentationml/2006/main">
   <p:sldMasterIdLst>
-    <p:sldMasterId xmlns:r="http://schemas.openxmlformats.org/officeDocument/2006/relationships" id="2147483648" r:id="R1a81753c595b4d7a"/>
+    <p:sldMasterId xmlns:r="http://schemas.openxmlformats.org/officeDocument/2006/relationships" id="2147483648" r:id="Rc7c47fcb67db4682"/>
   </p:sldMasterIdLst>
   <p:notesMasterIdLst>
-    <p:notesMasterId xmlns:r="http://schemas.openxmlformats.org/officeDocument/2006/relationships" r:id="R76d241b67d6740d1"/>
+    <p:notesMasterId xmlns:r="http://schemas.openxmlformats.org/officeDocument/2006/relationships" r:id="R3573175aa10d4ae5"/>
   </p:notesMasterIdLst>
   <p:sldIdLst>
-    <p:sldId xmlns:r="http://schemas.openxmlformats.org/officeDocument/2006/relationships" id="256" r:id="R130380ad2ed74dab"/>
-    <p:sldId xmlns:r="http://schemas.openxmlformats.org/officeDocument/2006/relationships" id="257" r:id="Ra13fb9900e7e49d3"/>
-    <p:sldId xmlns:r="http://schemas.openxmlformats.org/officeDocument/2006/relationships" id="258" r:id="R130e0aa151e145e9"/>
-    <p:sldId xmlns:r="http://schemas.openxmlformats.org/officeDocument/2006/relationships" id="259" r:id="Rcc96af1fc4b6498d"/>
-    <p:sldId xmlns:r="http://schemas.openxmlformats.org/officeDocument/2006/relationships" id="260" r:id="R3764f547e8ac4386"/>
-    <p:sldId xmlns:r="http://schemas.openxmlformats.org/officeDocument/2006/relationships" id="261" r:id="R85fc071bbcfa4d29"/>
-    <p:sldId xmlns:r="http://schemas.openxmlformats.org/officeDocument/2006/relationships" id="262" r:id="R75c25d7de86b48f9"/>
-    <p:sldId xmlns:r="http://schemas.openxmlformats.org/officeDocument/2006/relationships" id="263" r:id="Rfa81bf8144754b73"/>
-    <p:sldId xmlns:r="http://schemas.openxmlformats.org/officeDocument/2006/relationships" id="264" r:id="R846f4a41cfeb47e4"/>
-    <p:sldId xmlns:r="http://schemas.openxmlformats.org/officeDocument/2006/relationships" id="265" r:id="R9eb8d6cf95194d25"/>
+    <p:sldId xmlns:r="http://schemas.openxmlformats.org/officeDocument/2006/relationships" id="256" r:id="R890d636d798448d4"/>
+    <p:sldId xmlns:r="http://schemas.openxmlformats.org/officeDocument/2006/relationships" id="257" r:id="R1df7e4370ed64182"/>
+    <p:sldId xmlns:r="http://schemas.openxmlformats.org/officeDocument/2006/relationships" id="258" r:id="R734efbd93d0b4ba0"/>
+    <p:sldId xmlns:r="http://schemas.openxmlformats.org/officeDocument/2006/relationships" id="259" r:id="Rda984c929fb74a7a"/>
+    <p:sldId xmlns:r="http://schemas.openxmlformats.org/officeDocument/2006/relationships" id="260" r:id="R21a053bc75774dfa"/>
+    <p:sldId xmlns:r="http://schemas.openxmlformats.org/officeDocument/2006/relationships" id="261" r:id="Re90847331cab4fd9"/>
+    <p:sldId xmlns:r="http://schemas.openxmlformats.org/officeDocument/2006/relationships" id="262" r:id="R93cc8934b0274b1f"/>
+    <p:sldId xmlns:r="http://schemas.openxmlformats.org/officeDocument/2006/relationships" id="263" r:id="R82637aa6dfb845d6"/>
+    <p:sldId xmlns:r="http://schemas.openxmlformats.org/officeDocument/2006/relationships" id="264" r:id="R9cb7725056aa457b"/>
+    <p:sldId xmlns:r="http://schemas.openxmlformats.org/officeDocument/2006/relationships" id="265" r:id="Rfb8c505698774ff6"/>
   </p:sldIdLst>
   <p:sldSz cx="12192000" cy="6858000"/>
   <p:notesSz cx="6858000" cy="9144000"/>
@@ -1158,7 +1158,7 @@
   </p:cSld>
   <p:clrMap bg1="lt1" tx1="dk1" bg2="lt2" tx2="dk2" accent1="accent1" accent2="accent2" accent3="accent3" accent4="accent4" accent5="accent5" accent6="accent6" hlink="hlink" folHlink="folHlink"/>
   <p:sldLayoutIdLst>
-    <p:sldLayoutId xmlns:r="http://schemas.openxmlformats.org/officeDocument/2006/relationships" id="2147483649" r:id="Rf7e2ad55b6e14dec"/>
+    <p:sldLayoutId xmlns:r="http://schemas.openxmlformats.org/officeDocument/2006/relationships" id="2147483649" r:id="Refc94faac2a54fca"/>
   </p:sldLayoutIdLst>
   <p:txStyles>
     <p:titleStyle>
@@ -1656,7 +1656,7 @@
           <p:cNvPr id="1" name="">
             <a:extLst xmlns:a="http://schemas.openxmlformats.org/drawingml/2006/main">
               <a:ext uri="{FF2B5EF4-FFF2-40B4-BE49-F238E27FC236}">
-                <a16:creationId xmlns:a16="http://schemas.microsoft.com/office/drawing/2014/main" id="{47CA29FE-4E68-476E-A557-10D7F2CC8731}"/>
+                <a16:creationId xmlns:a16="http://schemas.microsoft.com/office/drawing/2014/main" id="{6D3B8632-1E03-4309-8E12-8D0FD962C649}"/>
               </a:ext>
             </a:extLst>
           </p:cNvPr>
@@ -1691,7 +1691,7 @@
           <p:cNvPr id="2" name="">
             <a:extLst xmlns:a="http://schemas.openxmlformats.org/drawingml/2006/main">
               <a:ext uri="{FF2B5EF4-FFF2-40B4-BE49-F238E27FC236}">
-                <a16:creationId xmlns:a16="http://schemas.microsoft.com/office/drawing/2014/main" id="{6B76B2CE-1EA6-46B3-8870-A08C45BDDAD3}"/>
+                <a16:creationId xmlns:a16="http://schemas.microsoft.com/office/drawing/2014/main" id="{13557F13-7A98-4509-85B2-B50DFFCBAD1E}"/>
               </a:ext>
             </a:extLst>
           </p:cNvPr>
@@ -1726,7 +1726,7 @@
           <p:cNvPr id="3" name="">
             <a:extLst xmlns:a="http://schemas.openxmlformats.org/drawingml/2006/main">
               <a:ext uri="{FF2B5EF4-FFF2-40B4-BE49-F238E27FC236}">
-                <a16:creationId xmlns:a16="http://schemas.microsoft.com/office/drawing/2014/main" id="{BFF4C22A-78DD-447D-A956-6A142B9B47A2}"/>
+                <a16:creationId xmlns:a16="http://schemas.microsoft.com/office/drawing/2014/main" id="{44DA2464-D9BD-4C52-AD85-3259991CE073}"/>
               </a:ext>
             </a:extLst>
           </p:cNvPr>
@@ -1759,7 +1759,7 @@
           <p:cNvPr id="4" name="">
             <a:extLst xmlns:a="http://schemas.openxmlformats.org/drawingml/2006/main">
               <a:ext uri="{FF2B5EF4-FFF2-40B4-BE49-F238E27FC236}">
-                <a16:creationId xmlns:a16="http://schemas.microsoft.com/office/drawing/2014/main" id="{C023CD40-FAC7-410E-AF86-F7178ABC564E}"/>
+                <a16:creationId xmlns:a16="http://schemas.microsoft.com/office/drawing/2014/main" id="{5BC05CE4-9B75-423C-A8AE-0003D00AB8EB}"/>
               </a:ext>
             </a:extLst>
           </p:cNvPr>
@@ -1823,7 +1823,7 @@
           <p:cNvPr id="5" name="">
             <a:extLst xmlns:a="http://schemas.openxmlformats.org/drawingml/2006/main">
               <a:ext uri="{FF2B5EF4-FFF2-40B4-BE49-F238E27FC236}">
-                <a16:creationId xmlns:a16="http://schemas.microsoft.com/office/drawing/2014/main" id="{3C0CB6B9-EE4D-4CB3-923E-CEB32B936CA0}"/>
+                <a16:creationId xmlns:a16="http://schemas.microsoft.com/office/drawing/2014/main" id="{44DF149F-766D-403B-A405-AB896F2053D8}"/>
               </a:ext>
             </a:extLst>
           </p:cNvPr>
@@ -1887,7 +1887,7 @@
           <p:cNvPr id="6" name="">
             <a:extLst xmlns:a="http://schemas.openxmlformats.org/drawingml/2006/main">
               <a:ext uri="{FF2B5EF4-FFF2-40B4-BE49-F238E27FC236}">
-                <a16:creationId xmlns:a16="http://schemas.microsoft.com/office/drawing/2014/main" id="{74143459-41DE-4A2F-A347-DA52EA793F88}"/>
+                <a16:creationId xmlns:a16="http://schemas.microsoft.com/office/drawing/2014/main" id="{22A233C9-842D-4029-8CD8-EDD397AF2F33}"/>
               </a:ext>
             </a:extLst>
           </p:cNvPr>
@@ -1951,7 +1951,7 @@
           <p:cNvPr id="7" name="">
             <a:extLst xmlns:a="http://schemas.openxmlformats.org/drawingml/2006/main">
               <a:ext uri="{FF2B5EF4-FFF2-40B4-BE49-F238E27FC236}">
-                <a16:creationId xmlns:a16="http://schemas.microsoft.com/office/drawing/2014/main" id="{82DB1BD0-9D55-4E39-89FA-88581CBE7AC0}"/>
+                <a16:creationId xmlns:a16="http://schemas.microsoft.com/office/drawing/2014/main" id="{0805F1CE-8948-4F2E-84C1-F917DC3E881D}"/>
               </a:ext>
             </a:extLst>
           </p:cNvPr>
@@ -2015,7 +2015,7 @@
           <p:cNvPr id="8" name="">
             <a:extLst xmlns:a="http://schemas.openxmlformats.org/drawingml/2006/main">
               <a:ext uri="{FF2B5EF4-FFF2-40B4-BE49-F238E27FC236}">
-                <a16:creationId xmlns:a16="http://schemas.microsoft.com/office/drawing/2014/main" id="{A4B12C9A-772B-4A63-A254-A482F46F5C72}"/>
+                <a16:creationId xmlns:a16="http://schemas.microsoft.com/office/drawing/2014/main" id="{2D02B617-846E-4EA4-B41A-10B0731B429F}"/>
               </a:ext>
             </a:extLst>
           </p:cNvPr>
@@ -2048,7 +2048,7 @@
           <p:cNvPr id="9" name="">
             <a:extLst xmlns:a="http://schemas.openxmlformats.org/drawingml/2006/main">
               <a:ext uri="{FF2B5EF4-FFF2-40B4-BE49-F238E27FC236}">
-                <a16:creationId xmlns:a16="http://schemas.microsoft.com/office/drawing/2014/main" id="{463799A3-4C6E-4B1F-9AEE-5995F7EFCCA7}"/>
+                <a16:creationId xmlns:a16="http://schemas.microsoft.com/office/drawing/2014/main" id="{04AADB0F-C2CC-48B0-BE23-7708445E5A7D}"/>
               </a:ext>
             </a:extLst>
           </p:cNvPr>
@@ -2112,7 +2112,7 @@
           <p:cNvPr id="10" name="">
             <a:extLst xmlns:a="http://schemas.openxmlformats.org/drawingml/2006/main">
               <a:ext uri="{FF2B5EF4-FFF2-40B4-BE49-F238E27FC236}">
-                <a16:creationId xmlns:a16="http://schemas.microsoft.com/office/drawing/2014/main" id="{84469EA6-D3D8-41BB-8DC8-26D30A270C64}"/>
+                <a16:creationId xmlns:a16="http://schemas.microsoft.com/office/drawing/2014/main" id="{FC69BAA7-7A1C-4B8D-A338-D9270018AA7A}"/>
               </a:ext>
             </a:extLst>
           </p:cNvPr>
@@ -2176,7 +2176,7 @@
           <p:cNvPr id="11" name="">
             <a:extLst xmlns:a="http://schemas.openxmlformats.org/drawingml/2006/main">
               <a:ext uri="{FF2B5EF4-FFF2-40B4-BE49-F238E27FC236}">
-                <a16:creationId xmlns:a16="http://schemas.microsoft.com/office/drawing/2014/main" id="{C164E2E9-5F47-4F6C-9DE2-2E464E1AD066}"/>
+                <a16:creationId xmlns:a16="http://schemas.microsoft.com/office/drawing/2014/main" id="{DFA83F07-90D7-4D28-9BD1-ED5EC5FE9478}"/>
               </a:ext>
             </a:extLst>
           </p:cNvPr>
@@ -2240,7 +2240,7 @@
           <p:cNvPr id="12" name="">
             <a:extLst xmlns:a="http://schemas.openxmlformats.org/drawingml/2006/main">
               <a:ext uri="{FF2B5EF4-FFF2-40B4-BE49-F238E27FC236}">
-                <a16:creationId xmlns:a16="http://schemas.microsoft.com/office/drawing/2014/main" id="{4A908F32-C797-4FC2-9F6D-0167FC95A468}"/>
+                <a16:creationId xmlns:a16="http://schemas.microsoft.com/office/drawing/2014/main" id="{9AF1BF91-8A03-485C-905C-DD665C359A8E}"/>
               </a:ext>
             </a:extLst>
           </p:cNvPr>
@@ -2273,7 +2273,7 @@
           <p:cNvPr id="13" name="">
             <a:extLst xmlns:a="http://schemas.openxmlformats.org/drawingml/2006/main">
               <a:ext uri="{FF2B5EF4-FFF2-40B4-BE49-F238E27FC236}">
-                <a16:creationId xmlns:a16="http://schemas.microsoft.com/office/drawing/2014/main" id="{7EADCBC2-4AEF-4188-9FB8-52FCCB846B39}"/>
+                <a16:creationId xmlns:a16="http://schemas.microsoft.com/office/drawing/2014/main" id="{96B4A35D-2D1F-4E09-A35A-0AA6353D338D}"/>
               </a:ext>
             </a:extLst>
           </p:cNvPr>
@@ -2337,7 +2337,7 @@
           <p:cNvPr id="14" name="">
             <a:extLst xmlns:a="http://schemas.openxmlformats.org/drawingml/2006/main">
               <a:ext uri="{FF2B5EF4-FFF2-40B4-BE49-F238E27FC236}">
-                <a16:creationId xmlns:a16="http://schemas.microsoft.com/office/drawing/2014/main" id="{709590F0-7E87-406E-9F30-04A8E57732D8}"/>
+                <a16:creationId xmlns:a16="http://schemas.microsoft.com/office/drawing/2014/main" id="{0CAED3E2-8AE2-4BBD-AABA-F1F1222548AD}"/>
               </a:ext>
             </a:extLst>
           </p:cNvPr>
@@ -2401,7 +2401,7 @@
           <p:cNvPr id="15" name="">
             <a:extLst xmlns:a="http://schemas.openxmlformats.org/drawingml/2006/main">
               <a:ext uri="{FF2B5EF4-FFF2-40B4-BE49-F238E27FC236}">
-                <a16:creationId xmlns:a16="http://schemas.microsoft.com/office/drawing/2014/main" id="{D1598BAE-B4D7-4ED1-A1E3-96A45E836BF1}"/>
+                <a16:creationId xmlns:a16="http://schemas.microsoft.com/office/drawing/2014/main" id="{86EFCD90-BEDF-4828-A54D-E63F38A4A3A6}"/>
               </a:ext>
             </a:extLst>
           </p:cNvPr>
@@ -2465,7 +2465,7 @@
           <p:cNvPr id="16" name="">
             <a:extLst xmlns:a="http://schemas.openxmlformats.org/drawingml/2006/main">
               <a:ext uri="{FF2B5EF4-FFF2-40B4-BE49-F238E27FC236}">
-                <a16:creationId xmlns:a16="http://schemas.microsoft.com/office/drawing/2014/main" id="{90DFD6F9-A066-439D-86C4-7DFFBCD4BB0B}"/>
+                <a16:creationId xmlns:a16="http://schemas.microsoft.com/office/drawing/2014/main" id="{396CFFBC-2B55-40B5-BB1B-0C6178C69387}"/>
               </a:ext>
             </a:extLst>
           </p:cNvPr>
@@ -2498,7 +2498,7 @@
           <p:cNvPr id="17" name="">
             <a:extLst xmlns:a="http://schemas.openxmlformats.org/drawingml/2006/main">
               <a:ext uri="{FF2B5EF4-FFF2-40B4-BE49-F238E27FC236}">
-                <a16:creationId xmlns:a16="http://schemas.microsoft.com/office/drawing/2014/main" id="{831CBC0C-1BEC-4866-A208-55DA9899989C}"/>
+                <a16:creationId xmlns:a16="http://schemas.microsoft.com/office/drawing/2014/main" id="{7D7D1006-234F-45BE-9A1E-EABB437C8F44}"/>
               </a:ext>
             </a:extLst>
           </p:cNvPr>
@@ -2562,7 +2562,7 @@
           <p:cNvPr id="18" name="">
             <a:extLst xmlns:a="http://schemas.openxmlformats.org/drawingml/2006/main">
               <a:ext uri="{FF2B5EF4-FFF2-40B4-BE49-F238E27FC236}">
-                <a16:creationId xmlns:a16="http://schemas.microsoft.com/office/drawing/2014/main" id="{E79C32D4-0B2C-4CFD-B4FE-97409F05EF8F}"/>
+                <a16:creationId xmlns:a16="http://schemas.microsoft.com/office/drawing/2014/main" id="{04B6A965-E353-4FA5-8F92-C36C65A29C17}"/>
               </a:ext>
             </a:extLst>
           </p:cNvPr>
@@ -2626,7 +2626,7 @@
           <p:cNvPr id="19" name="">
             <a:extLst xmlns:a="http://schemas.openxmlformats.org/drawingml/2006/main">
               <a:ext uri="{FF2B5EF4-FFF2-40B4-BE49-F238E27FC236}">
-                <a16:creationId xmlns:a16="http://schemas.microsoft.com/office/drawing/2014/main" id="{A42C49D8-AD1A-43A1-AB67-1D68C9AC3EC0}"/>
+                <a16:creationId xmlns:a16="http://schemas.microsoft.com/office/drawing/2014/main" id="{D408A5DC-08EF-412F-8346-34E31D7D9E46}"/>
               </a:ext>
             </a:extLst>
           </p:cNvPr>
@@ -2690,7 +2690,7 @@
           <p:cNvPr id="20" name="">
             <a:extLst xmlns:a="http://schemas.openxmlformats.org/drawingml/2006/main">
               <a:ext uri="{FF2B5EF4-FFF2-40B4-BE49-F238E27FC236}">
-                <a16:creationId xmlns:a16="http://schemas.microsoft.com/office/drawing/2014/main" id="{A9F9F01D-A815-45D2-861A-251E3B960F43}"/>
+                <a16:creationId xmlns:a16="http://schemas.microsoft.com/office/drawing/2014/main" id="{776FD937-42D4-4059-933B-FE96CB90F55A}"/>
               </a:ext>
             </a:extLst>
           </p:cNvPr>
@@ -2723,7 +2723,7 @@
           <p:cNvPr id="21" name="">
             <a:extLst xmlns:a="http://schemas.openxmlformats.org/drawingml/2006/main">
               <a:ext uri="{FF2B5EF4-FFF2-40B4-BE49-F238E27FC236}">
-                <a16:creationId xmlns:a16="http://schemas.microsoft.com/office/drawing/2014/main" id="{945021B6-DCC1-4A25-B61E-D8B6D7EED7EB}"/>
+                <a16:creationId xmlns:a16="http://schemas.microsoft.com/office/drawing/2014/main" id="{C27DBDB3-60F2-47FE-8296-B89E47D59007}"/>
               </a:ext>
             </a:extLst>
           </p:cNvPr>
@@ -2787,7 +2787,7 @@
           <p:cNvPr id="22" name="">
             <a:extLst xmlns:a="http://schemas.openxmlformats.org/drawingml/2006/main">
               <a:ext uri="{FF2B5EF4-FFF2-40B4-BE49-F238E27FC236}">
-                <a16:creationId xmlns:a16="http://schemas.microsoft.com/office/drawing/2014/main" id="{BBCEC217-67F2-4FC4-8ACD-594816558E27}"/>
+                <a16:creationId xmlns:a16="http://schemas.microsoft.com/office/drawing/2014/main" id="{AC14CD72-DB2A-4A5A-8536-BBE72C689458}"/>
               </a:ext>
             </a:extLst>
           </p:cNvPr>
@@ -2851,7 +2851,7 @@
           <p:cNvPr id="23" name="">
             <a:extLst xmlns:a="http://schemas.openxmlformats.org/drawingml/2006/main">
               <a:ext uri="{FF2B5EF4-FFF2-40B4-BE49-F238E27FC236}">
-                <a16:creationId xmlns:a16="http://schemas.microsoft.com/office/drawing/2014/main" id="{066F6787-D29A-419E-8CE5-180000A66D62}"/>
+                <a16:creationId xmlns:a16="http://schemas.microsoft.com/office/drawing/2014/main" id="{DA57C524-9A37-45D9-8EFD-6404DCCD0DA8}"/>
               </a:ext>
             </a:extLst>
           </p:cNvPr>
@@ -2915,7 +2915,7 @@
           <p:cNvPr id="24" name="">
             <a:extLst xmlns:a="http://schemas.openxmlformats.org/drawingml/2006/main">
               <a:ext uri="{FF2B5EF4-FFF2-40B4-BE49-F238E27FC236}">
-                <a16:creationId xmlns:a16="http://schemas.microsoft.com/office/drawing/2014/main" id="{AFD82887-2339-450C-93DE-A798CAFF141E}"/>
+                <a16:creationId xmlns:a16="http://schemas.microsoft.com/office/drawing/2014/main" id="{53740EAF-112D-4DDD-BA19-BEF5329423CF}"/>
               </a:ext>
             </a:extLst>
           </p:cNvPr>
@@ -2979,7 +2979,7 @@
           <p:cNvPr id="25" name="">
             <a:extLst xmlns:a="http://schemas.openxmlformats.org/drawingml/2006/main">
               <a:ext uri="{FF2B5EF4-FFF2-40B4-BE49-F238E27FC236}">
-                <a16:creationId xmlns:a16="http://schemas.microsoft.com/office/drawing/2014/main" id="{67CE9298-CE2B-4700-AECB-363A08CFFA30}"/>
+                <a16:creationId xmlns:a16="http://schemas.microsoft.com/office/drawing/2014/main" id="{19B1B71E-2B2F-41DC-8C51-CD1E8BBB045D}"/>
               </a:ext>
             </a:extLst>
           </p:cNvPr>
@@ -3014,7 +3014,7 @@
           <p:cNvPr id="26" name="">
             <a:extLst xmlns:a="http://schemas.openxmlformats.org/drawingml/2006/main">
               <a:ext uri="{FF2B5EF4-FFF2-40B4-BE49-F238E27FC236}">
-                <a16:creationId xmlns:a16="http://schemas.microsoft.com/office/drawing/2014/main" id="{F0A41061-1984-4878-9BEF-7C9B5E831730}"/>
+                <a16:creationId xmlns:a16="http://schemas.microsoft.com/office/drawing/2014/main" id="{DB6F5C3B-3027-493D-B678-AE97F0ABD6FA}"/>
               </a:ext>
             </a:extLst>
           </p:cNvPr>
@@ -3078,7 +3078,7 @@
           <p:cNvPr id="27" name="">
             <a:extLst xmlns:a="http://schemas.openxmlformats.org/drawingml/2006/main">
               <a:ext uri="{FF2B5EF4-FFF2-40B4-BE49-F238E27FC236}">
-                <a16:creationId xmlns:a16="http://schemas.microsoft.com/office/drawing/2014/main" id="{85D25BEA-0660-46C5-9923-A91B50EECC37}"/>
+                <a16:creationId xmlns:a16="http://schemas.microsoft.com/office/drawing/2014/main" id="{57BF0E2A-770B-4C18-9DE4-9960B4B618FA}"/>
               </a:ext>
             </a:extLst>
           </p:cNvPr>
@@ -3140,7 +3140,7 @@
     </p:spTree>
     <p:extLst>
       <p:ext uri="{BB962C8B-B14F-4D97-AF65-F5344CB8AC3E}">
-        <p14:creationId xmlns:p14="http://schemas.microsoft.com/office/powerpoint/2010/main" val="344450819"/>
+        <p14:creationId xmlns:p14="http://schemas.microsoft.com/office/powerpoint/2010/main" val="1884270210"/>
       </p:ext>
     </p:extLst>
   </p:cSld>
@@ -3164,7 +3164,7 @@
           <p:cNvPr id="1" name="">
             <a:extLst xmlns:a="http://schemas.openxmlformats.org/drawingml/2006/main">
               <a:ext uri="{FF2B5EF4-FFF2-40B4-BE49-F238E27FC236}">
-                <a16:creationId xmlns:a16="http://schemas.microsoft.com/office/drawing/2014/main" id="{55902F81-F09F-4BB0-A2F9-31AE1F2A9B06}"/>
+                <a16:creationId xmlns:a16="http://schemas.microsoft.com/office/drawing/2014/main" id="{098EA76C-3035-4A56-826F-AD6D225EA6DB}"/>
               </a:ext>
             </a:extLst>
           </p:cNvPr>
@@ -3199,7 +3199,7 @@
           <p:cNvPr id="2" name="">
             <a:extLst xmlns:a="http://schemas.openxmlformats.org/drawingml/2006/main">
               <a:ext uri="{FF2B5EF4-FFF2-40B4-BE49-F238E27FC236}">
-                <a16:creationId xmlns:a16="http://schemas.microsoft.com/office/drawing/2014/main" id="{A5996A28-692A-4ADB-9B1D-FEFE603BFD6A}"/>
+                <a16:creationId xmlns:a16="http://schemas.microsoft.com/office/drawing/2014/main" id="{02C44F65-355C-48BE-A045-C65D0A4A2090}"/>
               </a:ext>
             </a:extLst>
           </p:cNvPr>
@@ -3234,7 +3234,7 @@
           <p:cNvPr id="3" name="">
             <a:extLst xmlns:a="http://schemas.openxmlformats.org/drawingml/2006/main">
               <a:ext uri="{FF2B5EF4-FFF2-40B4-BE49-F238E27FC236}">
-                <a16:creationId xmlns:a16="http://schemas.microsoft.com/office/drawing/2014/main" id="{1D9F7A11-3E80-479B-A770-2B86596B95C6}"/>
+                <a16:creationId xmlns:a16="http://schemas.microsoft.com/office/drawing/2014/main" id="{7FDB04DA-6DE2-491E-860C-4C32145D9F66}"/>
               </a:ext>
             </a:extLst>
           </p:cNvPr>
@@ -3298,7 +3298,7 @@
           <p:cNvPr id="4" name="">
             <a:extLst xmlns:a="http://schemas.openxmlformats.org/drawingml/2006/main">
               <a:ext uri="{FF2B5EF4-FFF2-40B4-BE49-F238E27FC236}">
-                <a16:creationId xmlns:a16="http://schemas.microsoft.com/office/drawing/2014/main" id="{4182E5B0-2326-4459-881F-4D22417DA405}"/>
+                <a16:creationId xmlns:a16="http://schemas.microsoft.com/office/drawing/2014/main" id="{E68FF109-E4F8-4D46-96FD-A567E056498B}"/>
               </a:ext>
             </a:extLst>
           </p:cNvPr>
@@ -3362,7 +3362,7 @@
           <p:cNvPr id="5" name="">
             <a:extLst xmlns:a="http://schemas.openxmlformats.org/drawingml/2006/main">
               <a:ext uri="{FF2B5EF4-FFF2-40B4-BE49-F238E27FC236}">
-                <a16:creationId xmlns:a16="http://schemas.microsoft.com/office/drawing/2014/main" id="{AD6D6B0F-6375-48B1-8B5D-6AEF7AC561EF}"/>
+                <a16:creationId xmlns:a16="http://schemas.microsoft.com/office/drawing/2014/main" id="{B0BAF4B1-3C04-4238-B68C-55D1CFE415BB}"/>
               </a:ext>
             </a:extLst>
           </p:cNvPr>
@@ -3426,7 +3426,7 @@
           <p:cNvPr id="6" name="">
             <a:extLst xmlns:a="http://schemas.openxmlformats.org/drawingml/2006/main">
               <a:ext uri="{FF2B5EF4-FFF2-40B4-BE49-F238E27FC236}">
-                <a16:creationId xmlns:a16="http://schemas.microsoft.com/office/drawing/2014/main" id="{04B329B1-0781-4E8F-A194-3E7D087F2161}"/>
+                <a16:creationId xmlns:a16="http://schemas.microsoft.com/office/drawing/2014/main" id="{7F2522A6-59EB-4EE4-A1C5-2A8816BEE061}"/>
               </a:ext>
             </a:extLst>
           </p:cNvPr>
@@ -3459,7 +3459,7 @@
           <p:cNvPr id="7" name="">
             <a:extLst xmlns:a="http://schemas.openxmlformats.org/drawingml/2006/main">
               <a:ext uri="{FF2B5EF4-FFF2-40B4-BE49-F238E27FC236}">
-                <a16:creationId xmlns:a16="http://schemas.microsoft.com/office/drawing/2014/main" id="{9D211AEE-6082-474B-A7F6-6594845A4AAE}"/>
+                <a16:creationId xmlns:a16="http://schemas.microsoft.com/office/drawing/2014/main" id="{3F9177FA-6B52-4401-8A4A-5509FBCDD85A}"/>
               </a:ext>
             </a:extLst>
           </p:cNvPr>
@@ -3523,7 +3523,7 @@
           <p:cNvPr id="8" name="">
             <a:extLst xmlns:a="http://schemas.openxmlformats.org/drawingml/2006/main">
               <a:ext uri="{FF2B5EF4-FFF2-40B4-BE49-F238E27FC236}">
-                <a16:creationId xmlns:a16="http://schemas.microsoft.com/office/drawing/2014/main" id="{5820C058-42A0-430F-88D2-26EE8DCC80DC}"/>
+                <a16:creationId xmlns:a16="http://schemas.microsoft.com/office/drawing/2014/main" id="{8841AC4E-D59C-4060-BFBA-AACFFA543004}"/>
               </a:ext>
             </a:extLst>
           </p:cNvPr>
@@ -3558,7 +3558,7 @@
           <p:cNvPr id="9" name="">
             <a:extLst xmlns:a="http://schemas.openxmlformats.org/drawingml/2006/main">
               <a:ext uri="{FF2B5EF4-FFF2-40B4-BE49-F238E27FC236}">
-                <a16:creationId xmlns:a16="http://schemas.microsoft.com/office/drawing/2014/main" id="{081FF899-AAF4-4A2F-9D8C-310F97ADDD5C}"/>
+                <a16:creationId xmlns:a16="http://schemas.microsoft.com/office/drawing/2014/main" id="{7A752AA9-3846-4795-9B47-B96CD239105E}"/>
               </a:ext>
             </a:extLst>
           </p:cNvPr>
@@ -3622,7 +3622,7 @@
           <p:cNvPr id="10" name="">
             <a:extLst xmlns:a="http://schemas.openxmlformats.org/drawingml/2006/main">
               <a:ext uri="{FF2B5EF4-FFF2-40B4-BE49-F238E27FC236}">
-                <a16:creationId xmlns:a16="http://schemas.microsoft.com/office/drawing/2014/main" id="{330930BC-5971-4C42-9285-A858CD8592C8}"/>
+                <a16:creationId xmlns:a16="http://schemas.microsoft.com/office/drawing/2014/main" id="{0D1E221C-397D-493E-9E28-EC1FA44DBFA9}"/>
               </a:ext>
             </a:extLst>
           </p:cNvPr>
@@ -3657,7 +3657,7 @@
           <p:cNvPr id="11" name="">
             <a:extLst xmlns:a="http://schemas.openxmlformats.org/drawingml/2006/main">
               <a:ext uri="{FF2B5EF4-FFF2-40B4-BE49-F238E27FC236}">
-                <a16:creationId xmlns:a16="http://schemas.microsoft.com/office/drawing/2014/main" id="{7ED8811F-6AE1-4192-AAA5-1863BB6324E6}"/>
+                <a16:creationId xmlns:a16="http://schemas.microsoft.com/office/drawing/2014/main" id="{D2F2E272-DF07-429E-84D3-EB8A0BE15904}"/>
               </a:ext>
             </a:extLst>
           </p:cNvPr>
@@ -3721,7 +3721,7 @@
           <p:cNvPr id="12" name="">
             <a:extLst xmlns:a="http://schemas.openxmlformats.org/drawingml/2006/main">
               <a:ext uri="{FF2B5EF4-FFF2-40B4-BE49-F238E27FC236}">
-                <a16:creationId xmlns:a16="http://schemas.microsoft.com/office/drawing/2014/main" id="{11B8D993-C7BA-4CEA-BCCA-39E8D57C56CF}"/>
+                <a16:creationId xmlns:a16="http://schemas.microsoft.com/office/drawing/2014/main" id="{F019B46F-9600-46C1-9505-65297A90D90E}"/>
               </a:ext>
             </a:extLst>
           </p:cNvPr>
@@ -3756,7 +3756,7 @@
           <p:cNvPr id="13" name="">
             <a:extLst xmlns:a="http://schemas.openxmlformats.org/drawingml/2006/main">
               <a:ext uri="{FF2B5EF4-FFF2-40B4-BE49-F238E27FC236}">
-                <a16:creationId xmlns:a16="http://schemas.microsoft.com/office/drawing/2014/main" id="{0E8E6737-718B-4D19-BC20-C96BB18D5ECD}"/>
+                <a16:creationId xmlns:a16="http://schemas.microsoft.com/office/drawing/2014/main" id="{EDDA5F9F-F86F-44D8-B84E-EDFD08621DCB}"/>
               </a:ext>
             </a:extLst>
           </p:cNvPr>
@@ -3820,7 +3820,7 @@
           <p:cNvPr id="14" name="">
             <a:extLst xmlns:a="http://schemas.openxmlformats.org/drawingml/2006/main">
               <a:ext uri="{FF2B5EF4-FFF2-40B4-BE49-F238E27FC236}">
-                <a16:creationId xmlns:a16="http://schemas.microsoft.com/office/drawing/2014/main" id="{C08606F9-D9B6-4242-A7EF-9B581A2ED29F}"/>
+                <a16:creationId xmlns:a16="http://schemas.microsoft.com/office/drawing/2014/main" id="{358B5AA3-40DB-4C65-B90D-6E70FE221BAC}"/>
               </a:ext>
             </a:extLst>
           </p:cNvPr>
@@ -3855,7 +3855,7 @@
           <p:cNvPr id="15" name="">
             <a:extLst xmlns:a="http://schemas.openxmlformats.org/drawingml/2006/main">
               <a:ext uri="{FF2B5EF4-FFF2-40B4-BE49-F238E27FC236}">
-                <a16:creationId xmlns:a16="http://schemas.microsoft.com/office/drawing/2014/main" id="{0B63F275-D0E0-47CF-9EA2-4F8BD11B89C9}"/>
+                <a16:creationId xmlns:a16="http://schemas.microsoft.com/office/drawing/2014/main" id="{ABDFD834-F285-4422-8861-CE81124648EA}"/>
               </a:ext>
             </a:extLst>
           </p:cNvPr>
@@ -3919,7 +3919,7 @@
           <p:cNvPr id="16" name="">
             <a:extLst xmlns:a="http://schemas.openxmlformats.org/drawingml/2006/main">
               <a:ext uri="{FF2B5EF4-FFF2-40B4-BE49-F238E27FC236}">
-                <a16:creationId xmlns:a16="http://schemas.microsoft.com/office/drawing/2014/main" id="{62CF9986-BF44-4679-BC23-23418D0D1E96}"/>
+                <a16:creationId xmlns:a16="http://schemas.microsoft.com/office/drawing/2014/main" id="{9CBC2E90-63CA-4360-840D-BD2ED0CBEAEB}"/>
               </a:ext>
             </a:extLst>
           </p:cNvPr>
@@ -3954,7 +3954,7 @@
           <p:cNvPr id="17" name="">
             <a:extLst xmlns:a="http://schemas.openxmlformats.org/drawingml/2006/main">
               <a:ext uri="{FF2B5EF4-FFF2-40B4-BE49-F238E27FC236}">
-                <a16:creationId xmlns:a16="http://schemas.microsoft.com/office/drawing/2014/main" id="{29E0E380-B3D5-4356-9904-D06751AB87A3}"/>
+                <a16:creationId xmlns:a16="http://schemas.microsoft.com/office/drawing/2014/main" id="{D658008A-F61F-4DF2-9DC5-547FC569B294}"/>
               </a:ext>
             </a:extLst>
           </p:cNvPr>
@@ -4018,7 +4018,7 @@
           <p:cNvPr id="18" name="">
             <a:extLst xmlns:a="http://schemas.openxmlformats.org/drawingml/2006/main">
               <a:ext uri="{FF2B5EF4-FFF2-40B4-BE49-F238E27FC236}">
-                <a16:creationId xmlns:a16="http://schemas.microsoft.com/office/drawing/2014/main" id="{94C39A61-FDAF-47D4-BF30-6A1DDBD6C9D2}"/>
+                <a16:creationId xmlns:a16="http://schemas.microsoft.com/office/drawing/2014/main" id="{81561445-86ED-4F84-B7C5-11078D0C1435}"/>
               </a:ext>
             </a:extLst>
           </p:cNvPr>
@@ -4051,7 +4051,7 @@
           <p:cNvPr id="19" name="">
             <a:extLst xmlns:a="http://schemas.openxmlformats.org/drawingml/2006/main">
               <a:ext uri="{FF2B5EF4-FFF2-40B4-BE49-F238E27FC236}">
-                <a16:creationId xmlns:a16="http://schemas.microsoft.com/office/drawing/2014/main" id="{BA3267CB-4937-4F37-8887-8748C69423EF}"/>
+                <a16:creationId xmlns:a16="http://schemas.microsoft.com/office/drawing/2014/main" id="{468D76F9-F3DA-45D3-908A-E678547274CC}"/>
               </a:ext>
             </a:extLst>
           </p:cNvPr>
@@ -4115,7 +4115,7 @@
           <p:cNvPr id="20" name="">
             <a:extLst xmlns:a="http://schemas.openxmlformats.org/drawingml/2006/main">
               <a:ext uri="{FF2B5EF4-FFF2-40B4-BE49-F238E27FC236}">
-                <a16:creationId xmlns:a16="http://schemas.microsoft.com/office/drawing/2014/main" id="{D842AEEB-F411-4A96-BCCA-0CDD92EC8A20}"/>
+                <a16:creationId xmlns:a16="http://schemas.microsoft.com/office/drawing/2014/main" id="{3AC07453-0997-4F99-AE0F-8B6B6B3B23CE}"/>
               </a:ext>
             </a:extLst>
           </p:cNvPr>
@@ -4150,7 +4150,7 @@
           <p:cNvPr id="21" name="">
             <a:extLst xmlns:a="http://schemas.openxmlformats.org/drawingml/2006/main">
               <a:ext uri="{FF2B5EF4-FFF2-40B4-BE49-F238E27FC236}">
-                <a16:creationId xmlns:a16="http://schemas.microsoft.com/office/drawing/2014/main" id="{66861E3F-0608-4E3E-917C-CDCA77E0D70D}"/>
+                <a16:creationId xmlns:a16="http://schemas.microsoft.com/office/drawing/2014/main" id="{E82579FC-CB13-443D-B45E-FB4E5A3EC844}"/>
               </a:ext>
             </a:extLst>
           </p:cNvPr>
@@ -4214,7 +4214,7 @@
           <p:cNvPr id="22" name="">
             <a:extLst xmlns:a="http://schemas.openxmlformats.org/drawingml/2006/main">
               <a:ext uri="{FF2B5EF4-FFF2-40B4-BE49-F238E27FC236}">
-                <a16:creationId xmlns:a16="http://schemas.microsoft.com/office/drawing/2014/main" id="{4F72F4A2-2369-4F1D-81BA-C8780A5A811C}"/>
+                <a16:creationId xmlns:a16="http://schemas.microsoft.com/office/drawing/2014/main" id="{00DCFB68-6EF8-4384-9092-5D11FECC50E4}"/>
               </a:ext>
             </a:extLst>
           </p:cNvPr>
@@ -4249,7 +4249,7 @@
           <p:cNvPr id="23" name="">
             <a:extLst xmlns:a="http://schemas.openxmlformats.org/drawingml/2006/main">
               <a:ext uri="{FF2B5EF4-FFF2-40B4-BE49-F238E27FC236}">
-                <a16:creationId xmlns:a16="http://schemas.microsoft.com/office/drawing/2014/main" id="{9B520AF2-BA44-4351-9314-1236DF75B6EC}"/>
+                <a16:creationId xmlns:a16="http://schemas.microsoft.com/office/drawing/2014/main" id="{CB97FC20-E383-493E-99C1-E53BDB469901}"/>
               </a:ext>
             </a:extLst>
           </p:cNvPr>
@@ -4313,7 +4313,7 @@
           <p:cNvPr id="24" name="">
             <a:extLst xmlns:a="http://schemas.openxmlformats.org/drawingml/2006/main">
               <a:ext uri="{FF2B5EF4-FFF2-40B4-BE49-F238E27FC236}">
-                <a16:creationId xmlns:a16="http://schemas.microsoft.com/office/drawing/2014/main" id="{4E8B9CCF-B56C-4F82-9F75-A6EC15E4FF30}"/>
+                <a16:creationId xmlns:a16="http://schemas.microsoft.com/office/drawing/2014/main" id="{86E56B0C-FB7A-4916-BD63-7EA925BE59DD}"/>
               </a:ext>
             </a:extLst>
           </p:cNvPr>
@@ -4348,7 +4348,7 @@
           <p:cNvPr id="25" name="">
             <a:extLst xmlns:a="http://schemas.openxmlformats.org/drawingml/2006/main">
               <a:ext uri="{FF2B5EF4-FFF2-40B4-BE49-F238E27FC236}">
-                <a16:creationId xmlns:a16="http://schemas.microsoft.com/office/drawing/2014/main" id="{D2973629-4288-4DE1-8B9B-260DE325F769}"/>
+                <a16:creationId xmlns:a16="http://schemas.microsoft.com/office/drawing/2014/main" id="{4ED2EF89-20CA-4953-9100-0FC5B7129457}"/>
               </a:ext>
             </a:extLst>
           </p:cNvPr>
@@ -4412,7 +4412,7 @@
           <p:cNvPr id="26" name="">
             <a:extLst xmlns:a="http://schemas.openxmlformats.org/drawingml/2006/main">
               <a:ext uri="{FF2B5EF4-FFF2-40B4-BE49-F238E27FC236}">
-                <a16:creationId xmlns:a16="http://schemas.microsoft.com/office/drawing/2014/main" id="{8D7BDACD-B7C3-45D1-8B98-607CBBEB2A17}"/>
+                <a16:creationId xmlns:a16="http://schemas.microsoft.com/office/drawing/2014/main" id="{2190D84E-643B-4408-9C4E-400AA2CA5BF1}"/>
               </a:ext>
             </a:extLst>
           </p:cNvPr>
@@ -4447,7 +4447,7 @@
           <p:cNvPr id="27" name="">
             <a:extLst xmlns:a="http://schemas.openxmlformats.org/drawingml/2006/main">
               <a:ext uri="{FF2B5EF4-FFF2-40B4-BE49-F238E27FC236}">
-                <a16:creationId xmlns:a16="http://schemas.microsoft.com/office/drawing/2014/main" id="{9AF1D5C0-CDC1-40A8-B8E7-C035E955E268}"/>
+                <a16:creationId xmlns:a16="http://schemas.microsoft.com/office/drawing/2014/main" id="{AE4A129A-5760-4ADC-9A65-A587A9E6B060}"/>
               </a:ext>
             </a:extLst>
           </p:cNvPr>
@@ -4511,7 +4511,7 @@
           <p:cNvPr id="28" name="">
             <a:extLst xmlns:a="http://schemas.openxmlformats.org/drawingml/2006/main">
               <a:ext uri="{FF2B5EF4-FFF2-40B4-BE49-F238E27FC236}">
-                <a16:creationId xmlns:a16="http://schemas.microsoft.com/office/drawing/2014/main" id="{923BDA5D-7158-415B-8A31-9FF592B28F9C}"/>
+                <a16:creationId xmlns:a16="http://schemas.microsoft.com/office/drawing/2014/main" id="{3B31D870-5485-4562-A57F-49402FE07656}"/>
               </a:ext>
             </a:extLst>
           </p:cNvPr>
@@ -4544,7 +4544,7 @@
           <p:cNvPr id="29" name="">
             <a:extLst xmlns:a="http://schemas.openxmlformats.org/drawingml/2006/main">
               <a:ext uri="{FF2B5EF4-FFF2-40B4-BE49-F238E27FC236}">
-                <a16:creationId xmlns:a16="http://schemas.microsoft.com/office/drawing/2014/main" id="{43C656F2-B6A5-4973-8B14-19285CEE2BF2}"/>
+                <a16:creationId xmlns:a16="http://schemas.microsoft.com/office/drawing/2014/main" id="{C27706FF-B0B4-4262-85A1-198942550D5E}"/>
               </a:ext>
             </a:extLst>
           </p:cNvPr>
@@ -4608,7 +4608,7 @@
           <p:cNvPr id="30" name="">
             <a:extLst xmlns:a="http://schemas.openxmlformats.org/drawingml/2006/main">
               <a:ext uri="{FF2B5EF4-FFF2-40B4-BE49-F238E27FC236}">
-                <a16:creationId xmlns:a16="http://schemas.microsoft.com/office/drawing/2014/main" id="{3E234A0E-382B-44E3-AF4C-080D395A6404}"/>
+                <a16:creationId xmlns:a16="http://schemas.microsoft.com/office/drawing/2014/main" id="{89FC164D-1381-438C-AF1F-82B1187E4B38}"/>
               </a:ext>
             </a:extLst>
           </p:cNvPr>
@@ -4643,7 +4643,7 @@
           <p:cNvPr id="31" name="">
             <a:extLst xmlns:a="http://schemas.openxmlformats.org/drawingml/2006/main">
               <a:ext uri="{FF2B5EF4-FFF2-40B4-BE49-F238E27FC236}">
-                <a16:creationId xmlns:a16="http://schemas.microsoft.com/office/drawing/2014/main" id="{AFB1D28E-DFEA-4C2A-9A4B-69CC3DF01978}"/>
+                <a16:creationId xmlns:a16="http://schemas.microsoft.com/office/drawing/2014/main" id="{027DE130-9058-46ED-A886-AF561E993BFE}"/>
               </a:ext>
             </a:extLst>
           </p:cNvPr>
@@ -4707,7 +4707,7 @@
           <p:cNvPr id="32" name="">
             <a:extLst xmlns:a="http://schemas.openxmlformats.org/drawingml/2006/main">
               <a:ext uri="{FF2B5EF4-FFF2-40B4-BE49-F238E27FC236}">
-                <a16:creationId xmlns:a16="http://schemas.microsoft.com/office/drawing/2014/main" id="{B8158C10-1E67-4598-A84D-A7D50346B5DA}"/>
+                <a16:creationId xmlns:a16="http://schemas.microsoft.com/office/drawing/2014/main" id="{6CBD63B0-3AC6-4FBC-8D8E-A8D17FE23855}"/>
               </a:ext>
             </a:extLst>
           </p:cNvPr>
@@ -4742,7 +4742,7 @@
           <p:cNvPr id="33" name="">
             <a:extLst xmlns:a="http://schemas.openxmlformats.org/drawingml/2006/main">
               <a:ext uri="{FF2B5EF4-FFF2-40B4-BE49-F238E27FC236}">
-                <a16:creationId xmlns:a16="http://schemas.microsoft.com/office/drawing/2014/main" id="{91A2E178-6B68-4964-9273-8E686C1B0D2C}"/>
+                <a16:creationId xmlns:a16="http://schemas.microsoft.com/office/drawing/2014/main" id="{BF034072-D9A9-46CD-94DD-3684647FA77C}"/>
               </a:ext>
             </a:extLst>
           </p:cNvPr>
@@ -4806,7 +4806,7 @@
           <p:cNvPr id="34" name="">
             <a:extLst xmlns:a="http://schemas.openxmlformats.org/drawingml/2006/main">
               <a:ext uri="{FF2B5EF4-FFF2-40B4-BE49-F238E27FC236}">
-                <a16:creationId xmlns:a16="http://schemas.microsoft.com/office/drawing/2014/main" id="{0243911F-160C-477F-A2C1-03DE26DB71F9}"/>
+                <a16:creationId xmlns:a16="http://schemas.microsoft.com/office/drawing/2014/main" id="{1AB89A12-A32D-43F3-9F83-625A3363B3E5}"/>
               </a:ext>
             </a:extLst>
           </p:cNvPr>
@@ -4841,7 +4841,7 @@
           <p:cNvPr id="35" name="">
             <a:extLst xmlns:a="http://schemas.openxmlformats.org/drawingml/2006/main">
               <a:ext uri="{FF2B5EF4-FFF2-40B4-BE49-F238E27FC236}">
-                <a16:creationId xmlns:a16="http://schemas.microsoft.com/office/drawing/2014/main" id="{F94CF7AF-DE0A-4B9E-BB8F-5CC9301DE3D0}"/>
+                <a16:creationId xmlns:a16="http://schemas.microsoft.com/office/drawing/2014/main" id="{C8740579-778C-4CEF-9F35-0BADB21BB5C5}"/>
               </a:ext>
             </a:extLst>
           </p:cNvPr>
@@ -4905,7 +4905,7 @@
           <p:cNvPr id="36" name="">
             <a:extLst xmlns:a="http://schemas.openxmlformats.org/drawingml/2006/main">
               <a:ext uri="{FF2B5EF4-FFF2-40B4-BE49-F238E27FC236}">
-                <a16:creationId xmlns:a16="http://schemas.microsoft.com/office/drawing/2014/main" id="{E8E99950-A91E-485C-ACF4-95A5A9DB6650}"/>
+                <a16:creationId xmlns:a16="http://schemas.microsoft.com/office/drawing/2014/main" id="{29F91DEA-1FF4-416B-9D1E-14B231ABA1D9}"/>
               </a:ext>
             </a:extLst>
           </p:cNvPr>
@@ -4940,7 +4940,7 @@
           <p:cNvPr id="37" name="">
             <a:extLst xmlns:a="http://schemas.openxmlformats.org/drawingml/2006/main">
               <a:ext uri="{FF2B5EF4-FFF2-40B4-BE49-F238E27FC236}">
-                <a16:creationId xmlns:a16="http://schemas.microsoft.com/office/drawing/2014/main" id="{25BB2CC9-0494-48A3-BAD5-D52BB10843F6}"/>
+                <a16:creationId xmlns:a16="http://schemas.microsoft.com/office/drawing/2014/main" id="{FA0E6B4E-3708-4318-A087-07CE6DBE7073}"/>
               </a:ext>
             </a:extLst>
           </p:cNvPr>
@@ -5004,7 +5004,7 @@
           <p:cNvPr id="38" name="">
             <a:extLst xmlns:a="http://schemas.openxmlformats.org/drawingml/2006/main">
               <a:ext uri="{FF2B5EF4-FFF2-40B4-BE49-F238E27FC236}">
-                <a16:creationId xmlns:a16="http://schemas.microsoft.com/office/drawing/2014/main" id="{D560AF5A-9B5F-4ABF-8CD4-C89244B3A3B6}"/>
+                <a16:creationId xmlns:a16="http://schemas.microsoft.com/office/drawing/2014/main" id="{F4751431-C0FC-47D0-8654-4A83E1BCA122}"/>
               </a:ext>
             </a:extLst>
           </p:cNvPr>
@@ -5037,7 +5037,7 @@
           <p:cNvPr id="39" name="">
             <a:extLst xmlns:a="http://schemas.openxmlformats.org/drawingml/2006/main">
               <a:ext uri="{FF2B5EF4-FFF2-40B4-BE49-F238E27FC236}">
-                <a16:creationId xmlns:a16="http://schemas.microsoft.com/office/drawing/2014/main" id="{A6BD4781-5FEE-4B5A-BFBA-360C3B602C49}"/>
+                <a16:creationId xmlns:a16="http://schemas.microsoft.com/office/drawing/2014/main" id="{875D731F-BE67-4EDE-A061-91E44A122159}"/>
               </a:ext>
             </a:extLst>
           </p:cNvPr>
@@ -5070,7 +5070,7 @@
           <p:cNvPr id="40" name="">
             <a:extLst xmlns:a="http://schemas.openxmlformats.org/drawingml/2006/main">
               <a:ext uri="{FF2B5EF4-FFF2-40B4-BE49-F238E27FC236}">
-                <a16:creationId xmlns:a16="http://schemas.microsoft.com/office/drawing/2014/main" id="{A90C6C75-EC2F-4FEC-AD9C-2AC21F485DF7}"/>
+                <a16:creationId xmlns:a16="http://schemas.microsoft.com/office/drawing/2014/main" id="{C8EC7486-AA1B-4845-BD4E-641DE471504E}"/>
               </a:ext>
             </a:extLst>
           </p:cNvPr>
@@ -5134,7 +5134,7 @@
           <p:cNvPr id="41" name="">
             <a:extLst xmlns:a="http://schemas.openxmlformats.org/drawingml/2006/main">
               <a:ext uri="{FF2B5EF4-FFF2-40B4-BE49-F238E27FC236}">
-                <a16:creationId xmlns:a16="http://schemas.microsoft.com/office/drawing/2014/main" id="{F67A3FEE-D01D-4767-85BB-FF7C193E4A62}"/>
+                <a16:creationId xmlns:a16="http://schemas.microsoft.com/office/drawing/2014/main" id="{075357F4-2883-4A82-9BE3-81D109C3BA68}"/>
               </a:ext>
             </a:extLst>
           </p:cNvPr>
@@ -5169,7 +5169,7 @@
           <p:cNvPr id="42" name="">
             <a:extLst xmlns:a="http://schemas.openxmlformats.org/drawingml/2006/main">
               <a:ext uri="{FF2B5EF4-FFF2-40B4-BE49-F238E27FC236}">
-                <a16:creationId xmlns:a16="http://schemas.microsoft.com/office/drawing/2014/main" id="{74AF6CA6-62F4-4D3D-A031-EDE20493E3F0}"/>
+                <a16:creationId xmlns:a16="http://schemas.microsoft.com/office/drawing/2014/main" id="{157AB377-C923-4755-A815-D9166640509A}"/>
               </a:ext>
             </a:extLst>
           </p:cNvPr>
@@ -5233,7 +5233,7 @@
           <p:cNvPr id="43" name="">
             <a:extLst xmlns:a="http://schemas.openxmlformats.org/drawingml/2006/main">
               <a:ext uri="{FF2B5EF4-FFF2-40B4-BE49-F238E27FC236}">
-                <a16:creationId xmlns:a16="http://schemas.microsoft.com/office/drawing/2014/main" id="{6DDB0AEC-F199-4C4A-8B3C-9AF3800E63C3}"/>
+                <a16:creationId xmlns:a16="http://schemas.microsoft.com/office/drawing/2014/main" id="{43D4B4EF-8E55-49AB-ABB1-B0E1EE35A258}"/>
               </a:ext>
             </a:extLst>
           </p:cNvPr>
@@ -5268,7 +5268,7 @@
           <p:cNvPr id="44" name="">
             <a:extLst xmlns:a="http://schemas.openxmlformats.org/drawingml/2006/main">
               <a:ext uri="{FF2B5EF4-FFF2-40B4-BE49-F238E27FC236}">
-                <a16:creationId xmlns:a16="http://schemas.microsoft.com/office/drawing/2014/main" id="{9BC07D5C-E981-47FE-A09B-44A38E131422}"/>
+                <a16:creationId xmlns:a16="http://schemas.microsoft.com/office/drawing/2014/main" id="{5B86B71C-ACAD-4695-8A43-33707D368998}"/>
               </a:ext>
             </a:extLst>
           </p:cNvPr>
@@ -5332,7 +5332,7 @@
           <p:cNvPr id="45" name="">
             <a:extLst xmlns:a="http://schemas.openxmlformats.org/drawingml/2006/main">
               <a:ext uri="{FF2B5EF4-FFF2-40B4-BE49-F238E27FC236}">
-                <a16:creationId xmlns:a16="http://schemas.microsoft.com/office/drawing/2014/main" id="{40EC8EE4-D0C8-4251-B6E0-2A0CD08C8F38}"/>
+                <a16:creationId xmlns:a16="http://schemas.microsoft.com/office/drawing/2014/main" id="{22D5F221-F84D-43B8-8228-4AC029DE8BDA}"/>
               </a:ext>
             </a:extLst>
           </p:cNvPr>
@@ -5367,7 +5367,7 @@
           <p:cNvPr id="46" name="">
             <a:extLst xmlns:a="http://schemas.openxmlformats.org/drawingml/2006/main">
               <a:ext uri="{FF2B5EF4-FFF2-40B4-BE49-F238E27FC236}">
-                <a16:creationId xmlns:a16="http://schemas.microsoft.com/office/drawing/2014/main" id="{CB8E86AC-5661-43D3-8D9D-A379C845FE52}"/>
+                <a16:creationId xmlns:a16="http://schemas.microsoft.com/office/drawing/2014/main" id="{A2DD73B2-56A5-406F-A671-EBC43C6A2876}"/>
               </a:ext>
             </a:extLst>
           </p:cNvPr>
@@ -5431,7 +5431,7 @@
           <p:cNvPr id="47" name="">
             <a:extLst xmlns:a="http://schemas.openxmlformats.org/drawingml/2006/main">
               <a:ext uri="{FF2B5EF4-FFF2-40B4-BE49-F238E27FC236}">
-                <a16:creationId xmlns:a16="http://schemas.microsoft.com/office/drawing/2014/main" id="{ABC6F41E-273F-448A-A1E0-25B40E7A0188}"/>
+                <a16:creationId xmlns:a16="http://schemas.microsoft.com/office/drawing/2014/main" id="{C2F91FF2-D4B3-45DF-8C6B-1CD2EC009541}"/>
               </a:ext>
             </a:extLst>
           </p:cNvPr>
@@ -5464,7 +5464,7 @@
           <p:cNvPr id="48" name="">
             <a:extLst xmlns:a="http://schemas.openxmlformats.org/drawingml/2006/main">
               <a:ext uri="{FF2B5EF4-FFF2-40B4-BE49-F238E27FC236}">
-                <a16:creationId xmlns:a16="http://schemas.microsoft.com/office/drawing/2014/main" id="{1987DC24-8857-4631-B1CC-179A447486C7}"/>
+                <a16:creationId xmlns:a16="http://schemas.microsoft.com/office/drawing/2014/main" id="{14EDE762-7DBD-46FC-856F-38C8523A689F}"/>
               </a:ext>
             </a:extLst>
           </p:cNvPr>
@@ -5497,7 +5497,7 @@
           <p:cNvPr id="49" name="">
             <a:extLst xmlns:a="http://schemas.openxmlformats.org/drawingml/2006/main">
               <a:ext uri="{FF2B5EF4-FFF2-40B4-BE49-F238E27FC236}">
-                <a16:creationId xmlns:a16="http://schemas.microsoft.com/office/drawing/2014/main" id="{0508C410-5853-4C44-A1A3-19230A32D035}"/>
+                <a16:creationId xmlns:a16="http://schemas.microsoft.com/office/drawing/2014/main" id="{67ED4AFF-17B9-4208-9F7C-42BE1E92BE2D}"/>
               </a:ext>
             </a:extLst>
           </p:cNvPr>
@@ -5561,7 +5561,7 @@
           <p:cNvPr id="50" name="">
             <a:extLst xmlns:a="http://schemas.openxmlformats.org/drawingml/2006/main">
               <a:ext uri="{FF2B5EF4-FFF2-40B4-BE49-F238E27FC236}">
-                <a16:creationId xmlns:a16="http://schemas.microsoft.com/office/drawing/2014/main" id="{752AB02E-F3B7-4D7C-B006-E4AAC0FB2341}"/>
+                <a16:creationId xmlns:a16="http://schemas.microsoft.com/office/drawing/2014/main" id="{B2A9277E-E95B-4CDB-B585-7B5110B26A6C}"/>
               </a:ext>
             </a:extLst>
           </p:cNvPr>
@@ -5596,7 +5596,7 @@
           <p:cNvPr id="51" name="">
             <a:extLst xmlns:a="http://schemas.openxmlformats.org/drawingml/2006/main">
               <a:ext uri="{FF2B5EF4-FFF2-40B4-BE49-F238E27FC236}">
-                <a16:creationId xmlns:a16="http://schemas.microsoft.com/office/drawing/2014/main" id="{2CB23A0D-75E1-4C3B-B172-54D7A5668B35}"/>
+                <a16:creationId xmlns:a16="http://schemas.microsoft.com/office/drawing/2014/main" id="{AD7160BF-4D9C-4D6B-B903-BC52A0819ED9}"/>
               </a:ext>
             </a:extLst>
           </p:cNvPr>
@@ -5660,7 +5660,7 @@
           <p:cNvPr id="52" name="">
             <a:extLst xmlns:a="http://schemas.openxmlformats.org/drawingml/2006/main">
               <a:ext uri="{FF2B5EF4-FFF2-40B4-BE49-F238E27FC236}">
-                <a16:creationId xmlns:a16="http://schemas.microsoft.com/office/drawing/2014/main" id="{490E8E89-3BB3-4DE1-9145-43FB9E5A822E}"/>
+                <a16:creationId xmlns:a16="http://schemas.microsoft.com/office/drawing/2014/main" id="{639B5BEF-5730-46CB-81E7-2E7C168F24EA}"/>
               </a:ext>
             </a:extLst>
           </p:cNvPr>
@@ -5695,7 +5695,7 @@
           <p:cNvPr id="53" name="">
             <a:extLst xmlns:a="http://schemas.openxmlformats.org/drawingml/2006/main">
               <a:ext uri="{FF2B5EF4-FFF2-40B4-BE49-F238E27FC236}">
-                <a16:creationId xmlns:a16="http://schemas.microsoft.com/office/drawing/2014/main" id="{2B29C598-0CB7-4D14-B1FE-1A2C47B89BFB}"/>
+                <a16:creationId xmlns:a16="http://schemas.microsoft.com/office/drawing/2014/main" id="{D0B34CFF-CE74-4C92-8625-37F27B9835FE}"/>
               </a:ext>
             </a:extLst>
           </p:cNvPr>
@@ -5759,7 +5759,7 @@
           <p:cNvPr id="54" name="">
             <a:extLst xmlns:a="http://schemas.openxmlformats.org/drawingml/2006/main">
               <a:ext uri="{FF2B5EF4-FFF2-40B4-BE49-F238E27FC236}">
-                <a16:creationId xmlns:a16="http://schemas.microsoft.com/office/drawing/2014/main" id="{4A4760EC-E08E-47FA-9CE7-1A09091E6212}"/>
+                <a16:creationId xmlns:a16="http://schemas.microsoft.com/office/drawing/2014/main" id="{F25F8BEB-2BE4-4A30-8638-0BFB87BE1941}"/>
               </a:ext>
             </a:extLst>
           </p:cNvPr>
@@ -5794,7 +5794,7 @@
           <p:cNvPr id="55" name="">
             <a:extLst xmlns:a="http://schemas.openxmlformats.org/drawingml/2006/main">
               <a:ext uri="{FF2B5EF4-FFF2-40B4-BE49-F238E27FC236}">
-                <a16:creationId xmlns:a16="http://schemas.microsoft.com/office/drawing/2014/main" id="{3DFD7C3C-63C2-4C33-86C6-0780EAAF9658}"/>
+                <a16:creationId xmlns:a16="http://schemas.microsoft.com/office/drawing/2014/main" id="{47B13987-22CC-497C-BFF0-4ECE9786AEB9}"/>
               </a:ext>
             </a:extLst>
           </p:cNvPr>
@@ -5858,7 +5858,7 @@
           <p:cNvPr id="56" name="">
             <a:extLst xmlns:a="http://schemas.openxmlformats.org/drawingml/2006/main">
               <a:ext uri="{FF2B5EF4-FFF2-40B4-BE49-F238E27FC236}">
-                <a16:creationId xmlns:a16="http://schemas.microsoft.com/office/drawing/2014/main" id="{34712856-CC20-494F-8897-5F1E0297C38F}"/>
+                <a16:creationId xmlns:a16="http://schemas.microsoft.com/office/drawing/2014/main" id="{C33DAD97-A7E7-47F7-A08C-148C28F28281}"/>
               </a:ext>
             </a:extLst>
           </p:cNvPr>
@@ -5922,7 +5922,7 @@
           <p:cNvPr id="57" name="">
             <a:extLst xmlns:a="http://schemas.openxmlformats.org/drawingml/2006/main">
               <a:ext uri="{FF2B5EF4-FFF2-40B4-BE49-F238E27FC236}">
-                <a16:creationId xmlns:a16="http://schemas.microsoft.com/office/drawing/2014/main" id="{44FD96F2-DA5B-435B-A122-06F6C90C55DB}"/>
+                <a16:creationId xmlns:a16="http://schemas.microsoft.com/office/drawing/2014/main" id="{5C709CC9-08F8-4554-95CD-5416FB9392D8}"/>
               </a:ext>
             </a:extLst>
           </p:cNvPr>
@@ -5957,7 +5957,7 @@
           <p:cNvPr id="58" name="">
             <a:extLst xmlns:a="http://schemas.openxmlformats.org/drawingml/2006/main">
               <a:ext uri="{FF2B5EF4-FFF2-40B4-BE49-F238E27FC236}">
-                <a16:creationId xmlns:a16="http://schemas.microsoft.com/office/drawing/2014/main" id="{526CAEDD-95D7-4AAF-90FE-D8B92F0006F8}"/>
+                <a16:creationId xmlns:a16="http://schemas.microsoft.com/office/drawing/2014/main" id="{CEB9E775-2056-49DA-BBBD-C8671BEFC098}"/>
               </a:ext>
             </a:extLst>
           </p:cNvPr>
@@ -6021,7 +6021,7 @@
           <p:cNvPr id="59" name="">
             <a:extLst xmlns:a="http://schemas.openxmlformats.org/drawingml/2006/main">
               <a:ext uri="{FF2B5EF4-FFF2-40B4-BE49-F238E27FC236}">
-                <a16:creationId xmlns:a16="http://schemas.microsoft.com/office/drawing/2014/main" id="{B9972BBA-1541-4968-AECE-ADCCBF66D9FA}"/>
+                <a16:creationId xmlns:a16="http://schemas.microsoft.com/office/drawing/2014/main" id="{06BCBEA2-BE3B-4967-84FE-CD85634F48B0}"/>
               </a:ext>
             </a:extLst>
           </p:cNvPr>
@@ -6083,7 +6083,7 @@
     </p:spTree>
     <p:extLst>
       <p:ext uri="{BB962C8B-B14F-4D97-AF65-F5344CB8AC3E}">
-        <p14:creationId xmlns:p14="http://schemas.microsoft.com/office/powerpoint/2010/main" val="334425797"/>
+        <p14:creationId xmlns:p14="http://schemas.microsoft.com/office/powerpoint/2010/main" val="707276375"/>
       </p:ext>
     </p:extLst>
   </p:cSld>
@@ -6107,7 +6107,7 @@
           <p:cNvPr id="1" name="">
             <a:extLst xmlns:a="http://schemas.openxmlformats.org/drawingml/2006/main">
               <a:ext uri="{FF2B5EF4-FFF2-40B4-BE49-F238E27FC236}">
-                <a16:creationId xmlns:a16="http://schemas.microsoft.com/office/drawing/2014/main" id="{3693129F-A536-481A-BD61-556F000BC642}"/>
+                <a16:creationId xmlns:a16="http://schemas.microsoft.com/office/drawing/2014/main" id="{F9F37475-92ED-4A03-B707-DFEAE3D5E8A1}"/>
               </a:ext>
             </a:extLst>
           </p:cNvPr>
@@ -6142,7 +6142,7 @@
           <p:cNvPr id="2" name="">
             <a:extLst xmlns:a="http://schemas.openxmlformats.org/drawingml/2006/main">
               <a:ext uri="{FF2B5EF4-FFF2-40B4-BE49-F238E27FC236}">
-                <a16:creationId xmlns:a16="http://schemas.microsoft.com/office/drawing/2014/main" id="{18104EDD-DA7C-4834-80E7-B6B13CDCE2F9}"/>
+                <a16:creationId xmlns:a16="http://schemas.microsoft.com/office/drawing/2014/main" id="{FF3E37F1-17F7-4D1C-A6E8-15D2C34CD70A}"/>
               </a:ext>
             </a:extLst>
           </p:cNvPr>
@@ -6177,7 +6177,7 @@
           <p:cNvPr id="3" name="">
             <a:extLst xmlns:a="http://schemas.openxmlformats.org/drawingml/2006/main">
               <a:ext uri="{FF2B5EF4-FFF2-40B4-BE49-F238E27FC236}">
-                <a16:creationId xmlns:a16="http://schemas.microsoft.com/office/drawing/2014/main" id="{9C73D179-3B0C-44F7-929F-70B4D3B0AF1D}"/>
+                <a16:creationId xmlns:a16="http://schemas.microsoft.com/office/drawing/2014/main" id="{4852B0AF-B1D8-4BF3-B336-D6E919502A17}"/>
               </a:ext>
             </a:extLst>
           </p:cNvPr>
@@ -6241,7 +6241,7 @@
           <p:cNvPr id="4" name="">
             <a:extLst xmlns:a="http://schemas.openxmlformats.org/drawingml/2006/main">
               <a:ext uri="{FF2B5EF4-FFF2-40B4-BE49-F238E27FC236}">
-                <a16:creationId xmlns:a16="http://schemas.microsoft.com/office/drawing/2014/main" id="{9DDF173F-5DD0-4D1E-8A4B-42135DB1CD59}"/>
+                <a16:creationId xmlns:a16="http://schemas.microsoft.com/office/drawing/2014/main" id="{61C524FA-77E9-4142-A92F-4CC5DF5D3904}"/>
               </a:ext>
             </a:extLst>
           </p:cNvPr>
@@ -6305,7 +6305,7 @@
           <p:cNvPr id="5" name="">
             <a:extLst xmlns:a="http://schemas.openxmlformats.org/drawingml/2006/main">
               <a:ext uri="{FF2B5EF4-FFF2-40B4-BE49-F238E27FC236}">
-                <a16:creationId xmlns:a16="http://schemas.microsoft.com/office/drawing/2014/main" id="{568220F2-A7B1-4E3B-BF2A-31D13AA69F8B}"/>
+                <a16:creationId xmlns:a16="http://schemas.microsoft.com/office/drawing/2014/main" id="{E2FE2F34-28F6-4696-9364-2A6D03151231}"/>
               </a:ext>
             </a:extLst>
           </p:cNvPr>
@@ -6369,7 +6369,7 @@
           <p:cNvPr id="6" name="">
             <a:extLst xmlns:a="http://schemas.openxmlformats.org/drawingml/2006/main">
               <a:ext uri="{FF2B5EF4-FFF2-40B4-BE49-F238E27FC236}">
-                <a16:creationId xmlns:a16="http://schemas.microsoft.com/office/drawing/2014/main" id="{1B06EB22-B09A-40AC-AB33-4E0E27842AEE}"/>
+                <a16:creationId xmlns:a16="http://schemas.microsoft.com/office/drawing/2014/main" id="{FA5BABC8-C61A-4430-8A10-49E02FAB2F4B}"/>
               </a:ext>
             </a:extLst>
           </p:cNvPr>
@@ -6402,7 +6402,7 @@
           <p:cNvPr id="7" name="">
             <a:extLst xmlns:a="http://schemas.openxmlformats.org/drawingml/2006/main">
               <a:ext uri="{FF2B5EF4-FFF2-40B4-BE49-F238E27FC236}">
-                <a16:creationId xmlns:a16="http://schemas.microsoft.com/office/drawing/2014/main" id="{CB6E72FB-6DB8-4444-82D4-6B9D5B80D9F7}"/>
+                <a16:creationId xmlns:a16="http://schemas.microsoft.com/office/drawing/2014/main" id="{DCFD5408-E98B-47C1-98FF-E56BEEDE6AC4}"/>
               </a:ext>
             </a:extLst>
           </p:cNvPr>
@@ -6466,7 +6466,7 @@
           <p:cNvPr id="8" name="">
             <a:extLst xmlns:a="http://schemas.openxmlformats.org/drawingml/2006/main">
               <a:ext uri="{FF2B5EF4-FFF2-40B4-BE49-F238E27FC236}">
-                <a16:creationId xmlns:a16="http://schemas.microsoft.com/office/drawing/2014/main" id="{5BC23054-12AC-43B3-8584-4599C3BBE2F8}"/>
+                <a16:creationId xmlns:a16="http://schemas.microsoft.com/office/drawing/2014/main" id="{53B3CCF5-B9FC-4C61-93E6-291502D70663}"/>
               </a:ext>
             </a:extLst>
           </p:cNvPr>
@@ -6530,7 +6530,7 @@
           <p:cNvPr id="9" name="">
             <a:extLst xmlns:a="http://schemas.openxmlformats.org/drawingml/2006/main">
               <a:ext uri="{FF2B5EF4-FFF2-40B4-BE49-F238E27FC236}">
-                <a16:creationId xmlns:a16="http://schemas.microsoft.com/office/drawing/2014/main" id="{5D855353-D0E7-4FE4-A277-048C864DF2D2}"/>
+                <a16:creationId xmlns:a16="http://schemas.microsoft.com/office/drawing/2014/main" id="{6C0AD45C-06F0-4573-A7ED-0E2362BC6199}"/>
               </a:ext>
             </a:extLst>
           </p:cNvPr>
@@ -6563,7 +6563,7 @@
           <p:cNvPr id="10" name="">
             <a:extLst xmlns:a="http://schemas.openxmlformats.org/drawingml/2006/main">
               <a:ext uri="{FF2B5EF4-FFF2-40B4-BE49-F238E27FC236}">
-                <a16:creationId xmlns:a16="http://schemas.microsoft.com/office/drawing/2014/main" id="{41102B44-3C0E-46F9-9697-9055D6B35E4C}"/>
+                <a16:creationId xmlns:a16="http://schemas.microsoft.com/office/drawing/2014/main" id="{9FD08B14-18E5-4631-9FC9-5E61D92A9E4D}"/>
               </a:ext>
             </a:extLst>
           </p:cNvPr>
@@ -6627,7 +6627,7 @@
           <p:cNvPr id="11" name="">
             <a:extLst xmlns:a="http://schemas.openxmlformats.org/drawingml/2006/main">
               <a:ext uri="{FF2B5EF4-FFF2-40B4-BE49-F238E27FC236}">
-                <a16:creationId xmlns:a16="http://schemas.microsoft.com/office/drawing/2014/main" id="{61F0E933-7839-4AF7-A8E0-8A29670CC0A3}"/>
+                <a16:creationId xmlns:a16="http://schemas.microsoft.com/office/drawing/2014/main" id="{B8CF8946-06BD-4363-959F-2FA7C594FF79}"/>
               </a:ext>
             </a:extLst>
           </p:cNvPr>
@@ -6691,7 +6691,7 @@
           <p:cNvPr id="12" name="">
             <a:extLst xmlns:a="http://schemas.openxmlformats.org/drawingml/2006/main">
               <a:ext uri="{FF2B5EF4-FFF2-40B4-BE49-F238E27FC236}">
-                <a16:creationId xmlns:a16="http://schemas.microsoft.com/office/drawing/2014/main" id="{7B605517-75EA-4AE2-A999-7CA531CBB408}"/>
+                <a16:creationId xmlns:a16="http://schemas.microsoft.com/office/drawing/2014/main" id="{9D011424-F03B-455D-B391-2635D62B3B74}"/>
               </a:ext>
             </a:extLst>
           </p:cNvPr>
@@ -6724,7 +6724,7 @@
           <p:cNvPr id="13" name="">
             <a:extLst xmlns:a="http://schemas.openxmlformats.org/drawingml/2006/main">
               <a:ext uri="{FF2B5EF4-FFF2-40B4-BE49-F238E27FC236}">
-                <a16:creationId xmlns:a16="http://schemas.microsoft.com/office/drawing/2014/main" id="{1B357B7F-91BF-4474-8865-D3F67A5FB068}"/>
+                <a16:creationId xmlns:a16="http://schemas.microsoft.com/office/drawing/2014/main" id="{953EA054-BC89-41FE-A62F-580B32C02437}"/>
               </a:ext>
             </a:extLst>
           </p:cNvPr>
@@ -6788,7 +6788,7 @@
           <p:cNvPr id="14" name="">
             <a:extLst xmlns:a="http://schemas.openxmlformats.org/drawingml/2006/main">
               <a:ext uri="{FF2B5EF4-FFF2-40B4-BE49-F238E27FC236}">
-                <a16:creationId xmlns:a16="http://schemas.microsoft.com/office/drawing/2014/main" id="{5FF1D5AA-2C48-4EDE-9921-A58D8F94F489}"/>
+                <a16:creationId xmlns:a16="http://schemas.microsoft.com/office/drawing/2014/main" id="{CBC6D052-B8CA-4C71-BBE5-6806A1D790C0}"/>
               </a:ext>
             </a:extLst>
           </p:cNvPr>
@@ -6852,7 +6852,7 @@
           <p:cNvPr id="15" name="">
             <a:extLst xmlns:a="http://schemas.openxmlformats.org/drawingml/2006/main">
               <a:ext uri="{FF2B5EF4-FFF2-40B4-BE49-F238E27FC236}">
-                <a16:creationId xmlns:a16="http://schemas.microsoft.com/office/drawing/2014/main" id="{5D629C54-AAEB-4C32-BE5A-5ED3B75EED42}"/>
+                <a16:creationId xmlns:a16="http://schemas.microsoft.com/office/drawing/2014/main" id="{7083A9FB-A7D4-4BBC-BE0C-236056E39AD3}"/>
               </a:ext>
             </a:extLst>
           </p:cNvPr>
@@ -6887,7 +6887,7 @@
           <p:cNvPr id="16" name="">
             <a:extLst xmlns:a="http://schemas.openxmlformats.org/drawingml/2006/main">
               <a:ext uri="{FF2B5EF4-FFF2-40B4-BE49-F238E27FC236}">
-                <a16:creationId xmlns:a16="http://schemas.microsoft.com/office/drawing/2014/main" id="{297FDB41-B86B-4F9B-9AF7-5B76865963A2}"/>
+                <a16:creationId xmlns:a16="http://schemas.microsoft.com/office/drawing/2014/main" id="{836315A9-F311-462E-942A-98AAC7D85420}"/>
               </a:ext>
             </a:extLst>
           </p:cNvPr>
@@ -6922,7 +6922,7 @@
           <p:cNvPr id="17" name="">
             <a:extLst xmlns:a="http://schemas.openxmlformats.org/drawingml/2006/main">
               <a:ext uri="{FF2B5EF4-FFF2-40B4-BE49-F238E27FC236}">
-                <a16:creationId xmlns:a16="http://schemas.microsoft.com/office/drawing/2014/main" id="{80FB7CDA-0D21-470C-BC82-18A727C95D70}"/>
+                <a16:creationId xmlns:a16="http://schemas.microsoft.com/office/drawing/2014/main" id="{ACB5283B-56EC-43C2-B01B-38EA0BCF1D78}"/>
               </a:ext>
             </a:extLst>
           </p:cNvPr>
@@ -6955,7 +6955,7 @@
           <p:cNvPr id="18" name="">
             <a:extLst xmlns:a="http://schemas.openxmlformats.org/drawingml/2006/main">
               <a:ext uri="{FF2B5EF4-FFF2-40B4-BE49-F238E27FC236}">
-                <a16:creationId xmlns:a16="http://schemas.microsoft.com/office/drawing/2014/main" id="{4C5AE80D-1244-434F-8680-D8B101525F4B}"/>
+                <a16:creationId xmlns:a16="http://schemas.microsoft.com/office/drawing/2014/main" id="{0EB72112-A55A-4AA9-9A79-C533AC9FE2BA}"/>
               </a:ext>
             </a:extLst>
           </p:cNvPr>
@@ -7019,7 +7019,7 @@
           <p:cNvPr id="19" name="">
             <a:extLst xmlns:a="http://schemas.openxmlformats.org/drawingml/2006/main">
               <a:ext uri="{FF2B5EF4-FFF2-40B4-BE49-F238E27FC236}">
-                <a16:creationId xmlns:a16="http://schemas.microsoft.com/office/drawing/2014/main" id="{C350B93B-F646-4EE0-93B7-7B2BCD128739}"/>
+                <a16:creationId xmlns:a16="http://schemas.microsoft.com/office/drawing/2014/main" id="{11E917E1-62E1-42C8-B496-AC4ACCCB8F87}"/>
               </a:ext>
             </a:extLst>
           </p:cNvPr>
@@ -7083,7 +7083,7 @@
           <p:cNvPr id="20" name="">
             <a:extLst xmlns:a="http://schemas.openxmlformats.org/drawingml/2006/main">
               <a:ext uri="{FF2B5EF4-FFF2-40B4-BE49-F238E27FC236}">
-                <a16:creationId xmlns:a16="http://schemas.microsoft.com/office/drawing/2014/main" id="{F60CFD6F-00D9-4857-A2BB-BC3CE136F17E}"/>
+                <a16:creationId xmlns:a16="http://schemas.microsoft.com/office/drawing/2014/main" id="{2946867B-B8F3-4BF5-8411-E888349E4511}"/>
               </a:ext>
             </a:extLst>
           </p:cNvPr>
@@ -7118,7 +7118,7 @@
           <p:cNvPr id="21" name="">
             <a:extLst xmlns:a="http://schemas.openxmlformats.org/drawingml/2006/main">
               <a:ext uri="{FF2B5EF4-FFF2-40B4-BE49-F238E27FC236}">
-                <a16:creationId xmlns:a16="http://schemas.microsoft.com/office/drawing/2014/main" id="{C4E3280E-89C9-4AB3-B59D-D31723890D73}"/>
+                <a16:creationId xmlns:a16="http://schemas.microsoft.com/office/drawing/2014/main" id="{6BA754DB-125C-42B7-9D4B-AA397DE479CC}"/>
               </a:ext>
             </a:extLst>
           </p:cNvPr>
@@ -7182,7 +7182,7 @@
           <p:cNvPr id="22" name="">
             <a:extLst xmlns:a="http://schemas.openxmlformats.org/drawingml/2006/main">
               <a:ext uri="{FF2B5EF4-FFF2-40B4-BE49-F238E27FC236}">
-                <a16:creationId xmlns:a16="http://schemas.microsoft.com/office/drawing/2014/main" id="{EABA35C3-B65D-4D98-8FED-502D3173FD20}"/>
+                <a16:creationId xmlns:a16="http://schemas.microsoft.com/office/drawing/2014/main" id="{7D973429-96A2-483A-BEAB-FA54E50C7C50}"/>
               </a:ext>
             </a:extLst>
           </p:cNvPr>
@@ -7244,7 +7244,7 @@
     </p:spTree>
     <p:extLst>
       <p:ext uri="{BB962C8B-B14F-4D97-AF65-F5344CB8AC3E}">
-        <p14:creationId xmlns:p14="http://schemas.microsoft.com/office/powerpoint/2010/main" val="1364606487"/>
+        <p14:creationId xmlns:p14="http://schemas.microsoft.com/office/powerpoint/2010/main" val="2025943560"/>
       </p:ext>
     </p:extLst>
   </p:cSld>
@@ -7268,7 +7268,7 @@
           <p:cNvPr id="1" name="">
             <a:extLst xmlns:a="http://schemas.openxmlformats.org/drawingml/2006/main">
               <a:ext uri="{FF2B5EF4-FFF2-40B4-BE49-F238E27FC236}">
-                <a16:creationId xmlns:a16="http://schemas.microsoft.com/office/drawing/2014/main" id="{170FFBB5-31C6-4DC0-9789-675AB410CCCD}"/>
+                <a16:creationId xmlns:a16="http://schemas.microsoft.com/office/drawing/2014/main" id="{0B931618-FF2F-4DF8-AF97-D6BFD209DD7E}"/>
               </a:ext>
             </a:extLst>
           </p:cNvPr>
@@ -7303,7 +7303,7 @@
           <p:cNvPr id="2" name="">
             <a:extLst xmlns:a="http://schemas.openxmlformats.org/drawingml/2006/main">
               <a:ext uri="{FF2B5EF4-FFF2-40B4-BE49-F238E27FC236}">
-                <a16:creationId xmlns:a16="http://schemas.microsoft.com/office/drawing/2014/main" id="{2D8DE176-2086-44EF-AA60-87DAB0E6D209}"/>
+                <a16:creationId xmlns:a16="http://schemas.microsoft.com/office/drawing/2014/main" id="{99A06C94-9101-468D-B1CF-A806163872D6}"/>
               </a:ext>
             </a:extLst>
           </p:cNvPr>
@@ -7338,7 +7338,7 @@
           <p:cNvPr id="3" name="">
             <a:extLst xmlns:a="http://schemas.openxmlformats.org/drawingml/2006/main">
               <a:ext uri="{FF2B5EF4-FFF2-40B4-BE49-F238E27FC236}">
-                <a16:creationId xmlns:a16="http://schemas.microsoft.com/office/drawing/2014/main" id="{81E8EA12-159C-43A4-B3A0-F1703ADDF9E9}"/>
+                <a16:creationId xmlns:a16="http://schemas.microsoft.com/office/drawing/2014/main" id="{DB62FD52-9BA0-4CCA-A1EB-3F9F90D3F1C8}"/>
               </a:ext>
             </a:extLst>
           </p:cNvPr>
@@ -7402,7 +7402,7 @@
           <p:cNvPr id="4" name="">
             <a:extLst xmlns:a="http://schemas.openxmlformats.org/drawingml/2006/main">
               <a:ext uri="{FF2B5EF4-FFF2-40B4-BE49-F238E27FC236}">
-                <a16:creationId xmlns:a16="http://schemas.microsoft.com/office/drawing/2014/main" id="{7FC5AF25-C54D-4332-9ED5-A1C6958B6F28}"/>
+                <a16:creationId xmlns:a16="http://schemas.microsoft.com/office/drawing/2014/main" id="{4562D6B6-0FEB-45BA-A9D0-2E36A45D49D3}"/>
               </a:ext>
             </a:extLst>
           </p:cNvPr>
@@ -7466,7 +7466,7 @@
           <p:cNvPr id="5" name="">
             <a:extLst xmlns:a="http://schemas.openxmlformats.org/drawingml/2006/main">
               <a:ext uri="{FF2B5EF4-FFF2-40B4-BE49-F238E27FC236}">
-                <a16:creationId xmlns:a16="http://schemas.microsoft.com/office/drawing/2014/main" id="{4579A52C-2422-4407-937D-D36D29605EBF}"/>
+                <a16:creationId xmlns:a16="http://schemas.microsoft.com/office/drawing/2014/main" id="{EAF88F32-BBDF-4EE8-9FCD-C14DC00AF25A}"/>
               </a:ext>
             </a:extLst>
           </p:cNvPr>
@@ -7530,7 +7530,7 @@
           <p:cNvPr id="6" name="">
             <a:extLst xmlns:a="http://schemas.openxmlformats.org/drawingml/2006/main">
               <a:ext uri="{FF2B5EF4-FFF2-40B4-BE49-F238E27FC236}">
-                <a16:creationId xmlns:a16="http://schemas.microsoft.com/office/drawing/2014/main" id="{7C50D07F-0B50-4C28-BA14-C135C7A3BB81}"/>
+                <a16:creationId xmlns:a16="http://schemas.microsoft.com/office/drawing/2014/main" id="{928EE042-4830-4C50-BCAA-23405F688BC4}"/>
               </a:ext>
             </a:extLst>
           </p:cNvPr>
@@ -7563,7 +7563,7 @@
           <p:cNvPr id="7" name="">
             <a:extLst xmlns:a="http://schemas.openxmlformats.org/drawingml/2006/main">
               <a:ext uri="{FF2B5EF4-FFF2-40B4-BE49-F238E27FC236}">
-                <a16:creationId xmlns:a16="http://schemas.microsoft.com/office/drawing/2014/main" id="{77F777C7-728E-4DD4-A5D9-FAE56AE7012F}"/>
+                <a16:creationId xmlns:a16="http://schemas.microsoft.com/office/drawing/2014/main" id="{65A91A4B-B7E9-46B4-B34C-CB41404A2459}"/>
               </a:ext>
             </a:extLst>
           </p:cNvPr>
@@ -7627,7 +7627,7 @@
           <p:cNvPr id="8" name="">
             <a:extLst xmlns:a="http://schemas.openxmlformats.org/drawingml/2006/main">
               <a:ext uri="{FF2B5EF4-FFF2-40B4-BE49-F238E27FC236}">
-                <a16:creationId xmlns:a16="http://schemas.microsoft.com/office/drawing/2014/main" id="{54FE0EE0-18A3-414D-B445-00AA158BEC67}"/>
+                <a16:creationId xmlns:a16="http://schemas.microsoft.com/office/drawing/2014/main" id="{516CFF08-4D0C-44B9-B5B8-FD5039EB2AA0}"/>
               </a:ext>
             </a:extLst>
           </p:cNvPr>
@@ -7691,7 +7691,7 @@
           <p:cNvPr id="9" name="">
             <a:extLst xmlns:a="http://schemas.openxmlformats.org/drawingml/2006/main">
               <a:ext uri="{FF2B5EF4-FFF2-40B4-BE49-F238E27FC236}">
-                <a16:creationId xmlns:a16="http://schemas.microsoft.com/office/drawing/2014/main" id="{F978DECF-6E35-422C-8864-7E29282DCD73}"/>
+                <a16:creationId xmlns:a16="http://schemas.microsoft.com/office/drawing/2014/main" id="{04BEA37F-14B9-4EB1-B701-45C8F05BAF38}"/>
               </a:ext>
             </a:extLst>
           </p:cNvPr>
@@ -7755,7 +7755,7 @@
           <p:cNvPr id="10" name="">
             <a:extLst xmlns:a="http://schemas.openxmlformats.org/drawingml/2006/main">
               <a:ext uri="{FF2B5EF4-FFF2-40B4-BE49-F238E27FC236}">
-                <a16:creationId xmlns:a16="http://schemas.microsoft.com/office/drawing/2014/main" id="{06B6DAB9-9E85-4ED2-BEA6-0321277AA254}"/>
+                <a16:creationId xmlns:a16="http://schemas.microsoft.com/office/drawing/2014/main" id="{6A448EB6-D5EE-4421-9248-2A683FE129AC}"/>
               </a:ext>
             </a:extLst>
           </p:cNvPr>
@@ -7788,7 +7788,7 @@
           <p:cNvPr id="11" name="">
             <a:extLst xmlns:a="http://schemas.openxmlformats.org/drawingml/2006/main">
               <a:ext uri="{FF2B5EF4-FFF2-40B4-BE49-F238E27FC236}">
-                <a16:creationId xmlns:a16="http://schemas.microsoft.com/office/drawing/2014/main" id="{F0A6611D-4B18-4F84-B731-4A282E24FDAD}"/>
+                <a16:creationId xmlns:a16="http://schemas.microsoft.com/office/drawing/2014/main" id="{3FEFCDC9-DE78-4C86-A223-309F6E9B2CB5}"/>
               </a:ext>
             </a:extLst>
           </p:cNvPr>
@@ -7852,7 +7852,7 @@
           <p:cNvPr id="12" name="">
             <a:extLst xmlns:a="http://schemas.openxmlformats.org/drawingml/2006/main">
               <a:ext uri="{FF2B5EF4-FFF2-40B4-BE49-F238E27FC236}">
-                <a16:creationId xmlns:a16="http://schemas.microsoft.com/office/drawing/2014/main" id="{425D4505-7245-46C2-8A34-6EEDF1025467}"/>
+                <a16:creationId xmlns:a16="http://schemas.microsoft.com/office/drawing/2014/main" id="{4F4A0ADC-DF09-475B-A656-C3D2FCDC4FA1}"/>
               </a:ext>
             </a:extLst>
           </p:cNvPr>
@@ -7916,7 +7916,7 @@
           <p:cNvPr id="13" name="">
             <a:extLst xmlns:a="http://schemas.openxmlformats.org/drawingml/2006/main">
               <a:ext uri="{FF2B5EF4-FFF2-40B4-BE49-F238E27FC236}">
-                <a16:creationId xmlns:a16="http://schemas.microsoft.com/office/drawing/2014/main" id="{253D5762-7195-4033-9997-EDB0A885AE52}"/>
+                <a16:creationId xmlns:a16="http://schemas.microsoft.com/office/drawing/2014/main" id="{BC3A3334-D357-40B1-938A-2A10B6E32B01}"/>
               </a:ext>
             </a:extLst>
           </p:cNvPr>
@@ -7980,7 +7980,7 @@
           <p:cNvPr id="14" name="">
             <a:extLst xmlns:a="http://schemas.openxmlformats.org/drawingml/2006/main">
               <a:ext uri="{FF2B5EF4-FFF2-40B4-BE49-F238E27FC236}">
-                <a16:creationId xmlns:a16="http://schemas.microsoft.com/office/drawing/2014/main" id="{E3FFB9D7-CA9C-4F7C-AF9A-A1A390413E3A}"/>
+                <a16:creationId xmlns:a16="http://schemas.microsoft.com/office/drawing/2014/main" id="{6FE21EE6-DAA3-4539-B438-5260CC6CFBB5}"/>
               </a:ext>
             </a:extLst>
           </p:cNvPr>
@@ -8013,7 +8013,7 @@
           <p:cNvPr id="15" name="">
             <a:extLst xmlns:a="http://schemas.openxmlformats.org/drawingml/2006/main">
               <a:ext uri="{FF2B5EF4-FFF2-40B4-BE49-F238E27FC236}">
-                <a16:creationId xmlns:a16="http://schemas.microsoft.com/office/drawing/2014/main" id="{3CE1740D-8C93-4A3D-954C-11D65141B328}"/>
+                <a16:creationId xmlns:a16="http://schemas.microsoft.com/office/drawing/2014/main" id="{70177B9B-941F-4051-A436-FB9301FBA069}"/>
               </a:ext>
             </a:extLst>
           </p:cNvPr>
@@ -8077,7 +8077,7 @@
           <p:cNvPr id="16" name="">
             <a:extLst xmlns:a="http://schemas.openxmlformats.org/drawingml/2006/main">
               <a:ext uri="{FF2B5EF4-FFF2-40B4-BE49-F238E27FC236}">
-                <a16:creationId xmlns:a16="http://schemas.microsoft.com/office/drawing/2014/main" id="{C5B671B9-5735-4D10-8946-7A3423E9681F}"/>
+                <a16:creationId xmlns:a16="http://schemas.microsoft.com/office/drawing/2014/main" id="{89C9DEEF-C070-45D8-95EF-468010BBD05B}"/>
               </a:ext>
             </a:extLst>
           </p:cNvPr>
@@ -8141,7 +8141,7 @@
           <p:cNvPr id="17" name="">
             <a:extLst xmlns:a="http://schemas.openxmlformats.org/drawingml/2006/main">
               <a:ext uri="{FF2B5EF4-FFF2-40B4-BE49-F238E27FC236}">
-                <a16:creationId xmlns:a16="http://schemas.microsoft.com/office/drawing/2014/main" id="{9AC44331-C927-4013-9CCF-BEC39C2C84D7}"/>
+                <a16:creationId xmlns:a16="http://schemas.microsoft.com/office/drawing/2014/main" id="{2899CB34-7E5B-4436-9DEF-8AD6E201FDEA}"/>
               </a:ext>
             </a:extLst>
           </p:cNvPr>
@@ -8205,7 +8205,7 @@
           <p:cNvPr id="18" name="">
             <a:extLst xmlns:a="http://schemas.openxmlformats.org/drawingml/2006/main">
               <a:ext uri="{FF2B5EF4-FFF2-40B4-BE49-F238E27FC236}">
-                <a16:creationId xmlns:a16="http://schemas.microsoft.com/office/drawing/2014/main" id="{42A61E3E-7449-4F5B-84C2-CABD17BE5384}"/>
+                <a16:creationId xmlns:a16="http://schemas.microsoft.com/office/drawing/2014/main" id="{800B274E-47D2-49E2-BBA1-E61766B264A1}"/>
               </a:ext>
             </a:extLst>
           </p:cNvPr>
@@ -8238,7 +8238,7 @@
           <p:cNvPr id="19" name="">
             <a:extLst xmlns:a="http://schemas.openxmlformats.org/drawingml/2006/main">
               <a:ext uri="{FF2B5EF4-FFF2-40B4-BE49-F238E27FC236}">
-                <a16:creationId xmlns:a16="http://schemas.microsoft.com/office/drawing/2014/main" id="{38F61DAA-8F82-48B1-9682-84C1D905CE79}"/>
+                <a16:creationId xmlns:a16="http://schemas.microsoft.com/office/drawing/2014/main" id="{6BD9F144-C8F6-464C-95FA-8F5A7F550A65}"/>
               </a:ext>
             </a:extLst>
           </p:cNvPr>
@@ -8302,7 +8302,7 @@
           <p:cNvPr id="20" name="">
             <a:extLst xmlns:a="http://schemas.openxmlformats.org/drawingml/2006/main">
               <a:ext uri="{FF2B5EF4-FFF2-40B4-BE49-F238E27FC236}">
-                <a16:creationId xmlns:a16="http://schemas.microsoft.com/office/drawing/2014/main" id="{9D5FB782-6454-4E57-AA09-B7A7E9CA7352}"/>
+                <a16:creationId xmlns:a16="http://schemas.microsoft.com/office/drawing/2014/main" id="{97A726AC-8DE8-44F9-B9E3-7320F011BEA0}"/>
               </a:ext>
             </a:extLst>
           </p:cNvPr>
@@ -8366,7 +8366,7 @@
           <p:cNvPr id="21" name="">
             <a:extLst xmlns:a="http://schemas.openxmlformats.org/drawingml/2006/main">
               <a:ext uri="{FF2B5EF4-FFF2-40B4-BE49-F238E27FC236}">
-                <a16:creationId xmlns:a16="http://schemas.microsoft.com/office/drawing/2014/main" id="{7D9923F1-3337-41B8-B5B0-3434022A834A}"/>
+                <a16:creationId xmlns:a16="http://schemas.microsoft.com/office/drawing/2014/main" id="{9584A50B-B36C-480B-BD9C-2E0E5B3E8E17}"/>
               </a:ext>
             </a:extLst>
           </p:cNvPr>
@@ -8430,7 +8430,7 @@
           <p:cNvPr id="22" name="">
             <a:extLst xmlns:a="http://schemas.openxmlformats.org/drawingml/2006/main">
               <a:ext uri="{FF2B5EF4-FFF2-40B4-BE49-F238E27FC236}">
-                <a16:creationId xmlns:a16="http://schemas.microsoft.com/office/drawing/2014/main" id="{2961759D-B201-4ACF-BCB3-B52E9BD31962}"/>
+                <a16:creationId xmlns:a16="http://schemas.microsoft.com/office/drawing/2014/main" id="{9625F201-BAE8-4D5A-A364-E205322FF3BE}"/>
               </a:ext>
             </a:extLst>
           </p:cNvPr>
@@ -8463,7 +8463,7 @@
           <p:cNvPr id="23" name="">
             <a:extLst xmlns:a="http://schemas.openxmlformats.org/drawingml/2006/main">
               <a:ext uri="{FF2B5EF4-FFF2-40B4-BE49-F238E27FC236}">
-                <a16:creationId xmlns:a16="http://schemas.microsoft.com/office/drawing/2014/main" id="{87867BC2-DEE4-46BF-B5C9-9C65BAD43CC0}"/>
+                <a16:creationId xmlns:a16="http://schemas.microsoft.com/office/drawing/2014/main" id="{629698A8-F6A8-45F7-8F62-E1CBFF1B84F2}"/>
               </a:ext>
             </a:extLst>
           </p:cNvPr>
@@ -8527,7 +8527,7 @@
           <p:cNvPr id="24" name="">
             <a:extLst xmlns:a="http://schemas.openxmlformats.org/drawingml/2006/main">
               <a:ext uri="{FF2B5EF4-FFF2-40B4-BE49-F238E27FC236}">
-                <a16:creationId xmlns:a16="http://schemas.microsoft.com/office/drawing/2014/main" id="{9B8C1690-0532-4367-A42D-262C29EB53F8}"/>
+                <a16:creationId xmlns:a16="http://schemas.microsoft.com/office/drawing/2014/main" id="{6DC615F4-0358-4FE0-BEC2-100C767124D0}"/>
               </a:ext>
             </a:extLst>
           </p:cNvPr>
@@ -8591,7 +8591,7 @@
           <p:cNvPr id="25" name="">
             <a:extLst xmlns:a="http://schemas.openxmlformats.org/drawingml/2006/main">
               <a:ext uri="{FF2B5EF4-FFF2-40B4-BE49-F238E27FC236}">
-                <a16:creationId xmlns:a16="http://schemas.microsoft.com/office/drawing/2014/main" id="{EC6D56F0-5A4F-49CD-B2BB-2D765555AF02}"/>
+                <a16:creationId xmlns:a16="http://schemas.microsoft.com/office/drawing/2014/main" id="{93DE9892-022F-4A7B-8EF7-2E3F71B69A74}"/>
               </a:ext>
             </a:extLst>
           </p:cNvPr>
@@ -8655,7 +8655,7 @@
           <p:cNvPr id="26" name="">
             <a:extLst xmlns:a="http://schemas.openxmlformats.org/drawingml/2006/main">
               <a:ext uri="{FF2B5EF4-FFF2-40B4-BE49-F238E27FC236}">
-                <a16:creationId xmlns:a16="http://schemas.microsoft.com/office/drawing/2014/main" id="{FBA698D2-1DC3-40C4-B784-F0B5AAC940BD}"/>
+                <a16:creationId xmlns:a16="http://schemas.microsoft.com/office/drawing/2014/main" id="{F3E3EB7C-9E18-4EDB-80B6-00C1DA329632}"/>
               </a:ext>
             </a:extLst>
           </p:cNvPr>
@@ -8688,7 +8688,7 @@
           <p:cNvPr id="27" name="">
             <a:extLst xmlns:a="http://schemas.openxmlformats.org/drawingml/2006/main">
               <a:ext uri="{FF2B5EF4-FFF2-40B4-BE49-F238E27FC236}">
-                <a16:creationId xmlns:a16="http://schemas.microsoft.com/office/drawing/2014/main" id="{B90B0ADE-4577-4A65-A1BB-704C0B302A29}"/>
+                <a16:creationId xmlns:a16="http://schemas.microsoft.com/office/drawing/2014/main" id="{7DE709B3-EA29-44E2-B3EA-5893B1868A7D}"/>
               </a:ext>
             </a:extLst>
           </p:cNvPr>
@@ -8721,7 +8721,7 @@
           <p:cNvPr id="28" name="">
             <a:extLst xmlns:a="http://schemas.openxmlformats.org/drawingml/2006/main">
               <a:ext uri="{FF2B5EF4-FFF2-40B4-BE49-F238E27FC236}">
-                <a16:creationId xmlns:a16="http://schemas.microsoft.com/office/drawing/2014/main" id="{F1BA974B-C41A-4B4C-86C0-C3ACF73B5291}"/>
+                <a16:creationId xmlns:a16="http://schemas.microsoft.com/office/drawing/2014/main" id="{4DAD1619-AE28-4F5C-B7D3-BF989A69214E}"/>
               </a:ext>
             </a:extLst>
           </p:cNvPr>
@@ -8785,7 +8785,7 @@
           <p:cNvPr id="29" name="">
             <a:extLst xmlns:a="http://schemas.openxmlformats.org/drawingml/2006/main">
               <a:ext uri="{FF2B5EF4-FFF2-40B4-BE49-F238E27FC236}">
-                <a16:creationId xmlns:a16="http://schemas.microsoft.com/office/drawing/2014/main" id="{18552E02-3B75-4A4F-BCB4-A7E14B50BAB5}"/>
+                <a16:creationId xmlns:a16="http://schemas.microsoft.com/office/drawing/2014/main" id="{1A43B7EA-7E0B-422F-B36B-6CD751987978}"/>
               </a:ext>
             </a:extLst>
           </p:cNvPr>
@@ -8849,7 +8849,7 @@
           <p:cNvPr id="30" name="">
             <a:extLst xmlns:a="http://schemas.openxmlformats.org/drawingml/2006/main">
               <a:ext uri="{FF2B5EF4-FFF2-40B4-BE49-F238E27FC236}">
-                <a16:creationId xmlns:a16="http://schemas.microsoft.com/office/drawing/2014/main" id="{558956DF-E555-4F27-8947-CB851F5E22CC}"/>
+                <a16:creationId xmlns:a16="http://schemas.microsoft.com/office/drawing/2014/main" id="{2151310F-71AB-4728-A197-B6CCE40D9CEA}"/>
               </a:ext>
             </a:extLst>
           </p:cNvPr>
@@ -8913,7 +8913,7 @@
           <p:cNvPr id="31" name="">
             <a:extLst xmlns:a="http://schemas.openxmlformats.org/drawingml/2006/main">
               <a:ext uri="{FF2B5EF4-FFF2-40B4-BE49-F238E27FC236}">
-                <a16:creationId xmlns:a16="http://schemas.microsoft.com/office/drawing/2014/main" id="{C8D9D78A-A7A1-4581-BDD7-5C3F784B4198}"/>
+                <a16:creationId xmlns:a16="http://schemas.microsoft.com/office/drawing/2014/main" id="{413DFE9B-82AB-48F2-AF68-00B98E31E3E8}"/>
               </a:ext>
             </a:extLst>
           </p:cNvPr>
@@ -8977,7 +8977,7 @@
           <p:cNvPr id="32" name="">
             <a:extLst xmlns:a="http://schemas.openxmlformats.org/drawingml/2006/main">
               <a:ext uri="{FF2B5EF4-FFF2-40B4-BE49-F238E27FC236}">
-                <a16:creationId xmlns:a16="http://schemas.microsoft.com/office/drawing/2014/main" id="{E250A72E-FE9D-4EA9-81D4-9474CF4254E8}"/>
+                <a16:creationId xmlns:a16="http://schemas.microsoft.com/office/drawing/2014/main" id="{3A8B3B42-FC12-42F4-B9B5-421E25294830}"/>
               </a:ext>
             </a:extLst>
           </p:cNvPr>
@@ -9012,7 +9012,7 @@
           <p:cNvPr id="33" name="">
             <a:extLst xmlns:a="http://schemas.openxmlformats.org/drawingml/2006/main">
               <a:ext uri="{FF2B5EF4-FFF2-40B4-BE49-F238E27FC236}">
-                <a16:creationId xmlns:a16="http://schemas.microsoft.com/office/drawing/2014/main" id="{73A88B4E-4DF2-40E3-98EF-33D676458A16}"/>
+                <a16:creationId xmlns:a16="http://schemas.microsoft.com/office/drawing/2014/main" id="{FE39BF5B-5425-405F-B3B8-551B2EC62BAE}"/>
               </a:ext>
             </a:extLst>
           </p:cNvPr>
@@ -9076,7 +9076,7 @@
           <p:cNvPr id="34" name="">
             <a:extLst xmlns:a="http://schemas.openxmlformats.org/drawingml/2006/main">
               <a:ext uri="{FF2B5EF4-FFF2-40B4-BE49-F238E27FC236}">
-                <a16:creationId xmlns:a16="http://schemas.microsoft.com/office/drawing/2014/main" id="{246A6F3A-DF31-41FB-AB0D-E894E5C6735A}"/>
+                <a16:creationId xmlns:a16="http://schemas.microsoft.com/office/drawing/2014/main" id="{D124CE0B-E92B-4695-BE02-428A5853DE63}"/>
               </a:ext>
             </a:extLst>
           </p:cNvPr>
@@ -9138,7 +9138,7 @@
     </p:spTree>
     <p:extLst>
       <p:ext uri="{BB962C8B-B14F-4D97-AF65-F5344CB8AC3E}">
-        <p14:creationId xmlns:p14="http://schemas.microsoft.com/office/powerpoint/2010/main" val="2086716786"/>
+        <p14:creationId xmlns:p14="http://schemas.microsoft.com/office/powerpoint/2010/main" val="1493807778"/>
       </p:ext>
     </p:extLst>
   </p:cSld>
@@ -9162,7 +9162,7 @@
           <p:cNvPr id="1" name="">
             <a:extLst xmlns:a="http://schemas.openxmlformats.org/drawingml/2006/main">
               <a:ext uri="{FF2B5EF4-FFF2-40B4-BE49-F238E27FC236}">
-                <a16:creationId xmlns:a16="http://schemas.microsoft.com/office/drawing/2014/main" id="{4FC0282A-C1EF-40AB-959E-F60318987169}"/>
+                <a16:creationId xmlns:a16="http://schemas.microsoft.com/office/drawing/2014/main" id="{C99A2B11-34C0-455C-9DCD-307C9D44D388}"/>
               </a:ext>
             </a:extLst>
           </p:cNvPr>
@@ -9197,7 +9197,7 @@
           <p:cNvPr id="2" name="">
             <a:extLst xmlns:a="http://schemas.openxmlformats.org/drawingml/2006/main">
               <a:ext uri="{FF2B5EF4-FFF2-40B4-BE49-F238E27FC236}">
-                <a16:creationId xmlns:a16="http://schemas.microsoft.com/office/drawing/2014/main" id="{C2F3E1E4-B0EF-470D-B3B5-F24E2B99600A}"/>
+                <a16:creationId xmlns:a16="http://schemas.microsoft.com/office/drawing/2014/main" id="{60279DD8-857F-4358-A377-8055ADC03087}"/>
               </a:ext>
             </a:extLst>
           </p:cNvPr>
@@ -9232,7 +9232,7 @@
           <p:cNvPr id="3" name="">
             <a:extLst xmlns:a="http://schemas.openxmlformats.org/drawingml/2006/main">
               <a:ext uri="{FF2B5EF4-FFF2-40B4-BE49-F238E27FC236}">
-                <a16:creationId xmlns:a16="http://schemas.microsoft.com/office/drawing/2014/main" id="{4357081D-041B-4BF6-9A50-C6B859F79EB0}"/>
+                <a16:creationId xmlns:a16="http://schemas.microsoft.com/office/drawing/2014/main" id="{3F0FB33C-7C16-4B13-B57C-C3F25312519A}"/>
               </a:ext>
             </a:extLst>
           </p:cNvPr>
@@ -9296,7 +9296,7 @@
           <p:cNvPr id="4" name="">
             <a:extLst xmlns:a="http://schemas.openxmlformats.org/drawingml/2006/main">
               <a:ext uri="{FF2B5EF4-FFF2-40B4-BE49-F238E27FC236}">
-                <a16:creationId xmlns:a16="http://schemas.microsoft.com/office/drawing/2014/main" id="{64E0C10C-1C70-4A50-A118-BEE622E46C25}"/>
+                <a16:creationId xmlns:a16="http://schemas.microsoft.com/office/drawing/2014/main" id="{45A12A07-791D-4EC8-A7E4-DDBFA8F45BCF}"/>
               </a:ext>
             </a:extLst>
           </p:cNvPr>
@@ -9360,7 +9360,7 @@
           <p:cNvPr id="5" name="">
             <a:extLst xmlns:a="http://schemas.openxmlformats.org/drawingml/2006/main">
               <a:ext uri="{FF2B5EF4-FFF2-40B4-BE49-F238E27FC236}">
-                <a16:creationId xmlns:a16="http://schemas.microsoft.com/office/drawing/2014/main" id="{15D82907-CA72-466C-9981-3906D0C7E214}"/>
+                <a16:creationId xmlns:a16="http://schemas.microsoft.com/office/drawing/2014/main" id="{7A07616C-EAE7-4DC4-A030-7CF142367A61}"/>
               </a:ext>
             </a:extLst>
           </p:cNvPr>
@@ -9424,7 +9424,7 @@
           <p:cNvPr id="6" name="">
             <a:extLst xmlns:a="http://schemas.openxmlformats.org/drawingml/2006/main">
               <a:ext uri="{FF2B5EF4-FFF2-40B4-BE49-F238E27FC236}">
-                <a16:creationId xmlns:a16="http://schemas.microsoft.com/office/drawing/2014/main" id="{42B47542-CBCF-4645-88AF-0D3278E63B31}"/>
+                <a16:creationId xmlns:a16="http://schemas.microsoft.com/office/drawing/2014/main" id="{4B55891A-9B77-4C9D-A647-CD287279FF95}"/>
               </a:ext>
             </a:extLst>
           </p:cNvPr>
@@ -9488,7 +9488,7 @@
           <p:cNvPr id="7" name="">
             <a:extLst xmlns:a="http://schemas.openxmlformats.org/drawingml/2006/main">
               <a:ext uri="{FF2B5EF4-FFF2-40B4-BE49-F238E27FC236}">
-                <a16:creationId xmlns:a16="http://schemas.microsoft.com/office/drawing/2014/main" id="{A77559BE-B86B-46FF-8F37-21DA88B3C674}"/>
+                <a16:creationId xmlns:a16="http://schemas.microsoft.com/office/drawing/2014/main" id="{8675C2FF-3284-411F-ADD8-5041EA68B8B4}"/>
               </a:ext>
             </a:extLst>
           </p:cNvPr>
@@ -9521,7 +9521,7 @@
           <p:cNvPr id="8" name="">
             <a:extLst xmlns:a="http://schemas.openxmlformats.org/drawingml/2006/main">
               <a:ext uri="{FF2B5EF4-FFF2-40B4-BE49-F238E27FC236}">
-                <a16:creationId xmlns:a16="http://schemas.microsoft.com/office/drawing/2014/main" id="{D87039A0-7719-4315-8081-D7CC232CB32D}"/>
+                <a16:creationId xmlns:a16="http://schemas.microsoft.com/office/drawing/2014/main" id="{3B1CEE96-7AAD-431E-AB58-6FD3A83A70E0}"/>
               </a:ext>
             </a:extLst>
           </p:cNvPr>
@@ -9585,7 +9585,7 @@
           <p:cNvPr id="9" name="">
             <a:extLst xmlns:a="http://schemas.openxmlformats.org/drawingml/2006/main">
               <a:ext uri="{FF2B5EF4-FFF2-40B4-BE49-F238E27FC236}">
-                <a16:creationId xmlns:a16="http://schemas.microsoft.com/office/drawing/2014/main" id="{23509F52-C0A5-4CBC-9162-E861338D7D29}"/>
+                <a16:creationId xmlns:a16="http://schemas.microsoft.com/office/drawing/2014/main" id="{C3451D38-0E47-4F36-9F2A-2354E9B26E5B}"/>
               </a:ext>
             </a:extLst>
           </p:cNvPr>
@@ -9672,7 +9672,7 @@
           <p:cNvPr id="10" name="">
             <a:extLst xmlns:a="http://schemas.openxmlformats.org/drawingml/2006/main">
               <a:ext uri="{FF2B5EF4-FFF2-40B4-BE49-F238E27FC236}">
-                <a16:creationId xmlns:a16="http://schemas.microsoft.com/office/drawing/2014/main" id="{D0397BEE-6DE5-461F-B214-A2E29B0AF8C8}"/>
+                <a16:creationId xmlns:a16="http://schemas.microsoft.com/office/drawing/2014/main" id="{8A3BCB43-3E2A-4899-B7F3-E6F3549212A4}"/>
               </a:ext>
             </a:extLst>
           </p:cNvPr>
@@ -9705,7 +9705,7 @@
           <p:cNvPr id="11" name="">
             <a:extLst xmlns:a="http://schemas.openxmlformats.org/drawingml/2006/main">
               <a:ext uri="{FF2B5EF4-FFF2-40B4-BE49-F238E27FC236}">
-                <a16:creationId xmlns:a16="http://schemas.microsoft.com/office/drawing/2014/main" id="{3F69B63F-A842-41AE-AC00-E8EF881B28DD}"/>
+                <a16:creationId xmlns:a16="http://schemas.microsoft.com/office/drawing/2014/main" id="{DFED2D5A-696A-4A13-8D13-01E4BD53DE73}"/>
               </a:ext>
             </a:extLst>
           </p:cNvPr>
@@ -9769,7 +9769,7 @@
           <p:cNvPr id="12" name="">
             <a:extLst xmlns:a="http://schemas.openxmlformats.org/drawingml/2006/main">
               <a:ext uri="{FF2B5EF4-FFF2-40B4-BE49-F238E27FC236}">
-                <a16:creationId xmlns:a16="http://schemas.microsoft.com/office/drawing/2014/main" id="{A3544C9E-6452-4856-9328-F071B3CE80AC}"/>
+                <a16:creationId xmlns:a16="http://schemas.microsoft.com/office/drawing/2014/main" id="{15446310-1325-4FB3-90D7-A9C3F5F331A5}"/>
               </a:ext>
             </a:extLst>
           </p:cNvPr>
@@ -9856,7 +9856,7 @@
           <p:cNvPr id="13" name="">
             <a:extLst xmlns:a="http://schemas.openxmlformats.org/drawingml/2006/main">
               <a:ext uri="{FF2B5EF4-FFF2-40B4-BE49-F238E27FC236}">
-                <a16:creationId xmlns:a16="http://schemas.microsoft.com/office/drawing/2014/main" id="{FEA37D66-F616-46CC-82CA-EBFF07A573A5}"/>
+                <a16:creationId xmlns:a16="http://schemas.microsoft.com/office/drawing/2014/main" id="{45A273D3-E92F-4650-B624-073D60FD1121}"/>
               </a:ext>
             </a:extLst>
           </p:cNvPr>
@@ -9889,7 +9889,7 @@
           <p:cNvPr id="14" name="">
             <a:extLst xmlns:a="http://schemas.openxmlformats.org/drawingml/2006/main">
               <a:ext uri="{FF2B5EF4-FFF2-40B4-BE49-F238E27FC236}">
-                <a16:creationId xmlns:a16="http://schemas.microsoft.com/office/drawing/2014/main" id="{3D5C1BE6-40DA-49EA-8E9C-2D5CBCB48BF3}"/>
+                <a16:creationId xmlns:a16="http://schemas.microsoft.com/office/drawing/2014/main" id="{53B5CA7D-0CB1-43DF-8719-DFE5AD373563}"/>
               </a:ext>
             </a:extLst>
           </p:cNvPr>
@@ -9953,7 +9953,7 @@
           <p:cNvPr id="15" name="">
             <a:extLst xmlns:a="http://schemas.openxmlformats.org/drawingml/2006/main">
               <a:ext uri="{FF2B5EF4-FFF2-40B4-BE49-F238E27FC236}">
-                <a16:creationId xmlns:a16="http://schemas.microsoft.com/office/drawing/2014/main" id="{3615B208-DC3F-452C-B723-7D1790AB616D}"/>
+                <a16:creationId xmlns:a16="http://schemas.microsoft.com/office/drawing/2014/main" id="{E82CACE1-0265-4787-A7E8-04CFE42F0DDA}"/>
               </a:ext>
             </a:extLst>
           </p:cNvPr>
@@ -10040,7 +10040,7 @@
           <p:cNvPr id="16" name="">
             <a:extLst xmlns:a="http://schemas.openxmlformats.org/drawingml/2006/main">
               <a:ext uri="{FF2B5EF4-FFF2-40B4-BE49-F238E27FC236}">
-                <a16:creationId xmlns:a16="http://schemas.microsoft.com/office/drawing/2014/main" id="{4CBB6BC8-B066-44A2-99D1-D6FA46C56254}"/>
+                <a16:creationId xmlns:a16="http://schemas.microsoft.com/office/drawing/2014/main" id="{E06C10FC-80BE-49CC-BA48-7D6DC4AE6996}"/>
               </a:ext>
             </a:extLst>
           </p:cNvPr>
@@ -10075,7 +10075,7 @@
           <p:cNvPr id="17" name="">
             <a:extLst xmlns:a="http://schemas.openxmlformats.org/drawingml/2006/main">
               <a:ext uri="{FF2B5EF4-FFF2-40B4-BE49-F238E27FC236}">
-                <a16:creationId xmlns:a16="http://schemas.microsoft.com/office/drawing/2014/main" id="{685474FC-529A-4202-9765-4237B69428D4}"/>
+                <a16:creationId xmlns:a16="http://schemas.microsoft.com/office/drawing/2014/main" id="{24B81F13-306B-474A-86B5-AD677F1235A6}"/>
               </a:ext>
             </a:extLst>
           </p:cNvPr>
@@ -10110,7 +10110,7 @@
           <p:cNvPr id="18" name="">
             <a:extLst xmlns:a="http://schemas.openxmlformats.org/drawingml/2006/main">
               <a:ext uri="{FF2B5EF4-FFF2-40B4-BE49-F238E27FC236}">
-                <a16:creationId xmlns:a16="http://schemas.microsoft.com/office/drawing/2014/main" id="{97D244C7-4995-43A6-A76F-5D8F1EAA42C0}"/>
+                <a16:creationId xmlns:a16="http://schemas.microsoft.com/office/drawing/2014/main" id="{2379687D-E2D7-478E-AE01-41F47960D501}"/>
               </a:ext>
             </a:extLst>
           </p:cNvPr>
@@ -10143,7 +10143,7 @@
           <p:cNvPr id="19" name="">
             <a:extLst xmlns:a="http://schemas.openxmlformats.org/drawingml/2006/main">
               <a:ext uri="{FF2B5EF4-FFF2-40B4-BE49-F238E27FC236}">
-                <a16:creationId xmlns:a16="http://schemas.microsoft.com/office/drawing/2014/main" id="{38B10650-7E78-4A9E-B8C5-0118BCB2AE88}"/>
+                <a16:creationId xmlns:a16="http://schemas.microsoft.com/office/drawing/2014/main" id="{8EC2A716-2CCC-48A0-9460-CF87DA16C7FB}"/>
               </a:ext>
             </a:extLst>
           </p:cNvPr>
@@ -10207,7 +10207,7 @@
           <p:cNvPr id="20" name="">
             <a:extLst xmlns:a="http://schemas.openxmlformats.org/drawingml/2006/main">
               <a:ext uri="{FF2B5EF4-FFF2-40B4-BE49-F238E27FC236}">
-                <a16:creationId xmlns:a16="http://schemas.microsoft.com/office/drawing/2014/main" id="{C7F96865-E98E-4CA2-9467-EB98E7F8E6DE}"/>
+                <a16:creationId xmlns:a16="http://schemas.microsoft.com/office/drawing/2014/main" id="{22F8B1C3-23C8-441F-A979-EFF9D045FFC0}"/>
               </a:ext>
             </a:extLst>
           </p:cNvPr>
@@ -10271,7 +10271,7 @@
           <p:cNvPr id="21" name="">
             <a:extLst xmlns:a="http://schemas.openxmlformats.org/drawingml/2006/main">
               <a:ext uri="{FF2B5EF4-FFF2-40B4-BE49-F238E27FC236}">
-                <a16:creationId xmlns:a16="http://schemas.microsoft.com/office/drawing/2014/main" id="{1AAA6FA1-6AEA-4D7F-B4B8-458D2AB9F305}"/>
+                <a16:creationId xmlns:a16="http://schemas.microsoft.com/office/drawing/2014/main" id="{F6229C07-19D7-4425-84CC-B6BF27019989}"/>
               </a:ext>
             </a:extLst>
           </p:cNvPr>
@@ -10306,7 +10306,7 @@
           <p:cNvPr id="22" name="">
             <a:extLst xmlns:a="http://schemas.openxmlformats.org/drawingml/2006/main">
               <a:ext uri="{FF2B5EF4-FFF2-40B4-BE49-F238E27FC236}">
-                <a16:creationId xmlns:a16="http://schemas.microsoft.com/office/drawing/2014/main" id="{6E093C10-FA79-4D45-8761-6B6E6943B274}"/>
+                <a16:creationId xmlns:a16="http://schemas.microsoft.com/office/drawing/2014/main" id="{9BC8EC9E-1BA8-4940-A143-B83508BA19EC}"/>
               </a:ext>
             </a:extLst>
           </p:cNvPr>
@@ -10370,7 +10370,7 @@
           <p:cNvPr id="23" name="">
             <a:extLst xmlns:a="http://schemas.openxmlformats.org/drawingml/2006/main">
               <a:ext uri="{FF2B5EF4-FFF2-40B4-BE49-F238E27FC236}">
-                <a16:creationId xmlns:a16="http://schemas.microsoft.com/office/drawing/2014/main" id="{B6CC9F07-B707-4679-ADC6-3D5F2838796F}"/>
+                <a16:creationId xmlns:a16="http://schemas.microsoft.com/office/drawing/2014/main" id="{84D51336-C2A6-4E2E-9958-80A18621283F}"/>
               </a:ext>
             </a:extLst>
           </p:cNvPr>
@@ -10432,7 +10432,7 @@
     </p:spTree>
     <p:extLst>
       <p:ext uri="{BB962C8B-B14F-4D97-AF65-F5344CB8AC3E}">
-        <p14:creationId xmlns:p14="http://schemas.microsoft.com/office/powerpoint/2010/main" val="1887437754"/>
+        <p14:creationId xmlns:p14="http://schemas.microsoft.com/office/powerpoint/2010/main" val="248827230"/>
       </p:ext>
     </p:extLst>
   </p:cSld>
@@ -10456,7 +10456,7 @@
           <p:cNvPr id="1" name="">
             <a:extLst xmlns:a="http://schemas.openxmlformats.org/drawingml/2006/main">
               <a:ext uri="{FF2B5EF4-FFF2-40B4-BE49-F238E27FC236}">
-                <a16:creationId xmlns:a16="http://schemas.microsoft.com/office/drawing/2014/main" id="{F9DDD95B-A5F2-4EDD-9BF7-1683BB75C9ED}"/>
+                <a16:creationId xmlns:a16="http://schemas.microsoft.com/office/drawing/2014/main" id="{B4DB19E1-3AFB-4832-8421-9A22BEE6C89F}"/>
               </a:ext>
             </a:extLst>
           </p:cNvPr>
@@ -10491,7 +10491,7 @@
           <p:cNvPr id="2" name="">
             <a:extLst xmlns:a="http://schemas.openxmlformats.org/drawingml/2006/main">
               <a:ext uri="{FF2B5EF4-FFF2-40B4-BE49-F238E27FC236}">
-                <a16:creationId xmlns:a16="http://schemas.microsoft.com/office/drawing/2014/main" id="{B577ED9E-7EDB-49AA-BE14-37892B06CD7C}"/>
+                <a16:creationId xmlns:a16="http://schemas.microsoft.com/office/drawing/2014/main" id="{B3144A9E-B2DC-47A4-8CE3-AB23AFB8375E}"/>
               </a:ext>
             </a:extLst>
           </p:cNvPr>
@@ -10526,7 +10526,7 @@
           <p:cNvPr id="3" name="">
             <a:extLst xmlns:a="http://schemas.openxmlformats.org/drawingml/2006/main">
               <a:ext uri="{FF2B5EF4-FFF2-40B4-BE49-F238E27FC236}">
-                <a16:creationId xmlns:a16="http://schemas.microsoft.com/office/drawing/2014/main" id="{FCC7AF5C-9BC2-495C-97FA-FE9D1E9A37D6}"/>
+                <a16:creationId xmlns:a16="http://schemas.microsoft.com/office/drawing/2014/main" id="{3B3983C2-E643-4668-9E5B-0A0AEDF12CB7}"/>
               </a:ext>
             </a:extLst>
           </p:cNvPr>
@@ -10590,7 +10590,7 @@
           <p:cNvPr id="4" name="">
             <a:extLst xmlns:a="http://schemas.openxmlformats.org/drawingml/2006/main">
               <a:ext uri="{FF2B5EF4-FFF2-40B4-BE49-F238E27FC236}">
-                <a16:creationId xmlns:a16="http://schemas.microsoft.com/office/drawing/2014/main" id="{9C622303-BBE3-4017-98E9-9DD87A77E796}"/>
+                <a16:creationId xmlns:a16="http://schemas.microsoft.com/office/drawing/2014/main" id="{F097059A-74E5-40A3-BFE8-E51239FBFE63}"/>
               </a:ext>
             </a:extLst>
           </p:cNvPr>
@@ -10654,7 +10654,7 @@
           <p:cNvPr id="5" name="">
             <a:extLst xmlns:a="http://schemas.openxmlformats.org/drawingml/2006/main">
               <a:ext uri="{FF2B5EF4-FFF2-40B4-BE49-F238E27FC236}">
-                <a16:creationId xmlns:a16="http://schemas.microsoft.com/office/drawing/2014/main" id="{6E0B714A-16E6-4429-8887-8475DF2BAB26}"/>
+                <a16:creationId xmlns:a16="http://schemas.microsoft.com/office/drawing/2014/main" id="{48FA9493-0D72-4CAD-8340-B6657E93218D}"/>
               </a:ext>
             </a:extLst>
           </p:cNvPr>
@@ -10718,7 +10718,7 @@
           <p:cNvPr id="6" name="">
             <a:extLst xmlns:a="http://schemas.openxmlformats.org/drawingml/2006/main">
               <a:ext uri="{FF2B5EF4-FFF2-40B4-BE49-F238E27FC236}">
-                <a16:creationId xmlns:a16="http://schemas.microsoft.com/office/drawing/2014/main" id="{1E4EBA00-99C5-44A1-8198-1932E6BDE072}"/>
+                <a16:creationId xmlns:a16="http://schemas.microsoft.com/office/drawing/2014/main" id="{E11FD403-7F6A-4B35-A67C-536922C561F6}"/>
               </a:ext>
             </a:extLst>
           </p:cNvPr>
@@ -10751,7 +10751,7 @@
           <p:cNvPr id="7" name="">
             <a:extLst xmlns:a="http://schemas.openxmlformats.org/drawingml/2006/main">
               <a:ext uri="{FF2B5EF4-FFF2-40B4-BE49-F238E27FC236}">
-                <a16:creationId xmlns:a16="http://schemas.microsoft.com/office/drawing/2014/main" id="{7FB2ABAD-E09D-4E09-A57E-52869149B211}"/>
+                <a16:creationId xmlns:a16="http://schemas.microsoft.com/office/drawing/2014/main" id="{57820265-EE4B-4C35-A80E-956F00CD9275}"/>
               </a:ext>
             </a:extLst>
           </p:cNvPr>
@@ -10815,7 +10815,7 @@
           <p:cNvPr id="8" name="">
             <a:extLst xmlns:a="http://schemas.openxmlformats.org/drawingml/2006/main">
               <a:ext uri="{FF2B5EF4-FFF2-40B4-BE49-F238E27FC236}">
-                <a16:creationId xmlns:a16="http://schemas.microsoft.com/office/drawing/2014/main" id="{1D8806A8-940A-48CC-A87E-2E9BA4336588}"/>
+                <a16:creationId xmlns:a16="http://schemas.microsoft.com/office/drawing/2014/main" id="{A40EE4A7-54AE-4B93-AFA8-9F7B185ED79C}"/>
               </a:ext>
             </a:extLst>
           </p:cNvPr>
@@ -10971,7 +10971,7 @@
           <p:cNvPr id="9" name="">
             <a:extLst xmlns:a="http://schemas.openxmlformats.org/drawingml/2006/main">
               <a:ext uri="{FF2B5EF4-FFF2-40B4-BE49-F238E27FC236}">
-                <a16:creationId xmlns:a16="http://schemas.microsoft.com/office/drawing/2014/main" id="{5AF5CCBD-A2E4-4749-81C5-29CA33EAAF1C}"/>
+                <a16:creationId xmlns:a16="http://schemas.microsoft.com/office/drawing/2014/main" id="{67AEE543-A983-45DC-B148-47106B4E270A}"/>
               </a:ext>
             </a:extLst>
           </p:cNvPr>
@@ -11004,7 +11004,7 @@
           <p:cNvPr id="10" name="">
             <a:extLst xmlns:a="http://schemas.openxmlformats.org/drawingml/2006/main">
               <a:ext uri="{FF2B5EF4-FFF2-40B4-BE49-F238E27FC236}">
-                <a16:creationId xmlns:a16="http://schemas.microsoft.com/office/drawing/2014/main" id="{67FDC953-7F3E-490D-854C-F59A4AC248B6}"/>
+                <a16:creationId xmlns:a16="http://schemas.microsoft.com/office/drawing/2014/main" id="{84B7D5BD-63AA-42AD-B28F-115E53048988}"/>
               </a:ext>
             </a:extLst>
           </p:cNvPr>
@@ -11068,7 +11068,7 @@
           <p:cNvPr id="11" name="">
             <a:extLst xmlns:a="http://schemas.openxmlformats.org/drawingml/2006/main">
               <a:ext uri="{FF2B5EF4-FFF2-40B4-BE49-F238E27FC236}">
-                <a16:creationId xmlns:a16="http://schemas.microsoft.com/office/drawing/2014/main" id="{6543C49D-3443-4975-9C28-6EE103842A8E}"/>
+                <a16:creationId xmlns:a16="http://schemas.microsoft.com/office/drawing/2014/main" id="{59CEACC4-ACC5-4BCE-A69E-83B2E3E099DD}"/>
               </a:ext>
             </a:extLst>
           </p:cNvPr>
@@ -11178,7 +11178,7 @@
           <p:cNvPr id="12" name="">
             <a:extLst xmlns:a="http://schemas.openxmlformats.org/drawingml/2006/main">
               <a:ext uri="{FF2B5EF4-FFF2-40B4-BE49-F238E27FC236}">
-                <a16:creationId xmlns:a16="http://schemas.microsoft.com/office/drawing/2014/main" id="{BA00CFA7-BCF3-4996-94BB-819E2C3ED3DB}"/>
+                <a16:creationId xmlns:a16="http://schemas.microsoft.com/office/drawing/2014/main" id="{2B3C7C2F-7CD4-448E-A2CE-98C34DB14C4A}"/>
               </a:ext>
             </a:extLst>
           </p:cNvPr>
@@ -11211,7 +11211,7 @@
           <p:cNvPr id="13" name="">
             <a:extLst xmlns:a="http://schemas.openxmlformats.org/drawingml/2006/main">
               <a:ext uri="{FF2B5EF4-FFF2-40B4-BE49-F238E27FC236}">
-                <a16:creationId xmlns:a16="http://schemas.microsoft.com/office/drawing/2014/main" id="{B509E78D-02F3-42D2-92B3-BC9723D48791}"/>
+                <a16:creationId xmlns:a16="http://schemas.microsoft.com/office/drawing/2014/main" id="{E7DFC9FC-19D7-4988-BAA3-5E9708775F6B}"/>
               </a:ext>
             </a:extLst>
           </p:cNvPr>
@@ -11275,7 +11275,7 @@
           <p:cNvPr id="14" name="">
             <a:extLst xmlns:a="http://schemas.openxmlformats.org/drawingml/2006/main">
               <a:ext uri="{FF2B5EF4-FFF2-40B4-BE49-F238E27FC236}">
-                <a16:creationId xmlns:a16="http://schemas.microsoft.com/office/drawing/2014/main" id="{AA8AA57D-3634-465D-B016-CA227FA52F39}"/>
+                <a16:creationId xmlns:a16="http://schemas.microsoft.com/office/drawing/2014/main" id="{F348D19B-3E3B-4C76-BB6D-E6E7C1FEBB9B}"/>
               </a:ext>
             </a:extLst>
           </p:cNvPr>
@@ -11408,7 +11408,7 @@
           <p:cNvPr id="15" name="">
             <a:extLst xmlns:a="http://schemas.openxmlformats.org/drawingml/2006/main">
               <a:ext uri="{FF2B5EF4-FFF2-40B4-BE49-F238E27FC236}">
-                <a16:creationId xmlns:a16="http://schemas.microsoft.com/office/drawing/2014/main" id="{BD4BC62A-DD46-405F-9942-3FA37F3D4365}"/>
+                <a16:creationId xmlns:a16="http://schemas.microsoft.com/office/drawing/2014/main" id="{AB671A57-AC30-41AA-80C2-F1726CD4ABE4}"/>
               </a:ext>
             </a:extLst>
           </p:cNvPr>
@@ -11441,7 +11441,7 @@
           <p:cNvPr id="16" name="">
             <a:extLst xmlns:a="http://schemas.openxmlformats.org/drawingml/2006/main">
               <a:ext uri="{FF2B5EF4-FFF2-40B4-BE49-F238E27FC236}">
-                <a16:creationId xmlns:a16="http://schemas.microsoft.com/office/drawing/2014/main" id="{407E1558-AD27-4EAD-B8A7-A905A4621290}"/>
+                <a16:creationId xmlns:a16="http://schemas.microsoft.com/office/drawing/2014/main" id="{7ED17014-3472-499B-A4C3-DD3C45FD1422}"/>
               </a:ext>
             </a:extLst>
           </p:cNvPr>
@@ -11505,7 +11505,7 @@
           <p:cNvPr id="17" name="">
             <a:extLst xmlns:a="http://schemas.openxmlformats.org/drawingml/2006/main">
               <a:ext uri="{FF2B5EF4-FFF2-40B4-BE49-F238E27FC236}">
-                <a16:creationId xmlns:a16="http://schemas.microsoft.com/office/drawing/2014/main" id="{5BF1F48A-34CE-43B1-A7EA-5B8EC946DC3E}"/>
+                <a16:creationId xmlns:a16="http://schemas.microsoft.com/office/drawing/2014/main" id="{3FC801CF-7B83-4642-B40D-CD6B21C95B7B}"/>
               </a:ext>
             </a:extLst>
           </p:cNvPr>
@@ -11638,7 +11638,7 @@
           <p:cNvPr id="18" name="">
             <a:extLst xmlns:a="http://schemas.openxmlformats.org/drawingml/2006/main">
               <a:ext uri="{FF2B5EF4-FFF2-40B4-BE49-F238E27FC236}">
-                <a16:creationId xmlns:a16="http://schemas.microsoft.com/office/drawing/2014/main" id="{24E941C0-8DCE-4F17-BA7D-D75BAF1B96D6}"/>
+                <a16:creationId xmlns:a16="http://schemas.microsoft.com/office/drawing/2014/main" id="{BDE9379A-FD7F-432E-9A45-D7775688258E}"/>
               </a:ext>
             </a:extLst>
           </p:cNvPr>
@@ -11671,7 +11671,7 @@
           <p:cNvPr id="19" name="">
             <a:extLst xmlns:a="http://schemas.openxmlformats.org/drawingml/2006/main">
               <a:ext uri="{FF2B5EF4-FFF2-40B4-BE49-F238E27FC236}">
-                <a16:creationId xmlns:a16="http://schemas.microsoft.com/office/drawing/2014/main" id="{4F130331-34B1-432D-B452-0AA2D650B7EF}"/>
+                <a16:creationId xmlns:a16="http://schemas.microsoft.com/office/drawing/2014/main" id="{66D02228-57E9-4647-B761-406E9ECDAFF9}"/>
               </a:ext>
             </a:extLst>
           </p:cNvPr>
@@ -11735,7 +11735,7 @@
           <p:cNvPr id="20" name="">
             <a:extLst xmlns:a="http://schemas.openxmlformats.org/drawingml/2006/main">
               <a:ext uri="{FF2B5EF4-FFF2-40B4-BE49-F238E27FC236}">
-                <a16:creationId xmlns:a16="http://schemas.microsoft.com/office/drawing/2014/main" id="{0CD957D2-5240-464E-BA72-BCA5C622D94E}"/>
+                <a16:creationId xmlns:a16="http://schemas.microsoft.com/office/drawing/2014/main" id="{D903E870-9FE2-46AD-8CDC-3112C7660F85}"/>
               </a:ext>
             </a:extLst>
           </p:cNvPr>
@@ -11845,7 +11845,7 @@
           <p:cNvPr id="21" name="">
             <a:extLst xmlns:a="http://schemas.openxmlformats.org/drawingml/2006/main">
               <a:ext uri="{FF2B5EF4-FFF2-40B4-BE49-F238E27FC236}">
-                <a16:creationId xmlns:a16="http://schemas.microsoft.com/office/drawing/2014/main" id="{DA723ECB-E36A-40DD-A7B6-B1963C61CEE1}"/>
+                <a16:creationId xmlns:a16="http://schemas.microsoft.com/office/drawing/2014/main" id="{25307CB7-C5CA-4C04-A31B-1F32F44E98AA}"/>
               </a:ext>
             </a:extLst>
           </p:cNvPr>
@@ -11878,7 +11878,7 @@
           <p:cNvPr id="22" name="">
             <a:extLst xmlns:a="http://schemas.openxmlformats.org/drawingml/2006/main">
               <a:ext uri="{FF2B5EF4-FFF2-40B4-BE49-F238E27FC236}">
-                <a16:creationId xmlns:a16="http://schemas.microsoft.com/office/drawing/2014/main" id="{8834F3D3-0239-4157-8A11-89F2AD6292BF}"/>
+                <a16:creationId xmlns:a16="http://schemas.microsoft.com/office/drawing/2014/main" id="{2C1DE2B5-E4B6-4B6C-991A-F06FC444B580}"/>
               </a:ext>
             </a:extLst>
           </p:cNvPr>
@@ -11942,7 +11942,7 @@
           <p:cNvPr id="23" name="">
             <a:extLst xmlns:a="http://schemas.openxmlformats.org/drawingml/2006/main">
               <a:ext uri="{FF2B5EF4-FFF2-40B4-BE49-F238E27FC236}">
-                <a16:creationId xmlns:a16="http://schemas.microsoft.com/office/drawing/2014/main" id="{5E00CED3-F106-4B27-BB80-16BC94444BEC}"/>
+                <a16:creationId xmlns:a16="http://schemas.microsoft.com/office/drawing/2014/main" id="{4EF36245-C973-4DBC-AC21-E884DC7499E8}"/>
               </a:ext>
             </a:extLst>
           </p:cNvPr>
@@ -12052,7 +12052,7 @@
           <p:cNvPr id="24" name="">
             <a:extLst xmlns:a="http://schemas.openxmlformats.org/drawingml/2006/main">
               <a:ext uri="{FF2B5EF4-FFF2-40B4-BE49-F238E27FC236}">
-                <a16:creationId xmlns:a16="http://schemas.microsoft.com/office/drawing/2014/main" id="{F746F315-F4FE-4D42-81CD-B1C213C4346C}"/>
+                <a16:creationId xmlns:a16="http://schemas.microsoft.com/office/drawing/2014/main" id="{959D2DED-7EAC-490B-AD3F-3E93E194CE98}"/>
               </a:ext>
             </a:extLst>
           </p:cNvPr>
@@ -12087,7 +12087,7 @@
           <p:cNvPr id="25" name="">
             <a:extLst xmlns:a="http://schemas.openxmlformats.org/drawingml/2006/main">
               <a:ext uri="{FF2B5EF4-FFF2-40B4-BE49-F238E27FC236}">
-                <a16:creationId xmlns:a16="http://schemas.microsoft.com/office/drawing/2014/main" id="{1BF0171D-3EC6-487F-B07D-0C8F4AF75BF1}"/>
+                <a16:creationId xmlns:a16="http://schemas.microsoft.com/office/drawing/2014/main" id="{26C4ECF4-66D2-4087-BE24-9010F0578575}"/>
               </a:ext>
             </a:extLst>
           </p:cNvPr>
@@ -12122,7 +12122,7 @@
           <p:cNvPr id="26" name="">
             <a:extLst xmlns:a="http://schemas.openxmlformats.org/drawingml/2006/main">
               <a:ext uri="{FF2B5EF4-FFF2-40B4-BE49-F238E27FC236}">
-                <a16:creationId xmlns:a16="http://schemas.microsoft.com/office/drawing/2014/main" id="{53E72567-5AC9-4F72-BA20-9AC04D77A66E}"/>
+                <a16:creationId xmlns:a16="http://schemas.microsoft.com/office/drawing/2014/main" id="{5CB44C6C-7C50-4390-A1CF-9CA4A0629EF0}"/>
               </a:ext>
             </a:extLst>
           </p:cNvPr>
@@ -12157,7 +12157,7 @@
           <p:cNvPr id="27" name="">
             <a:extLst xmlns:a="http://schemas.openxmlformats.org/drawingml/2006/main">
               <a:ext uri="{FF2B5EF4-FFF2-40B4-BE49-F238E27FC236}">
-                <a16:creationId xmlns:a16="http://schemas.microsoft.com/office/drawing/2014/main" id="{0E72F4F2-61DC-4427-A76C-8C19EFDD5393}"/>
+                <a16:creationId xmlns:a16="http://schemas.microsoft.com/office/drawing/2014/main" id="{FC2B7BEF-492D-456A-BF30-01076583FC13}"/>
               </a:ext>
             </a:extLst>
           </p:cNvPr>
@@ -12192,7 +12192,7 @@
           <p:cNvPr id="28" name="">
             <a:extLst xmlns:a="http://schemas.openxmlformats.org/drawingml/2006/main">
               <a:ext uri="{FF2B5EF4-FFF2-40B4-BE49-F238E27FC236}">
-                <a16:creationId xmlns:a16="http://schemas.microsoft.com/office/drawing/2014/main" id="{6453ECCA-7991-4272-A9A3-F864D4F6EF89}"/>
+                <a16:creationId xmlns:a16="http://schemas.microsoft.com/office/drawing/2014/main" id="{3B89AEE6-FFBE-4F2E-A7DF-E08043EDE6DF}"/>
               </a:ext>
             </a:extLst>
           </p:cNvPr>
@@ -12227,7 +12227,7 @@
           <p:cNvPr id="29" name="">
             <a:extLst xmlns:a="http://schemas.openxmlformats.org/drawingml/2006/main">
               <a:ext uri="{FF2B5EF4-FFF2-40B4-BE49-F238E27FC236}">
-                <a16:creationId xmlns:a16="http://schemas.microsoft.com/office/drawing/2014/main" id="{76B27634-5071-4851-B2B9-A6FFB5CB6FB8}"/>
+                <a16:creationId xmlns:a16="http://schemas.microsoft.com/office/drawing/2014/main" id="{AEF21531-2511-456E-BA66-5AF1E042D526}"/>
               </a:ext>
             </a:extLst>
           </p:cNvPr>
@@ -12291,7 +12291,7 @@
           <p:cNvPr id="30" name="">
             <a:extLst xmlns:a="http://schemas.openxmlformats.org/drawingml/2006/main">
               <a:ext uri="{FF2B5EF4-FFF2-40B4-BE49-F238E27FC236}">
-                <a16:creationId xmlns:a16="http://schemas.microsoft.com/office/drawing/2014/main" id="{9BC9F1AA-3CAB-4A19-9A98-0AEB90C2C9B2}"/>
+                <a16:creationId xmlns:a16="http://schemas.microsoft.com/office/drawing/2014/main" id="{FE76836D-BA41-4724-9A1D-1675A5F14837}"/>
               </a:ext>
             </a:extLst>
           </p:cNvPr>
@@ -12326,7 +12326,7 @@
           <p:cNvPr id="31" name="">
             <a:extLst xmlns:a="http://schemas.openxmlformats.org/drawingml/2006/main">
               <a:ext uri="{FF2B5EF4-FFF2-40B4-BE49-F238E27FC236}">
-                <a16:creationId xmlns:a16="http://schemas.microsoft.com/office/drawing/2014/main" id="{33670E03-BCD8-460E-9530-AABF6C8EC5E9}"/>
+                <a16:creationId xmlns:a16="http://schemas.microsoft.com/office/drawing/2014/main" id="{2204FA28-C56F-4834-9CD1-71AA948FFACE}"/>
               </a:ext>
             </a:extLst>
           </p:cNvPr>
@@ -12390,7 +12390,7 @@
           <p:cNvPr id="32" name="">
             <a:extLst xmlns:a="http://schemas.openxmlformats.org/drawingml/2006/main">
               <a:ext uri="{FF2B5EF4-FFF2-40B4-BE49-F238E27FC236}">
-                <a16:creationId xmlns:a16="http://schemas.microsoft.com/office/drawing/2014/main" id="{35287E3C-4A8D-4F01-986A-A1D3C8D99BBF}"/>
+                <a16:creationId xmlns:a16="http://schemas.microsoft.com/office/drawing/2014/main" id="{F513D7CE-8863-4442-B2A9-6F2B2D5214CE}"/>
               </a:ext>
             </a:extLst>
           </p:cNvPr>
@@ -12452,7 +12452,7 @@
     </p:spTree>
     <p:extLst>
       <p:ext uri="{BB962C8B-B14F-4D97-AF65-F5344CB8AC3E}">
-        <p14:creationId xmlns:p14="http://schemas.microsoft.com/office/powerpoint/2010/main" val="216168703"/>
+        <p14:creationId xmlns:p14="http://schemas.microsoft.com/office/powerpoint/2010/main" val="874438343"/>
       </p:ext>
     </p:extLst>
   </p:cSld>
@@ -12476,7 +12476,7 @@
           <p:cNvPr id="1" name="">
             <a:extLst xmlns:a="http://schemas.openxmlformats.org/drawingml/2006/main">
               <a:ext uri="{FF2B5EF4-FFF2-40B4-BE49-F238E27FC236}">
-                <a16:creationId xmlns:a16="http://schemas.microsoft.com/office/drawing/2014/main" id="{D81B209E-BD3F-4D70-B11B-9761F9D303E2}"/>
+                <a16:creationId xmlns:a16="http://schemas.microsoft.com/office/drawing/2014/main" id="{7E71AA72-337C-4AB2-AB12-AEB12C339430}"/>
               </a:ext>
             </a:extLst>
           </p:cNvPr>
@@ -12511,7 +12511,7 @@
           <p:cNvPr id="2" name="">
             <a:extLst xmlns:a="http://schemas.openxmlformats.org/drawingml/2006/main">
               <a:ext uri="{FF2B5EF4-FFF2-40B4-BE49-F238E27FC236}">
-                <a16:creationId xmlns:a16="http://schemas.microsoft.com/office/drawing/2014/main" id="{CAA9E292-6428-4AA6-A5BC-555E09F465B2}"/>
+                <a16:creationId xmlns:a16="http://schemas.microsoft.com/office/drawing/2014/main" id="{C2C9C7B8-45F1-472F-8681-21D99FF3FA43}"/>
               </a:ext>
             </a:extLst>
           </p:cNvPr>
@@ -12546,7 +12546,7 @@
           <p:cNvPr id="3" name="">
             <a:extLst xmlns:a="http://schemas.openxmlformats.org/drawingml/2006/main">
               <a:ext uri="{FF2B5EF4-FFF2-40B4-BE49-F238E27FC236}">
-                <a16:creationId xmlns:a16="http://schemas.microsoft.com/office/drawing/2014/main" id="{ED4E538B-0E94-4F9F-9F57-3B0FD65D5358}"/>
+                <a16:creationId xmlns:a16="http://schemas.microsoft.com/office/drawing/2014/main" id="{19EFF841-853D-4B9C-B852-3EB9B587F5DC}"/>
               </a:ext>
             </a:extLst>
           </p:cNvPr>
@@ -12610,7 +12610,7 @@
           <p:cNvPr id="4" name="">
             <a:extLst xmlns:a="http://schemas.openxmlformats.org/drawingml/2006/main">
               <a:ext uri="{FF2B5EF4-FFF2-40B4-BE49-F238E27FC236}">
-                <a16:creationId xmlns:a16="http://schemas.microsoft.com/office/drawing/2014/main" id="{99C46496-1716-4E7E-9FC3-B20147CD073C}"/>
+                <a16:creationId xmlns:a16="http://schemas.microsoft.com/office/drawing/2014/main" id="{43DD328F-FB83-4C01-A345-AD8436F11760}"/>
               </a:ext>
             </a:extLst>
           </p:cNvPr>
@@ -12674,7 +12674,7 @@
           <p:cNvPr id="5" name="">
             <a:extLst xmlns:a="http://schemas.openxmlformats.org/drawingml/2006/main">
               <a:ext uri="{FF2B5EF4-FFF2-40B4-BE49-F238E27FC236}">
-                <a16:creationId xmlns:a16="http://schemas.microsoft.com/office/drawing/2014/main" id="{DCCF3403-FC18-4EA9-925F-6E1D704A3272}"/>
+                <a16:creationId xmlns:a16="http://schemas.microsoft.com/office/drawing/2014/main" id="{A96277CD-48E3-40AC-A18A-53FB51EDFF4A}"/>
               </a:ext>
             </a:extLst>
           </p:cNvPr>
@@ -12738,7 +12738,7 @@
           <p:cNvPr id="6" name="">
             <a:extLst xmlns:a="http://schemas.openxmlformats.org/drawingml/2006/main">
               <a:ext uri="{FF2B5EF4-FFF2-40B4-BE49-F238E27FC236}">
-                <a16:creationId xmlns:a16="http://schemas.microsoft.com/office/drawing/2014/main" id="{D656CD16-13A4-445F-91C4-5BF0BB37A96E}"/>
+                <a16:creationId xmlns:a16="http://schemas.microsoft.com/office/drawing/2014/main" id="{C25665E9-D8C6-405F-9C36-ABF5A2AE32E9}"/>
               </a:ext>
             </a:extLst>
           </p:cNvPr>
@@ -12771,7 +12771,7 @@
           <p:cNvPr id="7" name="">
             <a:extLst xmlns:a="http://schemas.openxmlformats.org/drawingml/2006/main">
               <a:ext uri="{FF2B5EF4-FFF2-40B4-BE49-F238E27FC236}">
-                <a16:creationId xmlns:a16="http://schemas.microsoft.com/office/drawing/2014/main" id="{2996D2C5-6FF9-4AC6-8A41-B92C39B811C6}"/>
+                <a16:creationId xmlns:a16="http://schemas.microsoft.com/office/drawing/2014/main" id="{72C4AA39-AFD0-40FA-9C35-D9705B2CC95F}"/>
               </a:ext>
             </a:extLst>
           </p:cNvPr>
@@ -12804,7 +12804,7 @@
           <p:cNvPr id="8" name="">
             <a:extLst xmlns:a="http://schemas.openxmlformats.org/drawingml/2006/main">
               <a:ext uri="{FF2B5EF4-FFF2-40B4-BE49-F238E27FC236}">
-                <a16:creationId xmlns:a16="http://schemas.microsoft.com/office/drawing/2014/main" id="{DDFA016B-D85C-4303-99DA-7018EB760EEA}"/>
+                <a16:creationId xmlns:a16="http://schemas.microsoft.com/office/drawing/2014/main" id="{A1D7DD9E-AF71-4950-BB62-253F68B16F0B}"/>
               </a:ext>
             </a:extLst>
           </p:cNvPr>
@@ -12868,7 +12868,7 @@
           <p:cNvPr id="9" name="">
             <a:extLst xmlns:a="http://schemas.openxmlformats.org/drawingml/2006/main">
               <a:ext uri="{FF2B5EF4-FFF2-40B4-BE49-F238E27FC236}">
-                <a16:creationId xmlns:a16="http://schemas.microsoft.com/office/drawing/2014/main" id="{F0ADCF8D-6E2B-4657-9DA4-CFEB0B045960}"/>
+                <a16:creationId xmlns:a16="http://schemas.microsoft.com/office/drawing/2014/main" id="{73F13EA0-0509-410D-8DDB-89902B6A7E71}"/>
               </a:ext>
             </a:extLst>
           </p:cNvPr>
@@ -12978,7 +12978,7 @@
           <p:cNvPr id="10" name="">
             <a:extLst xmlns:a="http://schemas.openxmlformats.org/drawingml/2006/main">
               <a:ext uri="{FF2B5EF4-FFF2-40B4-BE49-F238E27FC236}">
-                <a16:creationId xmlns:a16="http://schemas.microsoft.com/office/drawing/2014/main" id="{4FA74F70-7DC0-4F02-BE61-A9C57E1D95C5}"/>
+                <a16:creationId xmlns:a16="http://schemas.microsoft.com/office/drawing/2014/main" id="{9EBCA9EE-B8DC-420E-99C7-F7DC7AB9AC6A}"/>
               </a:ext>
             </a:extLst>
           </p:cNvPr>
@@ -13011,7 +13011,7 @@
           <p:cNvPr id="11" name="">
             <a:extLst xmlns:a="http://schemas.openxmlformats.org/drawingml/2006/main">
               <a:ext uri="{FF2B5EF4-FFF2-40B4-BE49-F238E27FC236}">
-                <a16:creationId xmlns:a16="http://schemas.microsoft.com/office/drawing/2014/main" id="{9382BC03-AEF9-4D52-AD71-20EEC48A22D1}"/>
+                <a16:creationId xmlns:a16="http://schemas.microsoft.com/office/drawing/2014/main" id="{D305D90C-22B6-41C4-957C-50F2F820A291}"/>
               </a:ext>
             </a:extLst>
           </p:cNvPr>
@@ -13044,7 +13044,7 @@
           <p:cNvPr id="12" name="">
             <a:extLst xmlns:a="http://schemas.openxmlformats.org/drawingml/2006/main">
               <a:ext uri="{FF2B5EF4-FFF2-40B4-BE49-F238E27FC236}">
-                <a16:creationId xmlns:a16="http://schemas.microsoft.com/office/drawing/2014/main" id="{620B490E-5D7D-4106-90AB-802E84D4AD31}"/>
+                <a16:creationId xmlns:a16="http://schemas.microsoft.com/office/drawing/2014/main" id="{9BC082AA-9F49-480A-B24D-EBC53C0F44AB}"/>
               </a:ext>
             </a:extLst>
           </p:cNvPr>
@@ -13108,7 +13108,7 @@
           <p:cNvPr id="13" name="">
             <a:extLst xmlns:a="http://schemas.openxmlformats.org/drawingml/2006/main">
               <a:ext uri="{FF2B5EF4-FFF2-40B4-BE49-F238E27FC236}">
-                <a16:creationId xmlns:a16="http://schemas.microsoft.com/office/drawing/2014/main" id="{3375607C-62C8-4B72-AE74-6921F820C84C}"/>
+                <a16:creationId xmlns:a16="http://schemas.microsoft.com/office/drawing/2014/main" id="{FF041C62-EBD7-4946-8377-9C73D696461F}"/>
               </a:ext>
             </a:extLst>
           </p:cNvPr>
@@ -13218,7 +13218,7 @@
           <p:cNvPr id="14" name="">
             <a:extLst xmlns:a="http://schemas.openxmlformats.org/drawingml/2006/main">
               <a:ext uri="{FF2B5EF4-FFF2-40B4-BE49-F238E27FC236}">
-                <a16:creationId xmlns:a16="http://schemas.microsoft.com/office/drawing/2014/main" id="{9980D4F6-7B9D-4804-986B-694F6591191C}"/>
+                <a16:creationId xmlns:a16="http://schemas.microsoft.com/office/drawing/2014/main" id="{4BE86075-0E19-4EFB-B692-E2987A0174A0}"/>
               </a:ext>
             </a:extLst>
           </p:cNvPr>
@@ -13251,7 +13251,7 @@
           <p:cNvPr id="15" name="">
             <a:extLst xmlns:a="http://schemas.openxmlformats.org/drawingml/2006/main">
               <a:ext uri="{FF2B5EF4-FFF2-40B4-BE49-F238E27FC236}">
-                <a16:creationId xmlns:a16="http://schemas.microsoft.com/office/drawing/2014/main" id="{11576503-D8C0-45EB-A41D-BDC73D76371A}"/>
+                <a16:creationId xmlns:a16="http://schemas.microsoft.com/office/drawing/2014/main" id="{701E6146-C383-4B8F-A9BF-6459DF810A45}"/>
               </a:ext>
             </a:extLst>
           </p:cNvPr>
@@ -13284,7 +13284,7 @@
           <p:cNvPr id="16" name="">
             <a:extLst xmlns:a="http://schemas.openxmlformats.org/drawingml/2006/main">
               <a:ext uri="{FF2B5EF4-FFF2-40B4-BE49-F238E27FC236}">
-                <a16:creationId xmlns:a16="http://schemas.microsoft.com/office/drawing/2014/main" id="{57211F86-0502-40E6-B6B9-F93F8CC1D98D}"/>
+                <a16:creationId xmlns:a16="http://schemas.microsoft.com/office/drawing/2014/main" id="{C36DB172-C62A-4B14-B86F-ADE9973FE9D4}"/>
               </a:ext>
             </a:extLst>
           </p:cNvPr>
@@ -13348,7 +13348,7 @@
           <p:cNvPr id="17" name="">
             <a:extLst xmlns:a="http://schemas.openxmlformats.org/drawingml/2006/main">
               <a:ext uri="{FF2B5EF4-FFF2-40B4-BE49-F238E27FC236}">
-                <a16:creationId xmlns:a16="http://schemas.microsoft.com/office/drawing/2014/main" id="{85994802-68A5-4A98-8495-66683B3D0FAE}"/>
+                <a16:creationId xmlns:a16="http://schemas.microsoft.com/office/drawing/2014/main" id="{D97CF0B6-7050-4EB1-999D-ABEEACAB5F6C}"/>
               </a:ext>
             </a:extLst>
           </p:cNvPr>
@@ -13458,7 +13458,7 @@
           <p:cNvPr id="18" name="">
             <a:extLst xmlns:a="http://schemas.openxmlformats.org/drawingml/2006/main">
               <a:ext uri="{FF2B5EF4-FFF2-40B4-BE49-F238E27FC236}">
-                <a16:creationId xmlns:a16="http://schemas.microsoft.com/office/drawing/2014/main" id="{5E9D56F1-0754-47F9-A7D6-7536562A33B3}"/>
+                <a16:creationId xmlns:a16="http://schemas.microsoft.com/office/drawing/2014/main" id="{A7326084-4593-4F3E-880C-79DEC1ED66BD}"/>
               </a:ext>
             </a:extLst>
           </p:cNvPr>
@@ -13491,7 +13491,7 @@
           <p:cNvPr id="19" name="">
             <a:extLst xmlns:a="http://schemas.openxmlformats.org/drawingml/2006/main">
               <a:ext uri="{FF2B5EF4-FFF2-40B4-BE49-F238E27FC236}">
-                <a16:creationId xmlns:a16="http://schemas.microsoft.com/office/drawing/2014/main" id="{C1437D9D-91D3-41A1-AA85-2EC74F50E519}"/>
+                <a16:creationId xmlns:a16="http://schemas.microsoft.com/office/drawing/2014/main" id="{7A8CCDC8-C219-481D-BF5A-FCDE24A2F900}"/>
               </a:ext>
             </a:extLst>
           </p:cNvPr>
@@ -13555,7 +13555,7 @@
           <p:cNvPr id="20" name="">
             <a:extLst xmlns:a="http://schemas.openxmlformats.org/drawingml/2006/main">
               <a:ext uri="{FF2B5EF4-FFF2-40B4-BE49-F238E27FC236}">
-                <a16:creationId xmlns:a16="http://schemas.microsoft.com/office/drawing/2014/main" id="{BDF86A63-C1D9-46B9-8EA8-725B2C903004}"/>
+                <a16:creationId xmlns:a16="http://schemas.microsoft.com/office/drawing/2014/main" id="{E6C2D276-8C3F-426E-AE56-12BDA7EABE26}"/>
               </a:ext>
             </a:extLst>
           </p:cNvPr>
@@ -13590,7 +13590,7 @@
           <p:cNvPr id="21" name="">
             <a:extLst xmlns:a="http://schemas.openxmlformats.org/drawingml/2006/main">
               <a:ext uri="{FF2B5EF4-FFF2-40B4-BE49-F238E27FC236}">
-                <a16:creationId xmlns:a16="http://schemas.microsoft.com/office/drawing/2014/main" id="{D94D7518-0BD5-4F98-8A4B-D4E0C01C3554}"/>
+                <a16:creationId xmlns:a16="http://schemas.microsoft.com/office/drawing/2014/main" id="{31286EB4-9EF7-4FD4-8F65-FAB68CCD52B1}"/>
               </a:ext>
             </a:extLst>
           </p:cNvPr>
@@ -13654,7 +13654,7 @@
           <p:cNvPr id="22" name="">
             <a:extLst xmlns:a="http://schemas.openxmlformats.org/drawingml/2006/main">
               <a:ext uri="{FF2B5EF4-FFF2-40B4-BE49-F238E27FC236}">
-                <a16:creationId xmlns:a16="http://schemas.microsoft.com/office/drawing/2014/main" id="{6DA32497-9112-4DDE-BBC7-A08C76D3E034}"/>
+                <a16:creationId xmlns:a16="http://schemas.microsoft.com/office/drawing/2014/main" id="{60898A83-2896-4EA4-846B-A505030B3DFF}"/>
               </a:ext>
             </a:extLst>
           </p:cNvPr>
@@ -13689,7 +13689,7 @@
           <p:cNvPr id="23" name="">
             <a:extLst xmlns:a="http://schemas.openxmlformats.org/drawingml/2006/main">
               <a:ext uri="{FF2B5EF4-FFF2-40B4-BE49-F238E27FC236}">
-                <a16:creationId xmlns:a16="http://schemas.microsoft.com/office/drawing/2014/main" id="{5BDE4119-4586-42A0-83DE-4F0DDBB31BA3}"/>
+                <a16:creationId xmlns:a16="http://schemas.microsoft.com/office/drawing/2014/main" id="{F454251A-DF17-4CD8-A1F2-6CF6980A3CF4}"/>
               </a:ext>
             </a:extLst>
           </p:cNvPr>
@@ -13753,7 +13753,7 @@
           <p:cNvPr id="24" name="">
             <a:extLst xmlns:a="http://schemas.openxmlformats.org/drawingml/2006/main">
               <a:ext uri="{FF2B5EF4-FFF2-40B4-BE49-F238E27FC236}">
-                <a16:creationId xmlns:a16="http://schemas.microsoft.com/office/drawing/2014/main" id="{BC8C9FEA-ADAA-4CFA-8E44-CDEDB0488B7B}"/>
+                <a16:creationId xmlns:a16="http://schemas.microsoft.com/office/drawing/2014/main" id="{C35B62DB-3A19-4679-999E-DD157DE4EEFE}"/>
               </a:ext>
             </a:extLst>
           </p:cNvPr>
@@ -13788,7 +13788,7 @@
           <p:cNvPr id="25" name="">
             <a:extLst xmlns:a="http://schemas.openxmlformats.org/drawingml/2006/main">
               <a:ext uri="{FF2B5EF4-FFF2-40B4-BE49-F238E27FC236}">
-                <a16:creationId xmlns:a16="http://schemas.microsoft.com/office/drawing/2014/main" id="{37EBC743-3F19-4FF5-A6C3-7901BA4E0412}"/>
+                <a16:creationId xmlns:a16="http://schemas.microsoft.com/office/drawing/2014/main" id="{1D678E19-30F1-4B50-A1FB-2E7148987373}"/>
               </a:ext>
             </a:extLst>
           </p:cNvPr>
@@ -13852,7 +13852,7 @@
           <p:cNvPr id="26" name="">
             <a:extLst xmlns:a="http://schemas.openxmlformats.org/drawingml/2006/main">
               <a:ext uri="{FF2B5EF4-FFF2-40B4-BE49-F238E27FC236}">
-                <a16:creationId xmlns:a16="http://schemas.microsoft.com/office/drawing/2014/main" id="{CD7319B4-9487-4FA9-8DE8-49CCD02171D3}"/>
+                <a16:creationId xmlns:a16="http://schemas.microsoft.com/office/drawing/2014/main" id="{024B0F02-B5A1-4F6C-AF30-96495C0D94FA}"/>
               </a:ext>
             </a:extLst>
           </p:cNvPr>
@@ -13887,7 +13887,7 @@
           <p:cNvPr id="27" name="">
             <a:extLst xmlns:a="http://schemas.openxmlformats.org/drawingml/2006/main">
               <a:ext uri="{FF2B5EF4-FFF2-40B4-BE49-F238E27FC236}">
-                <a16:creationId xmlns:a16="http://schemas.microsoft.com/office/drawing/2014/main" id="{5E968B11-6650-4F0A-97F7-C4177AE47B46}"/>
+                <a16:creationId xmlns:a16="http://schemas.microsoft.com/office/drawing/2014/main" id="{5474C7AD-40DD-470E-80D8-60045032E7CC}"/>
               </a:ext>
             </a:extLst>
           </p:cNvPr>
@@ -13951,7 +13951,7 @@
           <p:cNvPr id="28" name="">
             <a:extLst xmlns:a="http://schemas.openxmlformats.org/drawingml/2006/main">
               <a:ext uri="{FF2B5EF4-FFF2-40B4-BE49-F238E27FC236}">
-                <a16:creationId xmlns:a16="http://schemas.microsoft.com/office/drawing/2014/main" id="{37FE67BB-FAB7-4BA5-8186-85F2AE102903}"/>
+                <a16:creationId xmlns:a16="http://schemas.microsoft.com/office/drawing/2014/main" id="{103441E4-7278-45BF-86C2-40EE6DFBD726}"/>
               </a:ext>
             </a:extLst>
           </p:cNvPr>
@@ -14013,7 +14013,7 @@
     </p:spTree>
     <p:extLst>
       <p:ext uri="{BB962C8B-B14F-4D97-AF65-F5344CB8AC3E}">
-        <p14:creationId xmlns:p14="http://schemas.microsoft.com/office/powerpoint/2010/main" val="2038103561"/>
+        <p14:creationId xmlns:p14="http://schemas.microsoft.com/office/powerpoint/2010/main" val="1898815126"/>
       </p:ext>
     </p:extLst>
   </p:cSld>
@@ -14037,7 +14037,7 @@
           <p:cNvPr id="1" name="">
             <a:extLst xmlns:a="http://schemas.openxmlformats.org/drawingml/2006/main">
               <a:ext uri="{FF2B5EF4-FFF2-40B4-BE49-F238E27FC236}">
-                <a16:creationId xmlns:a16="http://schemas.microsoft.com/office/drawing/2014/main" id="{ADBC4EF0-8DDA-4A91-B7C0-B9B856F15503}"/>
+                <a16:creationId xmlns:a16="http://schemas.microsoft.com/office/drawing/2014/main" id="{B0D07BED-5224-4F9F-B45A-DF9B62D0668C}"/>
               </a:ext>
             </a:extLst>
           </p:cNvPr>
@@ -14072,7 +14072,7 @@
           <p:cNvPr id="2" name="">
             <a:extLst xmlns:a="http://schemas.openxmlformats.org/drawingml/2006/main">
               <a:ext uri="{FF2B5EF4-FFF2-40B4-BE49-F238E27FC236}">
-                <a16:creationId xmlns:a16="http://schemas.microsoft.com/office/drawing/2014/main" id="{4F35EE1B-EB3E-42CB-A434-7DE90F40EF9B}"/>
+                <a16:creationId xmlns:a16="http://schemas.microsoft.com/office/drawing/2014/main" id="{E7747FD8-5BAC-4BF6-AD92-5ABBE1424B0F}"/>
               </a:ext>
             </a:extLst>
           </p:cNvPr>
@@ -14107,7 +14107,7 @@
           <p:cNvPr id="3" name="">
             <a:extLst xmlns:a="http://schemas.openxmlformats.org/drawingml/2006/main">
               <a:ext uri="{FF2B5EF4-FFF2-40B4-BE49-F238E27FC236}">
-                <a16:creationId xmlns:a16="http://schemas.microsoft.com/office/drawing/2014/main" id="{CED9E310-81DD-4B78-A8AA-EE5764C39BF5}"/>
+                <a16:creationId xmlns:a16="http://schemas.microsoft.com/office/drawing/2014/main" id="{9647060F-26FD-47F8-A0D3-CE03911B81A7}"/>
               </a:ext>
             </a:extLst>
           </p:cNvPr>
@@ -14171,7 +14171,7 @@
           <p:cNvPr id="4" name="">
             <a:extLst xmlns:a="http://schemas.openxmlformats.org/drawingml/2006/main">
               <a:ext uri="{FF2B5EF4-FFF2-40B4-BE49-F238E27FC236}">
-                <a16:creationId xmlns:a16="http://schemas.microsoft.com/office/drawing/2014/main" id="{DBB708F9-7A6D-4DB6-850C-4BBB88AF9A87}"/>
+                <a16:creationId xmlns:a16="http://schemas.microsoft.com/office/drawing/2014/main" id="{E116D9B1-5A94-49BB-9EB1-DBA0066B138D}"/>
               </a:ext>
             </a:extLst>
           </p:cNvPr>
@@ -14235,7 +14235,7 @@
           <p:cNvPr id="5" name="">
             <a:extLst xmlns:a="http://schemas.openxmlformats.org/drawingml/2006/main">
               <a:ext uri="{FF2B5EF4-FFF2-40B4-BE49-F238E27FC236}">
-                <a16:creationId xmlns:a16="http://schemas.microsoft.com/office/drawing/2014/main" id="{3FD34F3B-F99A-45EA-A92D-6B85CADDDF42}"/>
+                <a16:creationId xmlns:a16="http://schemas.microsoft.com/office/drawing/2014/main" id="{610B29D1-E6C4-424C-A34E-5F65AA9C8EBA}"/>
               </a:ext>
             </a:extLst>
           </p:cNvPr>
@@ -14299,7 +14299,7 @@
           <p:cNvPr id="6" name="">
             <a:extLst xmlns:a="http://schemas.openxmlformats.org/drawingml/2006/main">
               <a:ext uri="{FF2B5EF4-FFF2-40B4-BE49-F238E27FC236}">
-                <a16:creationId xmlns:a16="http://schemas.microsoft.com/office/drawing/2014/main" id="{26130A6C-283A-4B79-864E-A3CB5B795185}"/>
+                <a16:creationId xmlns:a16="http://schemas.microsoft.com/office/drawing/2014/main" id="{586B666B-9580-4395-ACF1-7450D68D0546}"/>
               </a:ext>
             </a:extLst>
           </p:cNvPr>
@@ -14332,7 +14332,7 @@
           <p:cNvPr id="7" name="">
             <a:extLst xmlns:a="http://schemas.openxmlformats.org/drawingml/2006/main">
               <a:ext uri="{FF2B5EF4-FFF2-40B4-BE49-F238E27FC236}">
-                <a16:creationId xmlns:a16="http://schemas.microsoft.com/office/drawing/2014/main" id="{BC89AD8A-ABCB-4801-A9DE-360146CB97EA}"/>
+                <a16:creationId xmlns:a16="http://schemas.microsoft.com/office/drawing/2014/main" id="{4D4B4A15-1B1E-4AF6-AFF6-2AB1B3423ACF}"/>
               </a:ext>
             </a:extLst>
           </p:cNvPr>
@@ -14396,7 +14396,7 @@
           <p:cNvPr id="8" name="">
             <a:extLst xmlns:a="http://schemas.openxmlformats.org/drawingml/2006/main">
               <a:ext uri="{FF2B5EF4-FFF2-40B4-BE49-F238E27FC236}">
-                <a16:creationId xmlns:a16="http://schemas.microsoft.com/office/drawing/2014/main" id="{A6B56A3F-8E0C-4902-A1EA-E00BECA55C4E}"/>
+                <a16:creationId xmlns:a16="http://schemas.microsoft.com/office/drawing/2014/main" id="{4F3685FC-7177-4BB4-80FA-906D5D089E10}"/>
               </a:ext>
             </a:extLst>
           </p:cNvPr>
@@ -14429,7 +14429,7 @@
           <p:cNvPr id="9" name="">
             <a:extLst xmlns:a="http://schemas.openxmlformats.org/drawingml/2006/main">
               <a:ext uri="{FF2B5EF4-FFF2-40B4-BE49-F238E27FC236}">
-                <a16:creationId xmlns:a16="http://schemas.microsoft.com/office/drawing/2014/main" id="{384667DE-79DD-47F1-94BA-96579AE1BF1D}"/>
+                <a16:creationId xmlns:a16="http://schemas.microsoft.com/office/drawing/2014/main" id="{E383EDFA-28D1-42E6-9F2B-D6F93345E299}"/>
               </a:ext>
             </a:extLst>
           </p:cNvPr>
@@ -14493,7 +14493,7 @@
           <p:cNvPr id="10" name="">
             <a:extLst xmlns:a="http://schemas.openxmlformats.org/drawingml/2006/main">
               <a:ext uri="{FF2B5EF4-FFF2-40B4-BE49-F238E27FC236}">
-                <a16:creationId xmlns:a16="http://schemas.microsoft.com/office/drawing/2014/main" id="{B50A3EEF-E49B-4FE6-9812-28A7B3FD59C6}"/>
+                <a16:creationId xmlns:a16="http://schemas.microsoft.com/office/drawing/2014/main" id="{C0F1C79C-36B5-466C-909B-4599A8CA4FED}"/>
               </a:ext>
             </a:extLst>
           </p:cNvPr>
@@ -14557,7 +14557,7 @@
           <p:cNvPr id="11" name="">
             <a:extLst xmlns:a="http://schemas.openxmlformats.org/drawingml/2006/main">
               <a:ext uri="{FF2B5EF4-FFF2-40B4-BE49-F238E27FC236}">
-                <a16:creationId xmlns:a16="http://schemas.microsoft.com/office/drawing/2014/main" id="{4EEA9129-6DA5-4D13-AE52-A45456D27B75}"/>
+                <a16:creationId xmlns:a16="http://schemas.microsoft.com/office/drawing/2014/main" id="{39AFB0F8-6034-49F3-BBCD-12DE20B71670}"/>
               </a:ext>
             </a:extLst>
           </p:cNvPr>
@@ -14590,7 +14590,7 @@
           <p:cNvPr id="12" name="">
             <a:extLst xmlns:a="http://schemas.openxmlformats.org/drawingml/2006/main">
               <a:ext uri="{FF2B5EF4-FFF2-40B4-BE49-F238E27FC236}">
-                <a16:creationId xmlns:a16="http://schemas.microsoft.com/office/drawing/2014/main" id="{07289153-0E2D-4481-81DD-00476856D5B9}"/>
+                <a16:creationId xmlns:a16="http://schemas.microsoft.com/office/drawing/2014/main" id="{E9918C91-335F-42A2-979F-228D6BA082B3}"/>
               </a:ext>
             </a:extLst>
           </p:cNvPr>
@@ -14654,7 +14654,7 @@
           <p:cNvPr id="13" name="">
             <a:extLst xmlns:a="http://schemas.openxmlformats.org/drawingml/2006/main">
               <a:ext uri="{FF2B5EF4-FFF2-40B4-BE49-F238E27FC236}">
-                <a16:creationId xmlns:a16="http://schemas.microsoft.com/office/drawing/2014/main" id="{09E1468D-26BE-4063-9E12-9EF83D9DEF5A}"/>
+                <a16:creationId xmlns:a16="http://schemas.microsoft.com/office/drawing/2014/main" id="{469BBA91-1BAC-4235-AE4F-C5342E50FF07}"/>
               </a:ext>
             </a:extLst>
           </p:cNvPr>
@@ -14718,7 +14718,7 @@
           <p:cNvPr id="14" name="">
             <a:extLst xmlns:a="http://schemas.openxmlformats.org/drawingml/2006/main">
               <a:ext uri="{FF2B5EF4-FFF2-40B4-BE49-F238E27FC236}">
-                <a16:creationId xmlns:a16="http://schemas.microsoft.com/office/drawing/2014/main" id="{45DE4C85-C9DA-4551-9B77-7B239E9738B1}"/>
+                <a16:creationId xmlns:a16="http://schemas.microsoft.com/office/drawing/2014/main" id="{2128DEF5-A5CA-4C86-BE1C-F8647B63C5A1}"/>
               </a:ext>
             </a:extLst>
           </p:cNvPr>
@@ -14751,7 +14751,7 @@
           <p:cNvPr id="15" name="">
             <a:extLst xmlns:a="http://schemas.openxmlformats.org/drawingml/2006/main">
               <a:ext uri="{FF2B5EF4-FFF2-40B4-BE49-F238E27FC236}">
-                <a16:creationId xmlns:a16="http://schemas.microsoft.com/office/drawing/2014/main" id="{A3B768C1-6D9D-4EBD-B683-2446D8A41FC5}"/>
+                <a16:creationId xmlns:a16="http://schemas.microsoft.com/office/drawing/2014/main" id="{BF9FC020-6E74-492A-A368-3D207022CD3E}"/>
               </a:ext>
             </a:extLst>
           </p:cNvPr>
@@ -14815,7 +14815,7 @@
           <p:cNvPr id="16" name="">
             <a:extLst xmlns:a="http://schemas.openxmlformats.org/drawingml/2006/main">
               <a:ext uri="{FF2B5EF4-FFF2-40B4-BE49-F238E27FC236}">
-                <a16:creationId xmlns:a16="http://schemas.microsoft.com/office/drawing/2014/main" id="{E233537B-BE31-407B-99E0-6430D5A2E87F}"/>
+                <a16:creationId xmlns:a16="http://schemas.microsoft.com/office/drawing/2014/main" id="{2D3BBC3B-E998-4DB9-8D1F-73F539AC325A}"/>
               </a:ext>
             </a:extLst>
           </p:cNvPr>
@@ -14879,7 +14879,7 @@
           <p:cNvPr id="17" name="">
             <a:extLst xmlns:a="http://schemas.openxmlformats.org/drawingml/2006/main">
               <a:ext uri="{FF2B5EF4-FFF2-40B4-BE49-F238E27FC236}">
-                <a16:creationId xmlns:a16="http://schemas.microsoft.com/office/drawing/2014/main" id="{45654219-81BD-4315-9BF6-E6B5BF90B48C}"/>
+                <a16:creationId xmlns:a16="http://schemas.microsoft.com/office/drawing/2014/main" id="{1F9C1146-313D-4052-947D-F944A69CFF5A}"/>
               </a:ext>
             </a:extLst>
           </p:cNvPr>
@@ -14912,7 +14912,7 @@
           <p:cNvPr id="18" name="">
             <a:extLst xmlns:a="http://schemas.openxmlformats.org/drawingml/2006/main">
               <a:ext uri="{FF2B5EF4-FFF2-40B4-BE49-F238E27FC236}">
-                <a16:creationId xmlns:a16="http://schemas.microsoft.com/office/drawing/2014/main" id="{F19A07A3-718D-4896-88C9-EB77BA2D3F75}"/>
+                <a16:creationId xmlns:a16="http://schemas.microsoft.com/office/drawing/2014/main" id="{7F180A9F-BDD4-4AFB-BE8A-2124AF8482A3}"/>
               </a:ext>
             </a:extLst>
           </p:cNvPr>
@@ -14976,7 +14976,7 @@
           <p:cNvPr id="19" name="">
             <a:extLst xmlns:a="http://schemas.openxmlformats.org/drawingml/2006/main">
               <a:ext uri="{FF2B5EF4-FFF2-40B4-BE49-F238E27FC236}">
-                <a16:creationId xmlns:a16="http://schemas.microsoft.com/office/drawing/2014/main" id="{6A157CAD-9588-4BE5-B157-D35FEFE99D2F}"/>
+                <a16:creationId xmlns:a16="http://schemas.microsoft.com/office/drawing/2014/main" id="{B3FF2B24-77D3-407F-8A87-CC77B8D58F8A}"/>
               </a:ext>
             </a:extLst>
           </p:cNvPr>
@@ -15040,7 +15040,7 @@
           <p:cNvPr id="20" name="">
             <a:extLst xmlns:a="http://schemas.openxmlformats.org/drawingml/2006/main">
               <a:ext uri="{FF2B5EF4-FFF2-40B4-BE49-F238E27FC236}">
-                <a16:creationId xmlns:a16="http://schemas.microsoft.com/office/drawing/2014/main" id="{E409146F-2260-4463-B5E8-14FB2B0E74C5}"/>
+                <a16:creationId xmlns:a16="http://schemas.microsoft.com/office/drawing/2014/main" id="{64750027-71C5-4418-A106-FEB4E2409094}"/>
               </a:ext>
             </a:extLst>
           </p:cNvPr>
@@ -15073,7 +15073,7 @@
           <p:cNvPr id="21" name="">
             <a:extLst xmlns:a="http://schemas.openxmlformats.org/drawingml/2006/main">
               <a:ext uri="{FF2B5EF4-FFF2-40B4-BE49-F238E27FC236}">
-                <a16:creationId xmlns:a16="http://schemas.microsoft.com/office/drawing/2014/main" id="{0742DE28-6CFB-4E9C-B9A0-604F2CBB5A40}"/>
+                <a16:creationId xmlns:a16="http://schemas.microsoft.com/office/drawing/2014/main" id="{D6E6AFBC-56FC-4F01-8D34-ED8B8CA7F317}"/>
               </a:ext>
             </a:extLst>
           </p:cNvPr>
@@ -15137,7 +15137,7 @@
           <p:cNvPr id="22" name="">
             <a:extLst xmlns:a="http://schemas.openxmlformats.org/drawingml/2006/main">
               <a:ext uri="{FF2B5EF4-FFF2-40B4-BE49-F238E27FC236}">
-                <a16:creationId xmlns:a16="http://schemas.microsoft.com/office/drawing/2014/main" id="{343FECD4-90D1-439A-A625-7DE5088A6BFA}"/>
+                <a16:creationId xmlns:a16="http://schemas.microsoft.com/office/drawing/2014/main" id="{362478AA-B509-4930-9B4D-53CA50552D3E}"/>
               </a:ext>
             </a:extLst>
           </p:cNvPr>
@@ -15201,7 +15201,7 @@
           <p:cNvPr id="23" name="">
             <a:extLst xmlns:a="http://schemas.openxmlformats.org/drawingml/2006/main">
               <a:ext uri="{FF2B5EF4-FFF2-40B4-BE49-F238E27FC236}">
-                <a16:creationId xmlns:a16="http://schemas.microsoft.com/office/drawing/2014/main" id="{400DDC8E-F0EE-4045-A9E9-CB1B153E656F}"/>
+                <a16:creationId xmlns:a16="http://schemas.microsoft.com/office/drawing/2014/main" id="{4E840787-2F6D-4C47-BC1D-10590F23AE4D}"/>
               </a:ext>
             </a:extLst>
           </p:cNvPr>
@@ -15236,7 +15236,7 @@
           <p:cNvPr id="24" name="">
             <a:extLst xmlns:a="http://schemas.openxmlformats.org/drawingml/2006/main">
               <a:ext uri="{FF2B5EF4-FFF2-40B4-BE49-F238E27FC236}">
-                <a16:creationId xmlns:a16="http://schemas.microsoft.com/office/drawing/2014/main" id="{BAA150CA-57CF-46B6-BEAF-5FB3734CE2BF}"/>
+                <a16:creationId xmlns:a16="http://schemas.microsoft.com/office/drawing/2014/main" id="{0F5FA86B-BD16-4516-87BC-7FA8CBA7C1C7}"/>
               </a:ext>
             </a:extLst>
           </p:cNvPr>
@@ -15271,7 +15271,7 @@
           <p:cNvPr id="25" name="">
             <a:extLst xmlns:a="http://schemas.openxmlformats.org/drawingml/2006/main">
               <a:ext uri="{FF2B5EF4-FFF2-40B4-BE49-F238E27FC236}">
-                <a16:creationId xmlns:a16="http://schemas.microsoft.com/office/drawing/2014/main" id="{DD3187D2-338A-4F27-AB98-60213FD7FA36}"/>
+                <a16:creationId xmlns:a16="http://schemas.microsoft.com/office/drawing/2014/main" id="{E46A13DE-FC17-44A8-94B0-A620A3FAA5C2}"/>
               </a:ext>
             </a:extLst>
           </p:cNvPr>
@@ -15306,7 +15306,7 @@
           <p:cNvPr id="26" name="">
             <a:extLst xmlns:a="http://schemas.openxmlformats.org/drawingml/2006/main">
               <a:ext uri="{FF2B5EF4-FFF2-40B4-BE49-F238E27FC236}">
-                <a16:creationId xmlns:a16="http://schemas.microsoft.com/office/drawing/2014/main" id="{88288C9D-7D67-48EB-9506-36168432871B}"/>
+                <a16:creationId xmlns:a16="http://schemas.microsoft.com/office/drawing/2014/main" id="{70A53E6E-AE5A-487B-B3B1-E16191D4963E}"/>
               </a:ext>
             </a:extLst>
           </p:cNvPr>
@@ -15341,7 +15341,7 @@
           <p:cNvPr id="27" name="">
             <a:extLst xmlns:a="http://schemas.openxmlformats.org/drawingml/2006/main">
               <a:ext uri="{FF2B5EF4-FFF2-40B4-BE49-F238E27FC236}">
-                <a16:creationId xmlns:a16="http://schemas.microsoft.com/office/drawing/2014/main" id="{8A95F9C4-4726-4CA0-9E8F-8D69EC5E6798}"/>
+                <a16:creationId xmlns:a16="http://schemas.microsoft.com/office/drawing/2014/main" id="{A8481A76-1B3B-4027-A549-CD742A1AFDAE}"/>
               </a:ext>
             </a:extLst>
           </p:cNvPr>
@@ -15376,7 +15376,7 @@
           <p:cNvPr id="28" name="">
             <a:extLst xmlns:a="http://schemas.openxmlformats.org/drawingml/2006/main">
               <a:ext uri="{FF2B5EF4-FFF2-40B4-BE49-F238E27FC236}">
-                <a16:creationId xmlns:a16="http://schemas.microsoft.com/office/drawing/2014/main" id="{1471760F-8CDD-402A-B47E-7AC81AD8F4D6}"/>
+                <a16:creationId xmlns:a16="http://schemas.microsoft.com/office/drawing/2014/main" id="{C11933FA-CE21-4BD5-8FC6-D2952CAB9D9F}"/>
               </a:ext>
             </a:extLst>
           </p:cNvPr>
@@ -15409,7 +15409,7 @@
           <p:cNvPr id="29" name="">
             <a:extLst xmlns:a="http://schemas.openxmlformats.org/drawingml/2006/main">
               <a:ext uri="{FF2B5EF4-FFF2-40B4-BE49-F238E27FC236}">
-                <a16:creationId xmlns:a16="http://schemas.microsoft.com/office/drawing/2014/main" id="{21C736B7-B61F-466B-B9F3-68BED3CC3047}"/>
+                <a16:creationId xmlns:a16="http://schemas.microsoft.com/office/drawing/2014/main" id="{53D78C82-76BF-4F4F-92B8-C357EF2C0BCB}"/>
               </a:ext>
             </a:extLst>
           </p:cNvPr>
@@ -15473,7 +15473,7 @@
           <p:cNvPr id="30" name="">
             <a:extLst xmlns:a="http://schemas.openxmlformats.org/drawingml/2006/main">
               <a:ext uri="{FF2B5EF4-FFF2-40B4-BE49-F238E27FC236}">
-                <a16:creationId xmlns:a16="http://schemas.microsoft.com/office/drawing/2014/main" id="{01624E79-75E4-48FF-AE94-28A8A2A40057}"/>
+                <a16:creationId xmlns:a16="http://schemas.microsoft.com/office/drawing/2014/main" id="{679B5D9F-3D21-4C0B-81F2-0ED598FEAD1E}"/>
               </a:ext>
             </a:extLst>
           </p:cNvPr>
@@ -15537,7 +15537,7 @@
           <p:cNvPr id="31" name="">
             <a:extLst xmlns:a="http://schemas.openxmlformats.org/drawingml/2006/main">
               <a:ext uri="{FF2B5EF4-FFF2-40B4-BE49-F238E27FC236}">
-                <a16:creationId xmlns:a16="http://schemas.microsoft.com/office/drawing/2014/main" id="{AE1D486E-2763-4D9A-B04C-4BBF96C489E5}"/>
+                <a16:creationId xmlns:a16="http://schemas.microsoft.com/office/drawing/2014/main" id="{55B24FC3-78D2-4E47-91E5-2FB2BFE9A87C}"/>
               </a:ext>
             </a:extLst>
           </p:cNvPr>
@@ -15572,7 +15572,7 @@
           <p:cNvPr id="32" name="">
             <a:extLst xmlns:a="http://schemas.openxmlformats.org/drawingml/2006/main">
               <a:ext uri="{FF2B5EF4-FFF2-40B4-BE49-F238E27FC236}">
-                <a16:creationId xmlns:a16="http://schemas.microsoft.com/office/drawing/2014/main" id="{1D8FA578-0A08-499D-8CC1-1B05FAD9B70A}"/>
+                <a16:creationId xmlns:a16="http://schemas.microsoft.com/office/drawing/2014/main" id="{705ABC8C-7E2A-478C-AB6B-CEC1A49AA658}"/>
               </a:ext>
             </a:extLst>
           </p:cNvPr>
@@ -15636,7 +15636,7 @@
           <p:cNvPr id="33" name="">
             <a:extLst xmlns:a="http://schemas.openxmlformats.org/drawingml/2006/main">
               <a:ext uri="{FF2B5EF4-FFF2-40B4-BE49-F238E27FC236}">
-                <a16:creationId xmlns:a16="http://schemas.microsoft.com/office/drawing/2014/main" id="{D4E67EAE-8C5E-4058-A77E-652170D8F6D1}"/>
+                <a16:creationId xmlns:a16="http://schemas.microsoft.com/office/drawing/2014/main" id="{8EB63B21-F30B-42A7-AEDF-2350DB7B69CE}"/>
               </a:ext>
             </a:extLst>
           </p:cNvPr>
@@ -15698,7 +15698,7 @@
     </p:spTree>
     <p:extLst>
       <p:ext uri="{BB962C8B-B14F-4D97-AF65-F5344CB8AC3E}">
-        <p14:creationId xmlns:p14="http://schemas.microsoft.com/office/powerpoint/2010/main" val="1815082802"/>
+        <p14:creationId xmlns:p14="http://schemas.microsoft.com/office/powerpoint/2010/main" val="675192537"/>
       </p:ext>
     </p:extLst>
   </p:cSld>
@@ -15722,7 +15722,7 @@
           <p:cNvPr id="1" name="">
             <a:extLst xmlns:a="http://schemas.openxmlformats.org/drawingml/2006/main">
               <a:ext uri="{FF2B5EF4-FFF2-40B4-BE49-F238E27FC236}">
-                <a16:creationId xmlns:a16="http://schemas.microsoft.com/office/drawing/2014/main" id="{B1381AF1-734B-4D15-860A-EA6CFB0F1D70}"/>
+                <a16:creationId xmlns:a16="http://schemas.microsoft.com/office/drawing/2014/main" id="{2A6C3B95-69A8-4438-BEF1-E85FF2128536}"/>
               </a:ext>
             </a:extLst>
           </p:cNvPr>
@@ -15757,7 +15757,7 @@
           <p:cNvPr id="2" name="">
             <a:extLst xmlns:a="http://schemas.openxmlformats.org/drawingml/2006/main">
               <a:ext uri="{FF2B5EF4-FFF2-40B4-BE49-F238E27FC236}">
-                <a16:creationId xmlns:a16="http://schemas.microsoft.com/office/drawing/2014/main" id="{FCA71619-1E7C-4989-94E3-D4340C3AE0A2}"/>
+                <a16:creationId xmlns:a16="http://schemas.microsoft.com/office/drawing/2014/main" id="{8FFD5C04-60EC-4208-869A-EC9650C31522}"/>
               </a:ext>
             </a:extLst>
           </p:cNvPr>
@@ -15792,7 +15792,7 @@
           <p:cNvPr id="3" name="">
             <a:extLst xmlns:a="http://schemas.openxmlformats.org/drawingml/2006/main">
               <a:ext uri="{FF2B5EF4-FFF2-40B4-BE49-F238E27FC236}">
-                <a16:creationId xmlns:a16="http://schemas.microsoft.com/office/drawing/2014/main" id="{F3B58373-5C02-44B7-9FE3-C23AEB9EF485}"/>
+                <a16:creationId xmlns:a16="http://schemas.microsoft.com/office/drawing/2014/main" id="{653D9CFB-8368-42B7-9E30-4C691275FC54}"/>
               </a:ext>
             </a:extLst>
           </p:cNvPr>
@@ -15856,7 +15856,7 @@
           <p:cNvPr id="4" name="">
             <a:extLst xmlns:a="http://schemas.openxmlformats.org/drawingml/2006/main">
               <a:ext uri="{FF2B5EF4-FFF2-40B4-BE49-F238E27FC236}">
-                <a16:creationId xmlns:a16="http://schemas.microsoft.com/office/drawing/2014/main" id="{3E5AFC64-BC66-4404-AB07-0E836A91C79D}"/>
+                <a16:creationId xmlns:a16="http://schemas.microsoft.com/office/drawing/2014/main" id="{32C353BF-FD86-46A8-8521-21D165513F43}"/>
               </a:ext>
             </a:extLst>
           </p:cNvPr>
@@ -15920,7 +15920,7 @@
           <p:cNvPr id="5" name="">
             <a:extLst xmlns:a="http://schemas.openxmlformats.org/drawingml/2006/main">
               <a:ext uri="{FF2B5EF4-FFF2-40B4-BE49-F238E27FC236}">
-                <a16:creationId xmlns:a16="http://schemas.microsoft.com/office/drawing/2014/main" id="{1C6C6B8D-8A85-4DFE-A37D-F695CAE74732}"/>
+                <a16:creationId xmlns:a16="http://schemas.microsoft.com/office/drawing/2014/main" id="{FC17F448-D251-480A-9571-D2C8B23293A1}"/>
               </a:ext>
             </a:extLst>
           </p:cNvPr>
@@ -15984,7 +15984,7 @@
           <p:cNvPr id="6" name="">
             <a:extLst xmlns:a="http://schemas.openxmlformats.org/drawingml/2006/main">
               <a:ext uri="{FF2B5EF4-FFF2-40B4-BE49-F238E27FC236}">
-                <a16:creationId xmlns:a16="http://schemas.microsoft.com/office/drawing/2014/main" id="{E48A6250-A8B1-4BF7-8A4F-B846A141D54E}"/>
+                <a16:creationId xmlns:a16="http://schemas.microsoft.com/office/drawing/2014/main" id="{FD71A76E-1467-460F-9906-3C59D72BFB2C}"/>
               </a:ext>
             </a:extLst>
           </p:cNvPr>
@@ -16017,7 +16017,7 @@
           <p:cNvPr id="7" name="">
             <a:extLst xmlns:a="http://schemas.openxmlformats.org/drawingml/2006/main">
               <a:ext uri="{FF2B5EF4-FFF2-40B4-BE49-F238E27FC236}">
-                <a16:creationId xmlns:a16="http://schemas.microsoft.com/office/drawing/2014/main" id="{55771272-8B2A-412F-B72A-DB6B1A8AA76F}"/>
+                <a16:creationId xmlns:a16="http://schemas.microsoft.com/office/drawing/2014/main" id="{D85779A8-56A3-4EBA-B700-6BA32D7AD4AA}"/>
               </a:ext>
             </a:extLst>
           </p:cNvPr>
@@ -16050,7 +16050,7 @@
           <p:cNvPr id="8" name="">
             <a:extLst xmlns:a="http://schemas.openxmlformats.org/drawingml/2006/main">
               <a:ext uri="{FF2B5EF4-FFF2-40B4-BE49-F238E27FC236}">
-                <a16:creationId xmlns:a16="http://schemas.microsoft.com/office/drawing/2014/main" id="{086E6B52-FBD6-460F-9CAD-195C57D095DA}"/>
+                <a16:creationId xmlns:a16="http://schemas.microsoft.com/office/drawing/2014/main" id="{293B7BBD-ACBC-4B3C-BA30-959870E7C487}"/>
               </a:ext>
             </a:extLst>
           </p:cNvPr>
@@ -16114,7 +16114,7 @@
           <p:cNvPr id="9" name="">
             <a:extLst xmlns:a="http://schemas.openxmlformats.org/drawingml/2006/main">
               <a:ext uri="{FF2B5EF4-FFF2-40B4-BE49-F238E27FC236}">
-                <a16:creationId xmlns:a16="http://schemas.microsoft.com/office/drawing/2014/main" id="{8A67373D-2142-4207-84D3-F2520176CE1D}"/>
+                <a16:creationId xmlns:a16="http://schemas.microsoft.com/office/drawing/2014/main" id="{099EC3DD-6F6B-4367-A724-0992BA8E3225}"/>
               </a:ext>
             </a:extLst>
           </p:cNvPr>
@@ -16149,7 +16149,7 @@
           <p:cNvPr id="10" name="">
             <a:extLst xmlns:a="http://schemas.openxmlformats.org/drawingml/2006/main">
               <a:ext uri="{FF2B5EF4-FFF2-40B4-BE49-F238E27FC236}">
-                <a16:creationId xmlns:a16="http://schemas.microsoft.com/office/drawing/2014/main" id="{07C76AA3-1072-48B2-9B01-CD873853E618}"/>
+                <a16:creationId xmlns:a16="http://schemas.microsoft.com/office/drawing/2014/main" id="{D60465A7-0CD1-4BC8-AC34-EA9F7BD5F5A4}"/>
               </a:ext>
             </a:extLst>
           </p:cNvPr>
@@ -16213,7 +16213,7 @@
           <p:cNvPr id="11" name="">
             <a:extLst xmlns:a="http://schemas.openxmlformats.org/drawingml/2006/main">
               <a:ext uri="{FF2B5EF4-FFF2-40B4-BE49-F238E27FC236}">
-                <a16:creationId xmlns:a16="http://schemas.microsoft.com/office/drawing/2014/main" id="{567A2CA0-1CAB-4BD5-B27A-F7191DE74AD8}"/>
+                <a16:creationId xmlns:a16="http://schemas.microsoft.com/office/drawing/2014/main" id="{DE79F328-2E0F-4BD5-9034-1C27E5DBBFD3}"/>
               </a:ext>
             </a:extLst>
           </p:cNvPr>
@@ -16248,7 +16248,7 @@
           <p:cNvPr id="12" name="">
             <a:extLst xmlns:a="http://schemas.openxmlformats.org/drawingml/2006/main">
               <a:ext uri="{FF2B5EF4-FFF2-40B4-BE49-F238E27FC236}">
-                <a16:creationId xmlns:a16="http://schemas.microsoft.com/office/drawing/2014/main" id="{21D7DD8B-C724-4A88-AB4F-E85B9FD28C47}"/>
+                <a16:creationId xmlns:a16="http://schemas.microsoft.com/office/drawing/2014/main" id="{6882758E-9EFB-4BE1-93A2-85FFFFC6A60E}"/>
               </a:ext>
             </a:extLst>
           </p:cNvPr>
@@ -16312,7 +16312,7 @@
           <p:cNvPr id="13" name="">
             <a:extLst xmlns:a="http://schemas.openxmlformats.org/drawingml/2006/main">
               <a:ext uri="{FF2B5EF4-FFF2-40B4-BE49-F238E27FC236}">
-                <a16:creationId xmlns:a16="http://schemas.microsoft.com/office/drawing/2014/main" id="{4E4F9E31-AB53-4849-9485-0AE41B40AD15}"/>
+                <a16:creationId xmlns:a16="http://schemas.microsoft.com/office/drawing/2014/main" id="{2DB73507-8F22-4B2F-A7FE-2B9F220BE7FC}"/>
               </a:ext>
             </a:extLst>
           </p:cNvPr>
@@ -16347,7 +16347,7 @@
           <p:cNvPr id="14" name="">
             <a:extLst xmlns:a="http://schemas.openxmlformats.org/drawingml/2006/main">
               <a:ext uri="{FF2B5EF4-FFF2-40B4-BE49-F238E27FC236}">
-                <a16:creationId xmlns:a16="http://schemas.microsoft.com/office/drawing/2014/main" id="{18E48AE9-ED5B-4A29-927E-98249B0901FB}"/>
+                <a16:creationId xmlns:a16="http://schemas.microsoft.com/office/drawing/2014/main" id="{9B8056B4-3F88-4470-94CC-5A56AB59008F}"/>
               </a:ext>
             </a:extLst>
           </p:cNvPr>
@@ -16411,7 +16411,7 @@
           <p:cNvPr id="15" name="">
             <a:extLst xmlns:a="http://schemas.openxmlformats.org/drawingml/2006/main">
               <a:ext uri="{FF2B5EF4-FFF2-40B4-BE49-F238E27FC236}">
-                <a16:creationId xmlns:a16="http://schemas.microsoft.com/office/drawing/2014/main" id="{C6937C2D-B770-4223-94C3-6C8F2F149481}"/>
+                <a16:creationId xmlns:a16="http://schemas.microsoft.com/office/drawing/2014/main" id="{AC5145D7-FEA9-4760-BA02-E9FD978E06F1}"/>
               </a:ext>
             </a:extLst>
           </p:cNvPr>
@@ -16446,7 +16446,7 @@
           <p:cNvPr id="16" name="">
             <a:extLst xmlns:a="http://schemas.openxmlformats.org/drawingml/2006/main">
               <a:ext uri="{FF2B5EF4-FFF2-40B4-BE49-F238E27FC236}">
-                <a16:creationId xmlns:a16="http://schemas.microsoft.com/office/drawing/2014/main" id="{ECBF1B50-4F81-4CBF-93CE-0BBD960096A3}"/>
+                <a16:creationId xmlns:a16="http://schemas.microsoft.com/office/drawing/2014/main" id="{AAF53BE8-A694-4C41-8D65-CF910DA62DDD}"/>
               </a:ext>
             </a:extLst>
           </p:cNvPr>
@@ -16510,7 +16510,7 @@
           <p:cNvPr id="17" name="">
             <a:extLst xmlns:a="http://schemas.openxmlformats.org/drawingml/2006/main">
               <a:ext uri="{FF2B5EF4-FFF2-40B4-BE49-F238E27FC236}">
-                <a16:creationId xmlns:a16="http://schemas.microsoft.com/office/drawing/2014/main" id="{889A9F6D-056B-4581-94C9-145DEF495042}"/>
+                <a16:creationId xmlns:a16="http://schemas.microsoft.com/office/drawing/2014/main" id="{BF1DE703-6CEB-457A-BEA2-88BA5AB50A29}"/>
               </a:ext>
             </a:extLst>
           </p:cNvPr>
@@ -16543,7 +16543,7 @@
           <p:cNvPr id="18" name="">
             <a:extLst xmlns:a="http://schemas.openxmlformats.org/drawingml/2006/main">
               <a:ext uri="{FF2B5EF4-FFF2-40B4-BE49-F238E27FC236}">
-                <a16:creationId xmlns:a16="http://schemas.microsoft.com/office/drawing/2014/main" id="{7C64E7A4-7BD9-48A4-82BA-C04AF830C304}"/>
+                <a16:creationId xmlns:a16="http://schemas.microsoft.com/office/drawing/2014/main" id="{39F7B198-94ED-4046-853E-4C6AF1CBB472}"/>
               </a:ext>
             </a:extLst>
           </p:cNvPr>
@@ -16576,7 +16576,7 @@
           <p:cNvPr id="19" name="">
             <a:extLst xmlns:a="http://schemas.openxmlformats.org/drawingml/2006/main">
               <a:ext uri="{FF2B5EF4-FFF2-40B4-BE49-F238E27FC236}">
-                <a16:creationId xmlns:a16="http://schemas.microsoft.com/office/drawing/2014/main" id="{096C838D-162D-473F-90F9-622D51B93E74}"/>
+                <a16:creationId xmlns:a16="http://schemas.microsoft.com/office/drawing/2014/main" id="{F8889563-BCF9-4C69-B3BA-D279D9619D06}"/>
               </a:ext>
             </a:extLst>
           </p:cNvPr>
@@ -16640,7 +16640,7 @@
           <p:cNvPr id="20" name="">
             <a:extLst xmlns:a="http://schemas.openxmlformats.org/drawingml/2006/main">
               <a:ext uri="{FF2B5EF4-FFF2-40B4-BE49-F238E27FC236}">
-                <a16:creationId xmlns:a16="http://schemas.microsoft.com/office/drawing/2014/main" id="{7A81237D-BA04-47AD-8F3E-6E7D78CFB6EA}"/>
+                <a16:creationId xmlns:a16="http://schemas.microsoft.com/office/drawing/2014/main" id="{4CC939B7-9533-4FB4-BA2E-DB3E8BD29EA7}"/>
               </a:ext>
             </a:extLst>
           </p:cNvPr>
@@ -16675,7 +16675,7 @@
           <p:cNvPr id="21" name="">
             <a:extLst xmlns:a="http://schemas.openxmlformats.org/drawingml/2006/main">
               <a:ext uri="{FF2B5EF4-FFF2-40B4-BE49-F238E27FC236}">
-                <a16:creationId xmlns:a16="http://schemas.microsoft.com/office/drawing/2014/main" id="{33671024-2183-403B-B4E9-38D542C8D711}"/>
+                <a16:creationId xmlns:a16="http://schemas.microsoft.com/office/drawing/2014/main" id="{006268F7-7B9A-47C3-9919-10B944E7403D}"/>
               </a:ext>
             </a:extLst>
           </p:cNvPr>
@@ -16739,7 +16739,7 @@
           <p:cNvPr id="22" name="">
             <a:extLst xmlns:a="http://schemas.openxmlformats.org/drawingml/2006/main">
               <a:ext uri="{FF2B5EF4-FFF2-40B4-BE49-F238E27FC236}">
-                <a16:creationId xmlns:a16="http://schemas.microsoft.com/office/drawing/2014/main" id="{7A5FA785-0543-4372-AA60-A8BAC7B8CA9B}"/>
+                <a16:creationId xmlns:a16="http://schemas.microsoft.com/office/drawing/2014/main" id="{96ABB325-DEDC-433F-9029-DFE6BA3E1B21}"/>
               </a:ext>
             </a:extLst>
           </p:cNvPr>
@@ -16774,7 +16774,7 @@
           <p:cNvPr id="23" name="">
             <a:extLst xmlns:a="http://schemas.openxmlformats.org/drawingml/2006/main">
               <a:ext uri="{FF2B5EF4-FFF2-40B4-BE49-F238E27FC236}">
-                <a16:creationId xmlns:a16="http://schemas.microsoft.com/office/drawing/2014/main" id="{50A8C451-4E40-4425-8066-97DAFF102113}"/>
+                <a16:creationId xmlns:a16="http://schemas.microsoft.com/office/drawing/2014/main" id="{CFE35313-B31F-434D-A451-8FD66E36D7E4}"/>
               </a:ext>
             </a:extLst>
           </p:cNvPr>
@@ -16838,7 +16838,7 @@
           <p:cNvPr id="24" name="">
             <a:extLst xmlns:a="http://schemas.openxmlformats.org/drawingml/2006/main">
               <a:ext uri="{FF2B5EF4-FFF2-40B4-BE49-F238E27FC236}">
-                <a16:creationId xmlns:a16="http://schemas.microsoft.com/office/drawing/2014/main" id="{43177637-8C19-4D22-A8FD-D024B25BE857}"/>
+                <a16:creationId xmlns:a16="http://schemas.microsoft.com/office/drawing/2014/main" id="{A1F9BC3A-6749-411F-865D-7CDC3842B51F}"/>
               </a:ext>
             </a:extLst>
           </p:cNvPr>
@@ -16873,7 +16873,7 @@
           <p:cNvPr id="25" name="">
             <a:extLst xmlns:a="http://schemas.openxmlformats.org/drawingml/2006/main">
               <a:ext uri="{FF2B5EF4-FFF2-40B4-BE49-F238E27FC236}">
-                <a16:creationId xmlns:a16="http://schemas.microsoft.com/office/drawing/2014/main" id="{45DF0FB8-292A-4189-B646-02B5CD47CC1D}"/>
+                <a16:creationId xmlns:a16="http://schemas.microsoft.com/office/drawing/2014/main" id="{029AD990-254F-4D57-A457-A0F22DCA1221}"/>
               </a:ext>
             </a:extLst>
           </p:cNvPr>
@@ -16937,7 +16937,7 @@
           <p:cNvPr id="26" name="">
             <a:extLst xmlns:a="http://schemas.openxmlformats.org/drawingml/2006/main">
               <a:ext uri="{FF2B5EF4-FFF2-40B4-BE49-F238E27FC236}">
-                <a16:creationId xmlns:a16="http://schemas.microsoft.com/office/drawing/2014/main" id="{0D40B4BB-D399-4AF1-BC4E-CE91584CA9CF}"/>
+                <a16:creationId xmlns:a16="http://schemas.microsoft.com/office/drawing/2014/main" id="{93618091-476C-49B0-9301-EA920A70AB71}"/>
               </a:ext>
             </a:extLst>
           </p:cNvPr>
@@ -16972,7 +16972,7 @@
           <p:cNvPr id="27" name="">
             <a:extLst xmlns:a="http://schemas.openxmlformats.org/drawingml/2006/main">
               <a:ext uri="{FF2B5EF4-FFF2-40B4-BE49-F238E27FC236}">
-                <a16:creationId xmlns:a16="http://schemas.microsoft.com/office/drawing/2014/main" id="{C7B28F83-646A-4A42-9B36-BBFD1D29E94B}"/>
+                <a16:creationId xmlns:a16="http://schemas.microsoft.com/office/drawing/2014/main" id="{1993D986-5CD0-42C6-8B2E-3027C9A5449C}"/>
               </a:ext>
             </a:extLst>
           </p:cNvPr>
@@ -17036,7 +17036,7 @@
           <p:cNvPr id="28" name="">
             <a:extLst xmlns:a="http://schemas.openxmlformats.org/drawingml/2006/main">
               <a:ext uri="{FF2B5EF4-FFF2-40B4-BE49-F238E27FC236}">
-                <a16:creationId xmlns:a16="http://schemas.microsoft.com/office/drawing/2014/main" id="{0409A517-4281-4A6C-8E12-DAA26886390C}"/>
+                <a16:creationId xmlns:a16="http://schemas.microsoft.com/office/drawing/2014/main" id="{1D428A1B-573E-4511-ACB0-E7B0B6633DE5}"/>
               </a:ext>
             </a:extLst>
           </p:cNvPr>
@@ -17069,7 +17069,7 @@
           <p:cNvPr id="29" name="">
             <a:extLst xmlns:a="http://schemas.openxmlformats.org/drawingml/2006/main">
               <a:ext uri="{FF2B5EF4-FFF2-40B4-BE49-F238E27FC236}">
-                <a16:creationId xmlns:a16="http://schemas.microsoft.com/office/drawing/2014/main" id="{E2383C49-4700-4D74-A29E-BF47BB294DE7}"/>
+                <a16:creationId xmlns:a16="http://schemas.microsoft.com/office/drawing/2014/main" id="{730C677D-6B1E-4439-A46D-18DF66A31C28}"/>
               </a:ext>
             </a:extLst>
           </p:cNvPr>
@@ -17102,7 +17102,7 @@
           <p:cNvPr id="30" name="">
             <a:extLst xmlns:a="http://schemas.openxmlformats.org/drawingml/2006/main">
               <a:ext uri="{FF2B5EF4-FFF2-40B4-BE49-F238E27FC236}">
-                <a16:creationId xmlns:a16="http://schemas.microsoft.com/office/drawing/2014/main" id="{A4BE8275-7A89-4DCA-808B-A21825B1C5EE}"/>
+                <a16:creationId xmlns:a16="http://schemas.microsoft.com/office/drawing/2014/main" id="{66694067-FBBF-44F0-B338-2160774EA838}"/>
               </a:ext>
             </a:extLst>
           </p:cNvPr>
@@ -17166,7 +17166,7 @@
           <p:cNvPr id="31" name="">
             <a:extLst xmlns:a="http://schemas.openxmlformats.org/drawingml/2006/main">
               <a:ext uri="{FF2B5EF4-FFF2-40B4-BE49-F238E27FC236}">
-                <a16:creationId xmlns:a16="http://schemas.microsoft.com/office/drawing/2014/main" id="{3F91E2CB-0218-454E-BA37-99A71ECB3582}"/>
+                <a16:creationId xmlns:a16="http://schemas.microsoft.com/office/drawing/2014/main" id="{A6A79746-5218-4B00-BE90-F89A3C7169B6}"/>
               </a:ext>
             </a:extLst>
           </p:cNvPr>
@@ -17201,7 +17201,7 @@
           <p:cNvPr id="32" name="">
             <a:extLst xmlns:a="http://schemas.openxmlformats.org/drawingml/2006/main">
               <a:ext uri="{FF2B5EF4-FFF2-40B4-BE49-F238E27FC236}">
-                <a16:creationId xmlns:a16="http://schemas.microsoft.com/office/drawing/2014/main" id="{0D8E62C3-D078-4E1F-A3A3-25AA73B4177B}"/>
+                <a16:creationId xmlns:a16="http://schemas.microsoft.com/office/drawing/2014/main" id="{4AF929EE-03FC-41A9-B0A7-51F517ACE006}"/>
               </a:ext>
             </a:extLst>
           </p:cNvPr>
@@ -17265,7 +17265,7 @@
           <p:cNvPr id="33" name="">
             <a:extLst xmlns:a="http://schemas.openxmlformats.org/drawingml/2006/main">
               <a:ext uri="{FF2B5EF4-FFF2-40B4-BE49-F238E27FC236}">
-                <a16:creationId xmlns:a16="http://schemas.microsoft.com/office/drawing/2014/main" id="{12CE71BE-3ED6-40F8-867D-F06C67AE33C5}"/>
+                <a16:creationId xmlns:a16="http://schemas.microsoft.com/office/drawing/2014/main" id="{00345C26-A817-45FA-B99E-2643A07F674C}"/>
               </a:ext>
             </a:extLst>
           </p:cNvPr>
@@ -17300,7 +17300,7 @@
           <p:cNvPr id="34" name="">
             <a:extLst xmlns:a="http://schemas.openxmlformats.org/drawingml/2006/main">
               <a:ext uri="{FF2B5EF4-FFF2-40B4-BE49-F238E27FC236}">
-                <a16:creationId xmlns:a16="http://schemas.microsoft.com/office/drawing/2014/main" id="{071E116F-AB75-4B01-B04D-788D91BD8459}"/>
+                <a16:creationId xmlns:a16="http://schemas.microsoft.com/office/drawing/2014/main" id="{A16AF119-40C7-400C-A289-214C7B4CE48B}"/>
               </a:ext>
             </a:extLst>
           </p:cNvPr>
@@ -17364,7 +17364,7 @@
           <p:cNvPr id="35" name="">
             <a:extLst xmlns:a="http://schemas.openxmlformats.org/drawingml/2006/main">
               <a:ext uri="{FF2B5EF4-FFF2-40B4-BE49-F238E27FC236}">
-                <a16:creationId xmlns:a16="http://schemas.microsoft.com/office/drawing/2014/main" id="{E1095EDC-827F-4987-9E54-98287444927E}"/>
+                <a16:creationId xmlns:a16="http://schemas.microsoft.com/office/drawing/2014/main" id="{3F67172B-EA0A-4816-A92E-821507C6C26A}"/>
               </a:ext>
             </a:extLst>
           </p:cNvPr>
@@ -17399,7 +17399,7 @@
           <p:cNvPr id="36" name="">
             <a:extLst xmlns:a="http://schemas.openxmlformats.org/drawingml/2006/main">
               <a:ext uri="{FF2B5EF4-FFF2-40B4-BE49-F238E27FC236}">
-                <a16:creationId xmlns:a16="http://schemas.microsoft.com/office/drawing/2014/main" id="{583C5F07-491A-4AA9-9CA6-2CA85547475A}"/>
+                <a16:creationId xmlns:a16="http://schemas.microsoft.com/office/drawing/2014/main" id="{BC19D24C-BDCB-4FF5-A78D-BE44A91A4657}"/>
               </a:ext>
             </a:extLst>
           </p:cNvPr>
@@ -17463,7 +17463,7 @@
           <p:cNvPr id="37" name="">
             <a:extLst xmlns:a="http://schemas.openxmlformats.org/drawingml/2006/main">
               <a:ext uri="{FF2B5EF4-FFF2-40B4-BE49-F238E27FC236}">
-                <a16:creationId xmlns:a16="http://schemas.microsoft.com/office/drawing/2014/main" id="{0F2A6040-126F-4121-B2F0-FAEFC12D1B9B}"/>
+                <a16:creationId xmlns:a16="http://schemas.microsoft.com/office/drawing/2014/main" id="{1D06E88E-A471-483A-86AE-D2F4DD1FBBFC}"/>
               </a:ext>
             </a:extLst>
           </p:cNvPr>
@@ -17498,7 +17498,7 @@
           <p:cNvPr id="38" name="">
             <a:extLst xmlns:a="http://schemas.openxmlformats.org/drawingml/2006/main">
               <a:ext uri="{FF2B5EF4-FFF2-40B4-BE49-F238E27FC236}">
-                <a16:creationId xmlns:a16="http://schemas.microsoft.com/office/drawing/2014/main" id="{69F3C196-DD63-4A95-9358-9DD367058B42}"/>
+                <a16:creationId xmlns:a16="http://schemas.microsoft.com/office/drawing/2014/main" id="{91447F0D-D61F-4607-BBE1-C78175A9D5B6}"/>
               </a:ext>
             </a:extLst>
           </p:cNvPr>
@@ -17552,7 +17552,7 @@
                 <a:ea typeface="Aptos"/>
                 <a:cs typeface="Aptos"/>
               </a:rPr>
-              <a:t>- Discount cost</a:t>
+              <a:t>+ Discount-cost penalty</a:t>
             </a:r>
           </a:p>
         </p:txBody>
@@ -17562,7 +17562,7 @@
           <p:cNvPr id="39" name="">
             <a:extLst xmlns:a="http://schemas.openxmlformats.org/drawingml/2006/main">
               <a:ext uri="{FF2B5EF4-FFF2-40B4-BE49-F238E27FC236}">
-                <a16:creationId xmlns:a16="http://schemas.microsoft.com/office/drawing/2014/main" id="{97BE7886-4484-486D-AED6-6610F9D0A8B9}"/>
+                <a16:creationId xmlns:a16="http://schemas.microsoft.com/office/drawing/2014/main" id="{E8F1BDD5-A353-4EDE-8534-07F9073F0215}"/>
               </a:ext>
             </a:extLst>
           </p:cNvPr>
@@ -17597,7 +17597,7 @@
           <p:cNvPr id="40" name="">
             <a:extLst xmlns:a="http://schemas.openxmlformats.org/drawingml/2006/main">
               <a:ext uri="{FF2B5EF4-FFF2-40B4-BE49-F238E27FC236}">
-                <a16:creationId xmlns:a16="http://schemas.microsoft.com/office/drawing/2014/main" id="{420FA5D4-4A62-424D-BC17-F2E1EBA11F82}"/>
+                <a16:creationId xmlns:a16="http://schemas.microsoft.com/office/drawing/2014/main" id="{B8D4CA4F-3930-454F-A87E-0A35885D3F6A}"/>
               </a:ext>
             </a:extLst>
           </p:cNvPr>
@@ -17661,7 +17661,7 @@
           <p:cNvPr id="41" name="">
             <a:extLst xmlns:a="http://schemas.openxmlformats.org/drawingml/2006/main">
               <a:ext uri="{FF2B5EF4-FFF2-40B4-BE49-F238E27FC236}">
-                <a16:creationId xmlns:a16="http://schemas.microsoft.com/office/drawing/2014/main" id="{1A5E76B1-3238-4A9E-A86D-393F5B5C0D7D}"/>
+                <a16:creationId xmlns:a16="http://schemas.microsoft.com/office/drawing/2014/main" id="{40FD2C8F-ED66-418B-B186-18A1D911CF1E}"/>
               </a:ext>
             </a:extLst>
           </p:cNvPr>
@@ -17694,7 +17694,7 @@
           <p:cNvPr id="42" name="">
             <a:extLst xmlns:a="http://schemas.openxmlformats.org/drawingml/2006/main">
               <a:ext uri="{FF2B5EF4-FFF2-40B4-BE49-F238E27FC236}">
-                <a16:creationId xmlns:a16="http://schemas.microsoft.com/office/drawing/2014/main" id="{F3A630C9-158B-493E-B0B1-E49400142928}"/>
+                <a16:creationId xmlns:a16="http://schemas.microsoft.com/office/drawing/2014/main" id="{4608F0EC-C197-4C61-BD4D-2FFE0FED1AEE}"/>
               </a:ext>
             </a:extLst>
           </p:cNvPr>
@@ -17758,7 +17758,7 @@
           <p:cNvPr id="43" name="">
             <a:extLst xmlns:a="http://schemas.openxmlformats.org/drawingml/2006/main">
               <a:ext uri="{FF2B5EF4-FFF2-40B4-BE49-F238E27FC236}">
-                <a16:creationId xmlns:a16="http://schemas.microsoft.com/office/drawing/2014/main" id="{1E3A1E8A-8365-428D-9BCD-12B8C19FC93D}"/>
+                <a16:creationId xmlns:a16="http://schemas.microsoft.com/office/drawing/2014/main" id="{366D45D2-0E3E-4A6D-B8C2-86E506D3FD41}"/>
               </a:ext>
             </a:extLst>
           </p:cNvPr>
@@ -17793,7 +17793,7 @@
           <p:cNvPr id="44" name="">
             <a:extLst xmlns:a="http://schemas.openxmlformats.org/drawingml/2006/main">
               <a:ext uri="{FF2B5EF4-FFF2-40B4-BE49-F238E27FC236}">
-                <a16:creationId xmlns:a16="http://schemas.microsoft.com/office/drawing/2014/main" id="{043207B1-70AD-419D-B9C5-2C5990C65FDD}"/>
+                <a16:creationId xmlns:a16="http://schemas.microsoft.com/office/drawing/2014/main" id="{D397CC55-A6D4-471A-A2F2-71E3F3872E2D}"/>
               </a:ext>
             </a:extLst>
           </p:cNvPr>
@@ -17857,7 +17857,7 @@
           <p:cNvPr id="45" name="">
             <a:extLst xmlns:a="http://schemas.openxmlformats.org/drawingml/2006/main">
               <a:ext uri="{FF2B5EF4-FFF2-40B4-BE49-F238E27FC236}">
-                <a16:creationId xmlns:a16="http://schemas.microsoft.com/office/drawing/2014/main" id="{601D08FF-4876-49FA-8AB8-9F52DD0C0CB3}"/>
+                <a16:creationId xmlns:a16="http://schemas.microsoft.com/office/drawing/2014/main" id="{347E78FF-D76D-4E08-95F5-C0260F21A1BC}"/>
               </a:ext>
             </a:extLst>
           </p:cNvPr>
@@ -17919,7 +17919,7 @@
     </p:spTree>
     <p:extLst>
       <p:ext uri="{BB962C8B-B14F-4D97-AF65-F5344CB8AC3E}">
-        <p14:creationId xmlns:p14="http://schemas.microsoft.com/office/powerpoint/2010/main" val="213831475"/>
+        <p14:creationId xmlns:p14="http://schemas.microsoft.com/office/powerpoint/2010/main" val="786137327"/>
       </p:ext>
     </p:extLst>
   </p:cSld>
@@ -17943,7 +17943,7 @@
           <p:cNvPr id="1" name="">
             <a:extLst xmlns:a="http://schemas.openxmlformats.org/drawingml/2006/main">
               <a:ext uri="{FF2B5EF4-FFF2-40B4-BE49-F238E27FC236}">
-                <a16:creationId xmlns:a16="http://schemas.microsoft.com/office/drawing/2014/main" id="{6AF9A71E-19B9-4076-9948-1E4A9419D82C}"/>
+                <a16:creationId xmlns:a16="http://schemas.microsoft.com/office/drawing/2014/main" id="{C4A5DFD3-7BF3-42C5-8205-9B97C0FD837C}"/>
               </a:ext>
             </a:extLst>
           </p:cNvPr>
@@ -17978,7 +17978,7 @@
           <p:cNvPr id="2" name="">
             <a:extLst xmlns:a="http://schemas.openxmlformats.org/drawingml/2006/main">
               <a:ext uri="{FF2B5EF4-FFF2-40B4-BE49-F238E27FC236}">
-                <a16:creationId xmlns:a16="http://schemas.microsoft.com/office/drawing/2014/main" id="{A388A05A-8B9E-4AE9-827A-7694F3811186}"/>
+                <a16:creationId xmlns:a16="http://schemas.microsoft.com/office/drawing/2014/main" id="{37F621C6-9C2E-45EA-AEE9-3F7973B82B35}"/>
               </a:ext>
             </a:extLst>
           </p:cNvPr>
@@ -18013,7 +18013,7 @@
           <p:cNvPr id="3" name="">
             <a:extLst xmlns:a="http://schemas.openxmlformats.org/drawingml/2006/main">
               <a:ext uri="{FF2B5EF4-FFF2-40B4-BE49-F238E27FC236}">
-                <a16:creationId xmlns:a16="http://schemas.microsoft.com/office/drawing/2014/main" id="{33ADCD16-611C-4836-AFEA-F8D22FA5B340}"/>
+                <a16:creationId xmlns:a16="http://schemas.microsoft.com/office/drawing/2014/main" id="{4487D643-AD0E-4639-A965-3979A1E93904}"/>
               </a:ext>
             </a:extLst>
           </p:cNvPr>
@@ -18077,7 +18077,7 @@
           <p:cNvPr id="4" name="">
             <a:extLst xmlns:a="http://schemas.openxmlformats.org/drawingml/2006/main">
               <a:ext uri="{FF2B5EF4-FFF2-40B4-BE49-F238E27FC236}">
-                <a16:creationId xmlns:a16="http://schemas.microsoft.com/office/drawing/2014/main" id="{E3047826-85D0-49EC-9306-51A7BD028DB0}"/>
+                <a16:creationId xmlns:a16="http://schemas.microsoft.com/office/drawing/2014/main" id="{A193B99C-7A1E-483E-AB53-35F3D0B52779}"/>
               </a:ext>
             </a:extLst>
           </p:cNvPr>
@@ -18141,7 +18141,7 @@
           <p:cNvPr id="5" name="">
             <a:extLst xmlns:a="http://schemas.openxmlformats.org/drawingml/2006/main">
               <a:ext uri="{FF2B5EF4-FFF2-40B4-BE49-F238E27FC236}">
-                <a16:creationId xmlns:a16="http://schemas.microsoft.com/office/drawing/2014/main" id="{940FC267-A66D-4D9A-B1CB-1003135039DA}"/>
+                <a16:creationId xmlns:a16="http://schemas.microsoft.com/office/drawing/2014/main" id="{C92102B4-988B-4D25-8333-5038480C59BD}"/>
               </a:ext>
             </a:extLst>
           </p:cNvPr>
@@ -18205,7 +18205,7 @@
           <p:cNvPr id="6" name="">
             <a:extLst xmlns:a="http://schemas.openxmlformats.org/drawingml/2006/main">
               <a:ext uri="{FF2B5EF4-FFF2-40B4-BE49-F238E27FC236}">
-                <a16:creationId xmlns:a16="http://schemas.microsoft.com/office/drawing/2014/main" id="{AD63D37E-D778-4795-A9D3-666331B72257}"/>
+                <a16:creationId xmlns:a16="http://schemas.microsoft.com/office/drawing/2014/main" id="{86A03BC4-2A0A-45F3-91B9-6723543045DA}"/>
               </a:ext>
             </a:extLst>
           </p:cNvPr>
@@ -18238,7 +18238,7 @@
           <p:cNvPr id="7" name="">
             <a:extLst xmlns:a="http://schemas.openxmlformats.org/drawingml/2006/main">
               <a:ext uri="{FF2B5EF4-FFF2-40B4-BE49-F238E27FC236}">
-                <a16:creationId xmlns:a16="http://schemas.microsoft.com/office/drawing/2014/main" id="{EE588ED6-8AAD-4101-8020-65CE04D32A78}"/>
+                <a16:creationId xmlns:a16="http://schemas.microsoft.com/office/drawing/2014/main" id="{209E7084-4202-4397-88F1-51234B47A687}"/>
               </a:ext>
             </a:extLst>
           </p:cNvPr>
@@ -18302,7 +18302,7 @@
           <p:cNvPr id="8" name="">
             <a:extLst xmlns:a="http://schemas.openxmlformats.org/drawingml/2006/main">
               <a:ext uri="{FF2B5EF4-FFF2-40B4-BE49-F238E27FC236}">
-                <a16:creationId xmlns:a16="http://schemas.microsoft.com/office/drawing/2014/main" id="{A5AE2996-FA70-4778-80D4-108BC6F5D3C0}"/>
+                <a16:creationId xmlns:a16="http://schemas.microsoft.com/office/drawing/2014/main" id="{3FB2A0BD-D777-42BF-9414-E9E29FF249D6}"/>
               </a:ext>
             </a:extLst>
           </p:cNvPr>
@@ -18335,7 +18335,7 @@
           <p:cNvPr id="9" name="">
             <a:extLst xmlns:a="http://schemas.openxmlformats.org/drawingml/2006/main">
               <a:ext uri="{FF2B5EF4-FFF2-40B4-BE49-F238E27FC236}">
-                <a16:creationId xmlns:a16="http://schemas.microsoft.com/office/drawing/2014/main" id="{DF6EA7CB-55F5-496C-BA50-0AA5552240C5}"/>
+                <a16:creationId xmlns:a16="http://schemas.microsoft.com/office/drawing/2014/main" id="{9C2D590E-D5F8-47CD-9B8A-0777C22EB5B0}"/>
               </a:ext>
             </a:extLst>
           </p:cNvPr>
@@ -18399,7 +18399,7 @@
           <p:cNvPr id="10" name="">
             <a:extLst xmlns:a="http://schemas.openxmlformats.org/drawingml/2006/main">
               <a:ext uri="{FF2B5EF4-FFF2-40B4-BE49-F238E27FC236}">
-                <a16:creationId xmlns:a16="http://schemas.microsoft.com/office/drawing/2014/main" id="{2E7195B5-97D4-4951-A91B-3923FA88461E}"/>
+                <a16:creationId xmlns:a16="http://schemas.microsoft.com/office/drawing/2014/main" id="{682F8BFA-C8E2-4512-A3E3-7CB756087C08}"/>
               </a:ext>
             </a:extLst>
           </p:cNvPr>
@@ -18463,7 +18463,7 @@
           <p:cNvPr id="11" name="">
             <a:extLst xmlns:a="http://schemas.openxmlformats.org/drawingml/2006/main">
               <a:ext uri="{FF2B5EF4-FFF2-40B4-BE49-F238E27FC236}">
-                <a16:creationId xmlns:a16="http://schemas.microsoft.com/office/drawing/2014/main" id="{C6FAC9AA-EB03-46E2-BF4F-78F75AA802C8}"/>
+                <a16:creationId xmlns:a16="http://schemas.microsoft.com/office/drawing/2014/main" id="{97EDE260-FD63-455D-899A-721AE717EBF6}"/>
               </a:ext>
             </a:extLst>
           </p:cNvPr>
@@ -18496,7 +18496,7 @@
           <p:cNvPr id="12" name="">
             <a:extLst xmlns:a="http://schemas.openxmlformats.org/drawingml/2006/main">
               <a:ext uri="{FF2B5EF4-FFF2-40B4-BE49-F238E27FC236}">
-                <a16:creationId xmlns:a16="http://schemas.microsoft.com/office/drawing/2014/main" id="{33395BD0-43DB-4A60-A9DF-C66D9D78D82D}"/>
+                <a16:creationId xmlns:a16="http://schemas.microsoft.com/office/drawing/2014/main" id="{72CBFB53-33CC-4C8E-91AE-1EE062DF3A3A}"/>
               </a:ext>
             </a:extLst>
           </p:cNvPr>
@@ -18560,7 +18560,7 @@
           <p:cNvPr id="13" name="">
             <a:extLst xmlns:a="http://schemas.openxmlformats.org/drawingml/2006/main">
               <a:ext uri="{FF2B5EF4-FFF2-40B4-BE49-F238E27FC236}">
-                <a16:creationId xmlns:a16="http://schemas.microsoft.com/office/drawing/2014/main" id="{19601633-E789-42EE-A198-EF4A026F5922}"/>
+                <a16:creationId xmlns:a16="http://schemas.microsoft.com/office/drawing/2014/main" id="{1DDA1F40-8A9D-4F44-B715-88142F44062F}"/>
               </a:ext>
             </a:extLst>
           </p:cNvPr>
@@ -18624,7 +18624,7 @@
           <p:cNvPr id="14" name="">
             <a:extLst xmlns:a="http://schemas.openxmlformats.org/drawingml/2006/main">
               <a:ext uri="{FF2B5EF4-FFF2-40B4-BE49-F238E27FC236}">
-                <a16:creationId xmlns:a16="http://schemas.microsoft.com/office/drawing/2014/main" id="{DC90A9C9-E3AE-4526-895F-0B0913DF8068}"/>
+                <a16:creationId xmlns:a16="http://schemas.microsoft.com/office/drawing/2014/main" id="{94D0F96F-3A15-4E5B-929D-E8741861EB4A}"/>
               </a:ext>
             </a:extLst>
           </p:cNvPr>
@@ -18657,7 +18657,7 @@
           <p:cNvPr id="15" name="">
             <a:extLst xmlns:a="http://schemas.openxmlformats.org/drawingml/2006/main">
               <a:ext uri="{FF2B5EF4-FFF2-40B4-BE49-F238E27FC236}">
-                <a16:creationId xmlns:a16="http://schemas.microsoft.com/office/drawing/2014/main" id="{82A1435C-6A1D-46F9-8E6D-D6C53D9C935B}"/>
+                <a16:creationId xmlns:a16="http://schemas.microsoft.com/office/drawing/2014/main" id="{2391009F-68C3-4CA5-A4D4-467C77AF6C01}"/>
               </a:ext>
             </a:extLst>
           </p:cNvPr>
@@ -18721,7 +18721,7 @@
           <p:cNvPr id="16" name="">
             <a:extLst xmlns:a="http://schemas.openxmlformats.org/drawingml/2006/main">
               <a:ext uri="{FF2B5EF4-FFF2-40B4-BE49-F238E27FC236}">
-                <a16:creationId xmlns:a16="http://schemas.microsoft.com/office/drawing/2014/main" id="{85B863D4-D1ED-454D-B857-9A5903E85C30}"/>
+                <a16:creationId xmlns:a16="http://schemas.microsoft.com/office/drawing/2014/main" id="{7AD98F4E-D3C7-4E3E-BA9F-4F279EE25136}"/>
               </a:ext>
             </a:extLst>
           </p:cNvPr>
@@ -18785,7 +18785,7 @@
           <p:cNvPr id="17" name="">
             <a:extLst xmlns:a="http://schemas.openxmlformats.org/drawingml/2006/main">
               <a:ext uri="{FF2B5EF4-FFF2-40B4-BE49-F238E27FC236}">
-                <a16:creationId xmlns:a16="http://schemas.microsoft.com/office/drawing/2014/main" id="{004A7CC5-11B2-4242-8D66-5BBF902E8E17}"/>
+                <a16:creationId xmlns:a16="http://schemas.microsoft.com/office/drawing/2014/main" id="{95D6A993-23E8-4091-BF3A-76DD00827BED}"/>
               </a:ext>
             </a:extLst>
           </p:cNvPr>
@@ -18818,7 +18818,7 @@
           <p:cNvPr id="18" name="">
             <a:extLst xmlns:a="http://schemas.openxmlformats.org/drawingml/2006/main">
               <a:ext uri="{FF2B5EF4-FFF2-40B4-BE49-F238E27FC236}">
-                <a16:creationId xmlns:a16="http://schemas.microsoft.com/office/drawing/2014/main" id="{1C06D9A9-7351-46E8-BF7E-B1F9E97C8DD5}"/>
+                <a16:creationId xmlns:a16="http://schemas.microsoft.com/office/drawing/2014/main" id="{E3C4AE82-0352-4006-852E-969B59CABC90}"/>
               </a:ext>
             </a:extLst>
           </p:cNvPr>
@@ -18851,7 +18851,7 @@
           <p:cNvPr id="19" name="">
             <a:extLst xmlns:a="http://schemas.openxmlformats.org/drawingml/2006/main">
               <a:ext uri="{FF2B5EF4-FFF2-40B4-BE49-F238E27FC236}">
-                <a16:creationId xmlns:a16="http://schemas.microsoft.com/office/drawing/2014/main" id="{62A4DA21-93BE-45FD-A9CB-254F4240E604}"/>
+                <a16:creationId xmlns:a16="http://schemas.microsoft.com/office/drawing/2014/main" id="{335410C9-ADDE-4FAF-9C39-8F6AEC370E08}"/>
               </a:ext>
             </a:extLst>
           </p:cNvPr>
@@ -18915,7 +18915,7 @@
           <p:cNvPr id="20" name="">
             <a:extLst xmlns:a="http://schemas.openxmlformats.org/drawingml/2006/main">
               <a:ext uri="{FF2B5EF4-FFF2-40B4-BE49-F238E27FC236}">
-                <a16:creationId xmlns:a16="http://schemas.microsoft.com/office/drawing/2014/main" id="{D0AD500D-65B5-4008-98AF-75C48E2A1B18}"/>
+                <a16:creationId xmlns:a16="http://schemas.microsoft.com/office/drawing/2014/main" id="{40BD7100-D2B9-4D8D-8091-6C0C8419580A}"/>
               </a:ext>
             </a:extLst>
           </p:cNvPr>
@@ -18979,7 +18979,7 @@
           <p:cNvPr id="21" name="">
             <a:extLst xmlns:a="http://schemas.openxmlformats.org/drawingml/2006/main">
               <a:ext uri="{FF2B5EF4-FFF2-40B4-BE49-F238E27FC236}">
-                <a16:creationId xmlns:a16="http://schemas.microsoft.com/office/drawing/2014/main" id="{79E4066A-D12D-4080-9ABC-2EF2786E49E9}"/>
+                <a16:creationId xmlns:a16="http://schemas.microsoft.com/office/drawing/2014/main" id="{89A97307-ED04-410A-BACC-DC2B65978C0B}"/>
               </a:ext>
             </a:extLst>
           </p:cNvPr>
@@ -19043,7 +19043,7 @@
           <p:cNvPr id="22" name="">
             <a:extLst xmlns:a="http://schemas.openxmlformats.org/drawingml/2006/main">
               <a:ext uri="{FF2B5EF4-FFF2-40B4-BE49-F238E27FC236}">
-                <a16:creationId xmlns:a16="http://schemas.microsoft.com/office/drawing/2014/main" id="{02D95D47-0131-4F02-982B-CC4A3A5CC72C}"/>
+                <a16:creationId xmlns:a16="http://schemas.microsoft.com/office/drawing/2014/main" id="{C932386B-E9EC-4591-9619-009E490FDBE7}"/>
               </a:ext>
             </a:extLst>
           </p:cNvPr>
@@ -19107,7 +19107,7 @@
           <p:cNvPr id="23" name="">
             <a:extLst xmlns:a="http://schemas.openxmlformats.org/drawingml/2006/main">
               <a:ext uri="{FF2B5EF4-FFF2-40B4-BE49-F238E27FC236}">
-                <a16:creationId xmlns:a16="http://schemas.microsoft.com/office/drawing/2014/main" id="{4AAE5742-367A-41E0-ADAC-48DE4EDC2309}"/>
+                <a16:creationId xmlns:a16="http://schemas.microsoft.com/office/drawing/2014/main" id="{2FA4B68D-F7C3-4F61-B63A-7D4E3DA3F3AD}"/>
               </a:ext>
             </a:extLst>
           </p:cNvPr>
@@ -19171,7 +19171,7 @@
           <p:cNvPr id="24" name="">
             <a:extLst xmlns:a="http://schemas.openxmlformats.org/drawingml/2006/main">
               <a:ext uri="{FF2B5EF4-FFF2-40B4-BE49-F238E27FC236}">
-                <a16:creationId xmlns:a16="http://schemas.microsoft.com/office/drawing/2014/main" id="{92EFA77B-7F69-4DC9-AF62-70F1C0D93286}"/>
+                <a16:creationId xmlns:a16="http://schemas.microsoft.com/office/drawing/2014/main" id="{AE47D0BF-A4B2-4FD8-A391-7C6F4575AA5E}"/>
               </a:ext>
             </a:extLst>
           </p:cNvPr>
@@ -19235,7 +19235,7 @@
           <p:cNvPr id="25" name="">
             <a:extLst xmlns:a="http://schemas.openxmlformats.org/drawingml/2006/main">
               <a:ext uri="{FF2B5EF4-FFF2-40B4-BE49-F238E27FC236}">
-                <a16:creationId xmlns:a16="http://schemas.microsoft.com/office/drawing/2014/main" id="{9E70345E-A9CF-4A9A-A629-EDC6FDCAA789}"/>
+                <a16:creationId xmlns:a16="http://schemas.microsoft.com/office/drawing/2014/main" id="{292AA9C1-89AB-4BAD-ABFE-46C9569C3BE2}"/>
               </a:ext>
             </a:extLst>
           </p:cNvPr>
@@ -19270,7 +19270,7 @@
           <p:cNvPr id="26" name="">
             <a:extLst xmlns:a="http://schemas.openxmlformats.org/drawingml/2006/main">
               <a:ext uri="{FF2B5EF4-FFF2-40B4-BE49-F238E27FC236}">
-                <a16:creationId xmlns:a16="http://schemas.microsoft.com/office/drawing/2014/main" id="{102AC09A-B2C7-43CD-A5E4-54DB36258681}"/>
+                <a16:creationId xmlns:a16="http://schemas.microsoft.com/office/drawing/2014/main" id="{49B3633C-DB85-4FA5-A317-CD8D67376F85}"/>
               </a:ext>
             </a:extLst>
           </p:cNvPr>
@@ -19334,7 +19334,7 @@
           <p:cNvPr id="27" name="">
             <a:extLst xmlns:a="http://schemas.openxmlformats.org/drawingml/2006/main">
               <a:ext uri="{FF2B5EF4-FFF2-40B4-BE49-F238E27FC236}">
-                <a16:creationId xmlns:a16="http://schemas.microsoft.com/office/drawing/2014/main" id="{8B5EE308-CFB2-4BE7-BBAF-2530994DF9A2}"/>
+                <a16:creationId xmlns:a16="http://schemas.microsoft.com/office/drawing/2014/main" id="{AADA031D-1DDC-4D0B-BCFC-86A667D24D56}"/>
               </a:ext>
             </a:extLst>
           </p:cNvPr>
@@ -19398,7 +19398,7 @@
           <p:cNvPr id="28" name="">
             <a:extLst xmlns:a="http://schemas.openxmlformats.org/drawingml/2006/main">
               <a:ext uri="{FF2B5EF4-FFF2-40B4-BE49-F238E27FC236}">
-                <a16:creationId xmlns:a16="http://schemas.microsoft.com/office/drawing/2014/main" id="{DB80E65D-E8F0-4280-A7AC-6F25FC277070}"/>
+                <a16:creationId xmlns:a16="http://schemas.microsoft.com/office/drawing/2014/main" id="{8BC30234-B87A-42B9-8BA4-B42094A9526C}"/>
               </a:ext>
             </a:extLst>
           </p:cNvPr>
@@ -19462,7 +19462,7 @@
           <p:cNvPr id="29" name="">
             <a:extLst xmlns:a="http://schemas.openxmlformats.org/drawingml/2006/main">
               <a:ext uri="{FF2B5EF4-FFF2-40B4-BE49-F238E27FC236}">
-                <a16:creationId xmlns:a16="http://schemas.microsoft.com/office/drawing/2014/main" id="{9FED41B2-EBC1-4FA3-BF86-BAC82B400F8E}"/>
+                <a16:creationId xmlns:a16="http://schemas.microsoft.com/office/drawing/2014/main" id="{28A12199-6939-4CDA-A6AD-58221320821D}"/>
               </a:ext>
             </a:extLst>
           </p:cNvPr>
@@ -19526,7 +19526,7 @@
           <p:cNvPr id="30" name="">
             <a:extLst xmlns:a="http://schemas.openxmlformats.org/drawingml/2006/main">
               <a:ext uri="{FF2B5EF4-FFF2-40B4-BE49-F238E27FC236}">
-                <a16:creationId xmlns:a16="http://schemas.microsoft.com/office/drawing/2014/main" id="{FC90E6E5-3BAF-4C27-B5AF-0C130D00C3B8}"/>
+                <a16:creationId xmlns:a16="http://schemas.microsoft.com/office/drawing/2014/main" id="{D0A65D18-2B39-4DB7-8DAC-15460F79F256}"/>
               </a:ext>
             </a:extLst>
           </p:cNvPr>
@@ -19590,7 +19590,7 @@
           <p:cNvPr id="31" name="">
             <a:extLst xmlns:a="http://schemas.openxmlformats.org/drawingml/2006/main">
               <a:ext uri="{FF2B5EF4-FFF2-40B4-BE49-F238E27FC236}">
-                <a16:creationId xmlns:a16="http://schemas.microsoft.com/office/drawing/2014/main" id="{659842ED-BA29-429D-9339-1EC9D4C59E1D}"/>
+                <a16:creationId xmlns:a16="http://schemas.microsoft.com/office/drawing/2014/main" id="{024B749C-A4FE-47EF-BC5B-1C572193BF5B}"/>
               </a:ext>
             </a:extLst>
           </p:cNvPr>
@@ -19625,7 +19625,7 @@
           <p:cNvPr id="32" name="">
             <a:extLst xmlns:a="http://schemas.openxmlformats.org/drawingml/2006/main">
               <a:ext uri="{FF2B5EF4-FFF2-40B4-BE49-F238E27FC236}">
-                <a16:creationId xmlns:a16="http://schemas.microsoft.com/office/drawing/2014/main" id="{61CD94B4-EA99-4D49-AAAB-36E771E32CBD}"/>
+                <a16:creationId xmlns:a16="http://schemas.microsoft.com/office/drawing/2014/main" id="{9C1CB250-21B9-4BD4-B9DA-33D6131DC909}"/>
               </a:ext>
             </a:extLst>
           </p:cNvPr>
@@ -19689,7 +19689,7 @@
           <p:cNvPr id="33" name="">
             <a:extLst xmlns:a="http://schemas.openxmlformats.org/drawingml/2006/main">
               <a:ext uri="{FF2B5EF4-FFF2-40B4-BE49-F238E27FC236}">
-                <a16:creationId xmlns:a16="http://schemas.microsoft.com/office/drawing/2014/main" id="{35473CC5-DDDC-487F-AF75-76A34CA0E1DE}"/>
+                <a16:creationId xmlns:a16="http://schemas.microsoft.com/office/drawing/2014/main" id="{81A8DEE4-B106-4828-9037-01519369E8FB}"/>
               </a:ext>
             </a:extLst>
           </p:cNvPr>
@@ -19753,7 +19753,7 @@
           <p:cNvPr id="34" name="">
             <a:extLst xmlns:a="http://schemas.openxmlformats.org/drawingml/2006/main">
               <a:ext uri="{FF2B5EF4-FFF2-40B4-BE49-F238E27FC236}">
-                <a16:creationId xmlns:a16="http://schemas.microsoft.com/office/drawing/2014/main" id="{FBA4B84D-58E4-4F5E-AA8E-A51A08C7EA5E}"/>
+                <a16:creationId xmlns:a16="http://schemas.microsoft.com/office/drawing/2014/main" id="{16D7CFEE-E5F1-47A6-AD6E-45A98CC3FEA9}"/>
               </a:ext>
             </a:extLst>
           </p:cNvPr>
@@ -19817,7 +19817,7 @@
           <p:cNvPr id="35" name="">
             <a:extLst xmlns:a="http://schemas.openxmlformats.org/drawingml/2006/main">
               <a:ext uri="{FF2B5EF4-FFF2-40B4-BE49-F238E27FC236}">
-                <a16:creationId xmlns:a16="http://schemas.microsoft.com/office/drawing/2014/main" id="{59B97945-05FC-4F6C-803F-3418AC1CE651}"/>
+                <a16:creationId xmlns:a16="http://schemas.microsoft.com/office/drawing/2014/main" id="{1F7743FD-0E5A-4EC2-9CD5-AFAE49094CF3}"/>
               </a:ext>
             </a:extLst>
           </p:cNvPr>
@@ -19881,7 +19881,7 @@
           <p:cNvPr id="36" name="">
             <a:extLst xmlns:a="http://schemas.openxmlformats.org/drawingml/2006/main">
               <a:ext uri="{FF2B5EF4-FFF2-40B4-BE49-F238E27FC236}">
-                <a16:creationId xmlns:a16="http://schemas.microsoft.com/office/drawing/2014/main" id="{04EF55EE-27AE-4C0C-B0DC-5A10F67DBAEB}"/>
+                <a16:creationId xmlns:a16="http://schemas.microsoft.com/office/drawing/2014/main" id="{E8C332F0-50E7-4AED-9367-B0523C2FACCF}"/>
               </a:ext>
             </a:extLst>
           </p:cNvPr>
@@ -19945,7 +19945,7 @@
           <p:cNvPr id="37" name="">
             <a:extLst xmlns:a="http://schemas.openxmlformats.org/drawingml/2006/main">
               <a:ext uri="{FF2B5EF4-FFF2-40B4-BE49-F238E27FC236}">
-                <a16:creationId xmlns:a16="http://schemas.microsoft.com/office/drawing/2014/main" id="{21B15C17-C2AB-4B2A-9778-B14AC4C429A9}"/>
+                <a16:creationId xmlns:a16="http://schemas.microsoft.com/office/drawing/2014/main" id="{3997A477-627A-4394-8099-8B4D26B37B92}"/>
               </a:ext>
             </a:extLst>
           </p:cNvPr>
@@ -19980,7 +19980,7 @@
           <p:cNvPr id="38" name="">
             <a:extLst xmlns:a="http://schemas.openxmlformats.org/drawingml/2006/main">
               <a:ext uri="{FF2B5EF4-FFF2-40B4-BE49-F238E27FC236}">
-                <a16:creationId xmlns:a16="http://schemas.microsoft.com/office/drawing/2014/main" id="{82B6D918-6929-4C80-A8BF-F64749E20270}"/>
+                <a16:creationId xmlns:a16="http://schemas.microsoft.com/office/drawing/2014/main" id="{F1CF5B88-57EE-4C12-AE50-DB42502D6E5A}"/>
               </a:ext>
             </a:extLst>
           </p:cNvPr>
@@ -20044,7 +20044,7 @@
           <p:cNvPr id="39" name="">
             <a:extLst xmlns:a="http://schemas.openxmlformats.org/drawingml/2006/main">
               <a:ext uri="{FF2B5EF4-FFF2-40B4-BE49-F238E27FC236}">
-                <a16:creationId xmlns:a16="http://schemas.microsoft.com/office/drawing/2014/main" id="{62FF4441-04B2-4B84-ADF7-5DA0B24BE10E}"/>
+                <a16:creationId xmlns:a16="http://schemas.microsoft.com/office/drawing/2014/main" id="{571499DC-AACC-40D3-91E5-912E2E642F30}"/>
               </a:ext>
             </a:extLst>
           </p:cNvPr>
@@ -20108,7 +20108,7 @@
           <p:cNvPr id="40" name="">
             <a:extLst xmlns:a="http://schemas.openxmlformats.org/drawingml/2006/main">
               <a:ext uri="{FF2B5EF4-FFF2-40B4-BE49-F238E27FC236}">
-                <a16:creationId xmlns:a16="http://schemas.microsoft.com/office/drawing/2014/main" id="{26E9323E-5592-44F4-B309-8D17F4BF56B7}"/>
+                <a16:creationId xmlns:a16="http://schemas.microsoft.com/office/drawing/2014/main" id="{B61E9C06-B56B-4BB5-963E-2F900CF59BA9}"/>
               </a:ext>
             </a:extLst>
           </p:cNvPr>
@@ -20172,7 +20172,7 @@
           <p:cNvPr id="41" name="">
             <a:extLst xmlns:a="http://schemas.openxmlformats.org/drawingml/2006/main">
               <a:ext uri="{FF2B5EF4-FFF2-40B4-BE49-F238E27FC236}">
-                <a16:creationId xmlns:a16="http://schemas.microsoft.com/office/drawing/2014/main" id="{DE3AA59F-DA8E-4F17-9592-8FF6759F4743}"/>
+                <a16:creationId xmlns:a16="http://schemas.microsoft.com/office/drawing/2014/main" id="{6DA5371F-38EB-466E-A23B-ABDE2660D5CB}"/>
               </a:ext>
             </a:extLst>
           </p:cNvPr>
@@ -20236,7 +20236,7 @@
           <p:cNvPr id="42" name="">
             <a:extLst xmlns:a="http://schemas.openxmlformats.org/drawingml/2006/main">
               <a:ext uri="{FF2B5EF4-FFF2-40B4-BE49-F238E27FC236}">
-                <a16:creationId xmlns:a16="http://schemas.microsoft.com/office/drawing/2014/main" id="{A55169E2-3C5C-4C1E-9C38-AD36A90400EA}"/>
+                <a16:creationId xmlns:a16="http://schemas.microsoft.com/office/drawing/2014/main" id="{2C2B70F1-06E7-487B-B191-0AE3140C672A}"/>
               </a:ext>
             </a:extLst>
           </p:cNvPr>
@@ -20300,7 +20300,7 @@
           <p:cNvPr id="43" name="">
             <a:extLst xmlns:a="http://schemas.openxmlformats.org/drawingml/2006/main">
               <a:ext uri="{FF2B5EF4-FFF2-40B4-BE49-F238E27FC236}">
-                <a16:creationId xmlns:a16="http://schemas.microsoft.com/office/drawing/2014/main" id="{19ECE197-4BB0-49EE-8C0D-B3E32D1BC9F4}"/>
+                <a16:creationId xmlns:a16="http://schemas.microsoft.com/office/drawing/2014/main" id="{0B330261-BDFC-4564-8F94-F7BFBD298E82}"/>
               </a:ext>
             </a:extLst>
           </p:cNvPr>
@@ -20335,7 +20335,7 @@
           <p:cNvPr id="44" name="">
             <a:extLst xmlns:a="http://schemas.openxmlformats.org/drawingml/2006/main">
               <a:ext uri="{FF2B5EF4-FFF2-40B4-BE49-F238E27FC236}">
-                <a16:creationId xmlns:a16="http://schemas.microsoft.com/office/drawing/2014/main" id="{9C3B15F5-CFAE-42FA-9E03-4F60703133E3}"/>
+                <a16:creationId xmlns:a16="http://schemas.microsoft.com/office/drawing/2014/main" id="{327D72A3-F1DE-47AB-8399-06A244FDE3F6}"/>
               </a:ext>
             </a:extLst>
           </p:cNvPr>
@@ -20399,7 +20399,7 @@
           <p:cNvPr id="45" name="">
             <a:extLst xmlns:a="http://schemas.openxmlformats.org/drawingml/2006/main">
               <a:ext uri="{FF2B5EF4-FFF2-40B4-BE49-F238E27FC236}">
-                <a16:creationId xmlns:a16="http://schemas.microsoft.com/office/drawing/2014/main" id="{E0036C54-BF05-4B70-B1B3-EF686F1400FC}"/>
+                <a16:creationId xmlns:a16="http://schemas.microsoft.com/office/drawing/2014/main" id="{F7B1F85D-7041-49F1-863F-22A30541FD30}"/>
               </a:ext>
             </a:extLst>
           </p:cNvPr>
@@ -20463,7 +20463,7 @@
           <p:cNvPr id="46" name="">
             <a:extLst xmlns:a="http://schemas.openxmlformats.org/drawingml/2006/main">
               <a:ext uri="{FF2B5EF4-FFF2-40B4-BE49-F238E27FC236}">
-                <a16:creationId xmlns:a16="http://schemas.microsoft.com/office/drawing/2014/main" id="{4D44150A-5DD4-463A-B05E-1F845E0EC6DE}"/>
+                <a16:creationId xmlns:a16="http://schemas.microsoft.com/office/drawing/2014/main" id="{E425E0DE-67D6-4611-B022-E4B147B7BA61}"/>
               </a:ext>
             </a:extLst>
           </p:cNvPr>
@@ -20527,7 +20527,7 @@
           <p:cNvPr id="47" name="">
             <a:extLst xmlns:a="http://schemas.openxmlformats.org/drawingml/2006/main">
               <a:ext uri="{FF2B5EF4-FFF2-40B4-BE49-F238E27FC236}">
-                <a16:creationId xmlns:a16="http://schemas.microsoft.com/office/drawing/2014/main" id="{13867E41-9483-44C4-9793-CF030F33A5CE}"/>
+                <a16:creationId xmlns:a16="http://schemas.microsoft.com/office/drawing/2014/main" id="{59045DAD-BB86-4FF1-910B-D9976CC97A08}"/>
               </a:ext>
             </a:extLst>
           </p:cNvPr>
@@ -20591,7 +20591,7 @@
           <p:cNvPr id="48" name="">
             <a:extLst xmlns:a="http://schemas.openxmlformats.org/drawingml/2006/main">
               <a:ext uri="{FF2B5EF4-FFF2-40B4-BE49-F238E27FC236}">
-                <a16:creationId xmlns:a16="http://schemas.microsoft.com/office/drawing/2014/main" id="{99D30C5B-0944-46B9-B22B-6DBA5AA5E94D}"/>
+                <a16:creationId xmlns:a16="http://schemas.microsoft.com/office/drawing/2014/main" id="{8AABD1F4-1F9A-481B-94F2-C65347F9AD5A}"/>
               </a:ext>
             </a:extLst>
           </p:cNvPr>
@@ -20655,7 +20655,7 @@
           <p:cNvPr id="49" name="">
             <a:extLst xmlns:a="http://schemas.openxmlformats.org/drawingml/2006/main">
               <a:ext uri="{FF2B5EF4-FFF2-40B4-BE49-F238E27FC236}">
-                <a16:creationId xmlns:a16="http://schemas.microsoft.com/office/drawing/2014/main" id="{E8FA6B4E-AD77-41B5-AE33-E7F987B0D388}"/>
+                <a16:creationId xmlns:a16="http://schemas.microsoft.com/office/drawing/2014/main" id="{C5B746A5-5B8D-402B-847A-A56727BA53D8}"/>
               </a:ext>
             </a:extLst>
           </p:cNvPr>
@@ -20719,7 +20719,7 @@
           <p:cNvPr id="50" name="">
             <a:extLst xmlns:a="http://schemas.openxmlformats.org/drawingml/2006/main">
               <a:ext uri="{FF2B5EF4-FFF2-40B4-BE49-F238E27FC236}">
-                <a16:creationId xmlns:a16="http://schemas.microsoft.com/office/drawing/2014/main" id="{0912DDB3-EFF2-49B7-B372-52A32CE5BAF4}"/>
+                <a16:creationId xmlns:a16="http://schemas.microsoft.com/office/drawing/2014/main" id="{32EB6911-E72A-45A5-A1F1-31D62BD142BE}"/>
               </a:ext>
             </a:extLst>
           </p:cNvPr>
@@ -20754,7 +20754,7 @@
           <p:cNvPr id="51" name="">
             <a:extLst xmlns:a="http://schemas.openxmlformats.org/drawingml/2006/main">
               <a:ext uri="{FF2B5EF4-FFF2-40B4-BE49-F238E27FC236}">
-                <a16:creationId xmlns:a16="http://schemas.microsoft.com/office/drawing/2014/main" id="{B7AFA448-41EF-4E95-8A9D-33F48C473C03}"/>
+                <a16:creationId xmlns:a16="http://schemas.microsoft.com/office/drawing/2014/main" id="{C4A906FC-A2B7-437B-A14E-BA4715392410}"/>
               </a:ext>
             </a:extLst>
           </p:cNvPr>
@@ -20818,7 +20818,7 @@
           <p:cNvPr id="52" name="">
             <a:extLst xmlns:a="http://schemas.openxmlformats.org/drawingml/2006/main">
               <a:ext uri="{FF2B5EF4-FFF2-40B4-BE49-F238E27FC236}">
-                <a16:creationId xmlns:a16="http://schemas.microsoft.com/office/drawing/2014/main" id="{18A312D5-FDF4-4797-967C-ACFED6CA285A}"/>
+                <a16:creationId xmlns:a16="http://schemas.microsoft.com/office/drawing/2014/main" id="{7080102E-8A8A-4FE1-92D8-D87AEF76F8B7}"/>
               </a:ext>
             </a:extLst>
           </p:cNvPr>
@@ -20880,7 +20880,7 @@
     </p:spTree>
     <p:extLst>
       <p:ext uri="{BB962C8B-B14F-4D97-AF65-F5344CB8AC3E}">
-        <p14:creationId xmlns:p14="http://schemas.microsoft.com/office/powerpoint/2010/main" val="2086282552"/>
+        <p14:creationId xmlns:p14="http://schemas.microsoft.com/office/powerpoint/2010/main" val="790851155"/>
       </p:ext>
     </p:extLst>
   </p:cSld>

</xml_diff>